<commit_message>
added testing to the presentation
</commit_message>
<xml_diff>
--- a/docs/عرض المشروع.pptx
+++ b/docs/عرض المشروع.pptx
@@ -5,7 +5,7 @@
     <p:sldMasterId id="2147483648" r:id="rId1"/>
   </p:sldMasterIdLst>
   <p:notesMasterIdLst>
-    <p:notesMasterId r:id="rId17"/>
+    <p:notesMasterId r:id="rId18"/>
   </p:notesMasterIdLst>
   <p:sldIdLst>
     <p:sldId id="256" r:id="rId2"/>
@@ -20,9 +20,10 @@
     <p:sldId id="265" r:id="rId11"/>
     <p:sldId id="266" r:id="rId12"/>
     <p:sldId id="269" r:id="rId13"/>
-    <p:sldId id="270" r:id="rId14"/>
-    <p:sldId id="271" r:id="rId15"/>
-    <p:sldId id="272" r:id="rId16"/>
+    <p:sldId id="273" r:id="rId14"/>
+    <p:sldId id="270" r:id="rId15"/>
+    <p:sldId id="271" r:id="rId16"/>
+    <p:sldId id="272" r:id="rId17"/>
   </p:sldIdLst>
   <p:sldSz cx="12192000" cy="6858000"/>
   <p:notesSz cx="6858000" cy="12192000"/>
@@ -756,7 +757,7 @@
           <a:p>
             <a:r>
               <a:rPr lang="en-US" dirty="0"/>
-              <a:t>النظام اليوم مكتمل الوظائف الأساسية، والبناء عليه ممكن في أربعة اتجاهات: إعادة تدريب النماذج على بيانات محلية حقيقية لرفع دقّتها؛ وتطبيق موبايل يقرّبه من الناس؛ ونشرٌ سحابي يخدم مؤسساتٍ أكثر؛ وربطٌ أعمق بالمنظومة الصحية ليصبح عقدةً في شبكةٍ وطنية.</a:t>
+              <a:t>ويبقى سؤال: هل نثق بأنّ النظام يعمل كما نقول؟ لذلك بنينا منظومة اختباراتٍ آلية تُشغَّل بأمرٍ واحد، وعددها مئتان وخمسة عشر اختباراً تعمل جميعها بنجاح. تغطّي أربعة محاور: الوظائف الأساسية وواجهة النظام البرمجية ومطابقتها للمعيار؛ والصلاحيات، حيث نتأكّد آلياً أنّ المريض لا يصل إلى سجلّ غيره؛ ونماذج الذكاء الاصطناعي التي تُشغَّل فعلياً في الاختبار لا نسخاً وهمية؛ وأخيراً تعدّد المستخدمين والأداء. والأهمّ أنّ هذه الاختبارات أثبتت قدرتها على كشف الخطأ فعلياً: فحين عطّلنا فحصاً أمنياً عمداً على سبيل التجربة، أخفق اختبارا عزل المريض وحدهما دون سواهما — أي أنّها اختباراتٌ ذات قيمةٍ تشخيصية حقيقية لا مجرّد توكيداتٍ شكلية.</a:t>
             </a:r>
           </a:p>
         </p:txBody>
@@ -776,18 +777,78 @@
           <a:bodyPr/>
           <a:lstStyle/>
           <a:p>
+            <a:pPr marL="0" marR="0" lvl="0" indent="0" algn="l" defTabSz="914400" rtl="0" eaLnBrk="1" fontAlgn="auto" latinLnBrk="0" hangingPunct="1">
+              <a:lnSpc>
+                <a:spcPct val="100000"/>
+              </a:lnSpc>
+              <a:spcBef>
+                <a:spcPts val="0"/>
+              </a:spcBef>
+              <a:spcAft>
+                <a:spcPts val="0"/>
+              </a:spcAft>
+              <a:buClrTx/>
+              <a:buSzTx/>
+              <a:buFontTx/>
+              <a:buNone/>
+              <a:tabLst/>
+              <a:defRPr/>
+            </a:pPr>
             <a:fld id="{F7021451-1387-4CA6-816F-3879F97B5CBC}" type="slidenum">
-              <a:rPr lang="en-US"/>
+              <a:rPr kumimoji="0" lang="en-US" sz="1800" b="0" i="0" u="none" strike="noStrike" kern="1200" cap="none" spc="0" normalizeH="0" baseline="0" noProof="0">
+                <a:ln>
+                  <a:noFill/>
+                </a:ln>
+                <a:solidFill>
+                  <a:prstClr val="black"/>
+                </a:solidFill>
+                <a:effectLst/>
+                <a:uLnTx/>
+                <a:uFillTx/>
+                <a:latin typeface="Aptos" panose="02110004020202020204"/>
+                <a:ea typeface="+mn-ea"/>
+                <a:cs typeface="+mn-cs"/>
+              </a:rPr>
+              <a:pPr marL="0" marR="0" lvl="0" indent="0" algn="l" defTabSz="914400" rtl="0" eaLnBrk="1" fontAlgn="auto" latinLnBrk="0" hangingPunct="1">
+                <a:lnSpc>
+                  <a:spcPct val="100000"/>
+                </a:lnSpc>
+                <a:spcBef>
+                  <a:spcPts val="0"/>
+                </a:spcBef>
+                <a:spcAft>
+                  <a:spcPts val="0"/>
+                </a:spcAft>
+                <a:buClrTx/>
+                <a:buSzTx/>
+                <a:buFontTx/>
+                <a:buNone/>
+                <a:tabLst/>
+                <a:defRPr/>
+              </a:pPr>
               <a:t>13</a:t>
             </a:fld>
-            <a:endParaRPr lang="en-US"/>
+            <a:endParaRPr kumimoji="0" lang="en-US" sz="1800" b="0" i="0" u="none" strike="noStrike" kern="1200" cap="none" spc="0" normalizeH="0" baseline="0" noProof="0">
+              <a:ln>
+                <a:noFill/>
+              </a:ln>
+              <a:solidFill>
+                <a:prstClr val="black"/>
+              </a:solidFill>
+              <a:effectLst/>
+              <a:uLnTx/>
+              <a:uFillTx/>
+              <a:latin typeface="Aptos" panose="02110004020202020204"/>
+              <a:ea typeface="+mn-ea"/>
+              <a:cs typeface="+mn-cs"/>
+            </a:endParaRPr>
           </a:p>
         </p:txBody>
       </p:sp>
     </p:spTree>
     <p:extLst>
       <p:ext uri="{BB962C8B-B14F-4D97-AF65-F5344CB8AC3E}">
-        <p14:creationId xmlns:p14="http://schemas.microsoft.com/office/powerpoint/2010/main" val="1024086991"/>
+        <p14:creationId xmlns:p14="http://schemas.microsoft.com/office/powerpoint/2010/main" val="1632589195"/>
       </p:ext>
     </p:extLst>
   </p:cSld>
@@ -843,7 +904,7 @@
           <a:p>
             <a:r>
               <a:rPr lang="en-US" dirty="0"/>
-              <a:t>بدأنا من مشكلةٍ يعيشها كلّ مريض، وانتهينا إلى منصّةٍ تجمع الملف وتفهمه وتتصرّف: ملفٌ موحّد بلغةٍ عالمية، ومساعدٌ يقظ للطبيب، وذكاءٌ يتوقّع الخطر، وبابٌ آمن للمريض. ومن ملفٍّ مبعثر… إلى رعايةٍ تسبق المرض.</a:t>
+              <a:t>النظام اليوم مكتمل الوظائف الأساسية، والبناء عليه ممكن في أربعة اتجاهات: إعادة تدريب النماذج على بيانات محلية حقيقية لرفع دقّتها؛ وتطبيق موبايل يقرّبه من الناس؛ ونشرٌ سحابي يخدم مؤسساتٍ أكثر؛ وربطٌ أعمق بالمنظومة الصحية ليصبح عقدةً في شبكةٍ وطنية.</a:t>
             </a:r>
           </a:p>
         </p:txBody>
@@ -930,7 +991,7 @@
           <a:p>
             <a:r>
               <a:rPr lang="en-US" dirty="0"/>
-              <a:t>شكراً لحسن إصغائكم، ونسعد الآن بالإجابة عن أسئلتكم. وسنعرض بعد ذلك التسجيل العملي للنظام.</a:t>
+              <a:t>بدأنا من مشكلةٍ يعيشها كلّ مريض، وانتهينا إلى منصّةٍ تجمع الملف وتفهمه وتتصرّف: ملفٌ موحّد بلغةٍ عالمية، ومساعدٌ يقظ للطبيب، وذكاءٌ يتوقّع الخطر، وبابٌ آمن للمريض. ومن ملفٍّ مبعثر… إلى رعايةٍ تسبق المرض.</a:t>
             </a:r>
           </a:p>
         </p:txBody>
@@ -953,6 +1014,93 @@
             <a:fld id="{F7021451-1387-4CA6-816F-3879F97B5CBC}" type="slidenum">
               <a:rPr lang="en-US"/>
               <a:t>15</a:t>
+            </a:fld>
+            <a:endParaRPr lang="en-US"/>
+          </a:p>
+        </p:txBody>
+      </p:sp>
+    </p:spTree>
+    <p:extLst>
+      <p:ext uri="{BB962C8B-B14F-4D97-AF65-F5344CB8AC3E}">
+        <p14:creationId xmlns:p14="http://schemas.microsoft.com/office/powerpoint/2010/main" val="1024086991"/>
+      </p:ext>
+    </p:extLst>
+  </p:cSld>
+  <p:clrMapOvr>
+    <a:masterClrMapping/>
+  </p:clrMapOvr>
+</p:notes>
+</file>
+
+<file path=ppt/notesSlides/notesSlide16.xml><?xml version="1.0" encoding="utf-8"?>
+<p:notes xmlns:a="http://schemas.openxmlformats.org/drawingml/2006/main" xmlns:r="http://schemas.openxmlformats.org/officeDocument/2006/relationships" xmlns:p="http://schemas.openxmlformats.org/presentationml/2006/main">
+  <p:cSld>
+    <p:spTree>
+      <p:nvGrpSpPr>
+        <p:cNvPr id="1" name=""/>
+        <p:cNvGrpSpPr/>
+        <p:nvPr/>
+      </p:nvGrpSpPr>
+      <p:grpSpPr>
+        <a:xfrm>
+          <a:off x="0" y="0"/>
+          <a:ext cx="0" cy="0"/>
+          <a:chOff x="0" y="0"/>
+          <a:chExt cx="0" cy="0"/>
+        </a:xfrm>
+      </p:grpSpPr>
+      <p:sp>
+        <p:nvSpPr>
+          <p:cNvPr id="2" name="Slide Image Placeholder 1"/>
+          <p:cNvSpPr>
+            <a:spLocks noGrp="1" noRot="1" noChangeAspect="1"/>
+          </p:cNvSpPr>
+          <p:nvPr>
+            <p:ph type="sldImg"/>
+          </p:nvPr>
+        </p:nvSpPr>
+        <p:spPr/>
+      </p:sp>
+      <p:sp>
+        <p:nvSpPr>
+          <p:cNvPr id="3" name="Notes Placeholder 2"/>
+          <p:cNvSpPr>
+            <a:spLocks noGrp="1"/>
+          </p:cNvSpPr>
+          <p:nvPr>
+            <p:ph type="body" idx="1"/>
+          </p:nvPr>
+        </p:nvSpPr>
+        <p:spPr/>
+        <p:txBody>
+          <a:bodyPr/>
+          <a:lstStyle/>
+          <a:p>
+            <a:r>
+              <a:rPr lang="en-US" dirty="0"/>
+              <a:t>شكراً لحسن إصغائكم، ونسعد الآن بالإجابة عن أسئلتكم. وسنعرض بعد ذلك التسجيل العملي للنظام.</a:t>
+            </a:r>
+          </a:p>
+        </p:txBody>
+      </p:sp>
+      <p:sp>
+        <p:nvSpPr>
+          <p:cNvPr id="4" name="Slide Number Placeholder 3"/>
+          <p:cNvSpPr>
+            <a:spLocks noGrp="1"/>
+          </p:cNvSpPr>
+          <p:nvPr>
+            <p:ph type="sldNum" sz="quarter" idx="10"/>
+          </p:nvPr>
+        </p:nvSpPr>
+        <p:spPr/>
+        <p:txBody>
+          <a:bodyPr/>
+          <a:lstStyle/>
+          <a:p>
+            <a:fld id="{F7021451-1387-4CA6-816F-3879F97B5CBC}" type="slidenum">
+              <a:rPr lang="en-US"/>
+              <a:t>16</a:t>
             </a:fld>
             <a:endParaRPr lang="en-US"/>
           </a:p>
@@ -5116,6 +5264,1275 @@
 
 <file path=ppt/slides/slide13.xml><?xml version="1.0" encoding="utf-8"?>
 <p:sld xmlns:a="http://schemas.openxmlformats.org/drawingml/2006/main" xmlns:r="http://schemas.openxmlformats.org/officeDocument/2006/relationships" xmlns:p="http://schemas.openxmlformats.org/presentationml/2006/main">
+  <p:cSld>
+    <p:spTree>
+      <p:nvGrpSpPr>
+        <p:cNvPr id="1" name=""/>
+        <p:cNvGrpSpPr/>
+        <p:nvPr/>
+      </p:nvGrpSpPr>
+      <p:grpSpPr>
+        <a:xfrm>
+          <a:off x="0" y="0"/>
+          <a:ext cx="0" cy="0"/>
+          <a:chOff x="0" y="0"/>
+          <a:chExt cx="0" cy="0"/>
+        </a:xfrm>
+      </p:grpSpPr>
+      <p:sp>
+        <p:nvSpPr>
+          <p:cNvPr id="2" name="Text 0"/>
+          <p:cNvSpPr/>
+          <p:nvPr/>
+        </p:nvSpPr>
+        <p:spPr>
+          <a:xfrm>
+            <a:off x="7436815" y="6473952"/>
+            <a:ext cx="4206240" cy="274320"/>
+          </a:xfrm>
+          <a:prstGeom prst="rect">
+            <a:avLst/>
+          </a:prstGeom>
+          <a:noFill/>
+          <a:ln/>
+        </p:spPr>
+        <p:txBody>
+          <a:bodyPr wrap="square" lIns="0" tIns="0" rIns="0" bIns="0" rtlCol="0" anchor="ctr"/>
+          <a:lstStyle/>
+          <a:p>
+            <a:pPr marL="0" marR="0" lvl="0" indent="0" algn="r" defTabSz="914400" rtl="1" eaLnBrk="1" fontAlgn="auto" latinLnBrk="0" hangingPunct="1">
+              <a:lnSpc>
+                <a:spcPct val="100000"/>
+              </a:lnSpc>
+              <a:spcBef>
+                <a:spcPts val="0"/>
+              </a:spcBef>
+              <a:spcAft>
+                <a:spcPts val="0"/>
+              </a:spcAft>
+              <a:buClrTx/>
+              <a:buSzTx/>
+              <a:buFontTx/>
+              <a:buNone/>
+              <a:tabLst/>
+              <a:defRPr/>
+            </a:pPr>
+            <a:r>
+              <a:rPr kumimoji="0" lang="ar-SA" altLang="en-US" sz="900" b="0" i="0" u="none" strike="noStrike" kern="1200" cap="none" spc="0" normalizeH="0" baseline="0" noProof="0" dirty="0">
+                <a:ln>
+                  <a:noFill/>
+                </a:ln>
+                <a:solidFill>
+                  <a:srgbClr val="587078"/>
+                </a:solidFill>
+                <a:effectLst/>
+                <a:uLnTx/>
+                <a:uFillTx/>
+                <a:latin typeface="Dubai" panose="020B0503030403030204" pitchFamily="34" charset="-78"/>
+                <a:ea typeface="Arial" pitchFamily="34" charset="-122"/>
+                <a:cs typeface="Dubai" panose="020B0503030403030204" pitchFamily="34" charset="-78"/>
+              </a:rPr>
+              <a:t>نبض — نظام السجلات الطبية الرقمية</a:t>
+            </a:r>
+            <a:endParaRPr kumimoji="0" lang="ar-SA" sz="900" b="0" i="0" u="none" strike="noStrike" kern="1200" cap="none" spc="0" normalizeH="0" baseline="0" noProof="0" dirty="0">
+              <a:ln>
+                <a:noFill/>
+              </a:ln>
+              <a:solidFill>
+                <a:prstClr val="black"/>
+              </a:solidFill>
+              <a:effectLst/>
+              <a:uLnTx/>
+              <a:uFillTx/>
+              <a:latin typeface="Dubai" panose="020B0503030403030204" pitchFamily="34" charset="-78"/>
+              <a:cs typeface="Dubai" panose="020B0503030403030204" pitchFamily="34" charset="-78"/>
+            </a:endParaRPr>
+          </a:p>
+        </p:txBody>
+      </p:sp>
+      <p:sp>
+        <p:nvSpPr>
+          <p:cNvPr id="3" name="Text 1"/>
+          <p:cNvSpPr/>
+          <p:nvPr/>
+        </p:nvSpPr>
+        <p:spPr>
+          <a:xfrm>
+            <a:off x="548640" y="6473952"/>
+            <a:ext cx="548640" cy="274320"/>
+          </a:xfrm>
+          <a:prstGeom prst="rect">
+            <a:avLst/>
+          </a:prstGeom>
+          <a:noFill/>
+          <a:ln/>
+        </p:spPr>
+        <p:txBody>
+          <a:bodyPr wrap="square" lIns="0" tIns="0" rIns="0" bIns="0" rtlCol="0" anchor="ctr"/>
+          <a:lstStyle/>
+          <a:p>
+            <a:pPr marL="0" marR="0" lvl="0" indent="0" algn="l" defTabSz="914400" rtl="0" eaLnBrk="1" fontAlgn="auto" latinLnBrk="0" hangingPunct="1">
+              <a:lnSpc>
+                <a:spcPct val="100000"/>
+              </a:lnSpc>
+              <a:spcBef>
+                <a:spcPts val="0"/>
+              </a:spcBef>
+              <a:spcAft>
+                <a:spcPts val="0"/>
+              </a:spcAft>
+              <a:buClrTx/>
+              <a:buSzTx/>
+              <a:buFontTx/>
+              <a:buNone/>
+              <a:tabLst/>
+              <a:defRPr/>
+            </a:pPr>
+            <a:r>
+              <a:rPr kumimoji="0" lang="en-US" sz="900" b="0" i="0" u="none" strike="noStrike" kern="1200" cap="none" spc="0" normalizeH="0" baseline="0" noProof="0" dirty="0">
+                <a:ln>
+                  <a:noFill/>
+                </a:ln>
+                <a:solidFill>
+                  <a:srgbClr val="587078"/>
+                </a:solidFill>
+                <a:effectLst/>
+                <a:uLnTx/>
+                <a:uFillTx/>
+                <a:latin typeface="Arial" pitchFamily="34" charset="0"/>
+                <a:ea typeface="Arial" pitchFamily="34" charset="-122"/>
+                <a:cs typeface="Arial" pitchFamily="34" charset="-120"/>
+              </a:rPr>
+              <a:t>13</a:t>
+            </a:r>
+            <a:endParaRPr kumimoji="0" lang="en-US" sz="900" b="0" i="0" u="none" strike="noStrike" kern="1200" cap="none" spc="0" normalizeH="0" baseline="0" noProof="0" dirty="0">
+              <a:ln>
+                <a:noFill/>
+              </a:ln>
+              <a:solidFill>
+                <a:prstClr val="black"/>
+              </a:solidFill>
+              <a:effectLst/>
+              <a:uLnTx/>
+              <a:uFillTx/>
+              <a:latin typeface="Arial"/>
+              <a:ea typeface="+mn-ea"/>
+              <a:cs typeface="+mn-cs"/>
+            </a:endParaRPr>
+          </a:p>
+        </p:txBody>
+      </p:sp>
+      <p:sp>
+        <p:nvSpPr>
+          <p:cNvPr id="4" name="Text 2"/>
+          <p:cNvSpPr/>
+          <p:nvPr/>
+        </p:nvSpPr>
+        <p:spPr>
+          <a:xfrm>
+            <a:off x="548640" y="292608"/>
+            <a:ext cx="11094415" cy="566928"/>
+          </a:xfrm>
+          <a:prstGeom prst="rect">
+            <a:avLst/>
+          </a:prstGeom>
+          <a:noFill/>
+          <a:ln/>
+        </p:spPr>
+        <p:txBody>
+          <a:bodyPr wrap="square" lIns="0" tIns="0" rIns="0" bIns="0" rtlCol="0" anchor="ctr"/>
+          <a:lstStyle/>
+          <a:p>
+            <a:pPr marL="0" marR="0" lvl="0" indent="0" algn="r" defTabSz="914400" rtl="1" eaLnBrk="1" fontAlgn="auto" latinLnBrk="0" hangingPunct="1">
+              <a:lnSpc>
+                <a:spcPct val="100000"/>
+              </a:lnSpc>
+              <a:spcBef>
+                <a:spcPts val="0"/>
+              </a:spcBef>
+              <a:spcAft>
+                <a:spcPts val="0"/>
+              </a:spcAft>
+              <a:buClrTx/>
+              <a:buSzTx/>
+              <a:buFontTx/>
+              <a:buNone/>
+              <a:tabLst/>
+              <a:defRPr/>
+            </a:pPr>
+            <a:r>
+              <a:rPr kumimoji="0" lang="ar-SA" altLang="en-US" sz="2900" b="1" i="0" u="none" strike="noStrike" kern="1200" cap="none" spc="0" normalizeH="0" baseline="0" noProof="0" dirty="0">
+                <a:ln>
+                  <a:noFill/>
+                </a:ln>
+                <a:solidFill>
+                  <a:srgbClr val="0A3540"/>
+                </a:solidFill>
+                <a:effectLst/>
+                <a:uLnTx/>
+                <a:uFillTx/>
+                <a:latin typeface="Dubai" panose="020B0503030403030204" pitchFamily="34" charset="-78"/>
+                <a:ea typeface="Arial" pitchFamily="34" charset="-122"/>
+                <a:cs typeface="Dubai" panose="020B0503030403030204" pitchFamily="34" charset="-78"/>
+              </a:rPr>
+              <a:t>هل نثق بأنّ النظام يعمل؟</a:t>
+            </a:r>
+            <a:endParaRPr kumimoji="0" lang="ar-SA" sz="2900" b="0" i="0" u="none" strike="noStrike" kern="1200" cap="none" spc="0" normalizeH="0" baseline="0" noProof="0" dirty="0">
+              <a:ln>
+                <a:noFill/>
+              </a:ln>
+              <a:solidFill>
+                <a:prstClr val="black"/>
+              </a:solidFill>
+              <a:effectLst/>
+              <a:uLnTx/>
+              <a:uFillTx/>
+              <a:latin typeface="Dubai" panose="020B0503030403030204" pitchFamily="34" charset="-78"/>
+              <a:cs typeface="Dubai" panose="020B0503030403030204" pitchFamily="34" charset="-78"/>
+            </a:endParaRPr>
+          </a:p>
+        </p:txBody>
+      </p:sp>
+      <p:sp>
+        <p:nvSpPr>
+          <p:cNvPr id="5" name="Text 3"/>
+          <p:cNvSpPr/>
+          <p:nvPr/>
+        </p:nvSpPr>
+        <p:spPr>
+          <a:xfrm>
+            <a:off x="548640" y="859536"/>
+            <a:ext cx="11094415" cy="347472"/>
+          </a:xfrm>
+          <a:prstGeom prst="rect">
+            <a:avLst/>
+          </a:prstGeom>
+          <a:noFill/>
+          <a:ln/>
+        </p:spPr>
+        <p:txBody>
+          <a:bodyPr wrap="square" lIns="0" tIns="0" rIns="0" bIns="0" rtlCol="0" anchor="ctr"/>
+          <a:lstStyle/>
+          <a:p>
+            <a:pPr marL="0" marR="0" lvl="0" indent="0" algn="r" defTabSz="914400" rtl="1" eaLnBrk="1" fontAlgn="auto" latinLnBrk="0" hangingPunct="1">
+              <a:lnSpc>
+                <a:spcPct val="100000"/>
+              </a:lnSpc>
+              <a:spcBef>
+                <a:spcPts val="0"/>
+              </a:spcBef>
+              <a:spcAft>
+                <a:spcPts val="0"/>
+              </a:spcAft>
+              <a:buClrTx/>
+              <a:buSzTx/>
+              <a:buFontTx/>
+              <a:buNone/>
+              <a:tabLst/>
+              <a:defRPr/>
+            </a:pPr>
+            <a:r>
+              <a:rPr kumimoji="0" lang="ar-SA" altLang="en-US" sz="1400" b="0" i="0" u="none" strike="noStrike" kern="1200" cap="none" spc="0" normalizeH="0" baseline="0" noProof="0" dirty="0">
+                <a:ln>
+                  <a:noFill/>
+                </a:ln>
+                <a:solidFill>
+                  <a:srgbClr val="0E7C86"/>
+                </a:solidFill>
+                <a:effectLst/>
+                <a:uLnTx/>
+                <a:uFillTx/>
+                <a:latin typeface="Dubai" panose="020B0503030403030204" pitchFamily="34" charset="-78"/>
+                <a:ea typeface="Arial" pitchFamily="34" charset="-122"/>
+                <a:cs typeface="Dubai" panose="020B0503030403030204" pitchFamily="34" charset="-78"/>
+              </a:rPr>
+              <a:t>منظومة اختباراتٍ آلية تُشغَّل بأمرٍ واحد وتفحص النظام كلّه</a:t>
+            </a:r>
+            <a:endParaRPr kumimoji="0" lang="ar-SA" sz="1400" b="0" i="0" u="none" strike="noStrike" kern="1200" cap="none" spc="0" normalizeH="0" baseline="0" noProof="0" dirty="0">
+              <a:ln>
+                <a:noFill/>
+              </a:ln>
+              <a:solidFill>
+                <a:prstClr val="black"/>
+              </a:solidFill>
+              <a:effectLst/>
+              <a:uLnTx/>
+              <a:uFillTx/>
+              <a:latin typeface="Dubai" panose="020B0503030403030204" pitchFamily="34" charset="-78"/>
+              <a:cs typeface="Dubai" panose="020B0503030403030204" pitchFamily="34" charset="-78"/>
+            </a:endParaRPr>
+          </a:p>
+        </p:txBody>
+      </p:sp>
+      <p:sp>
+        <p:nvSpPr>
+          <p:cNvPr id="6" name="Shape 4"/>
+          <p:cNvSpPr/>
+          <p:nvPr/>
+        </p:nvSpPr>
+        <p:spPr>
+          <a:xfrm>
+            <a:off x="548640" y="1572768"/>
+            <a:ext cx="11094415" cy="786384"/>
+          </a:xfrm>
+          <a:prstGeom prst="roundRect">
+            <a:avLst>
+              <a:gd name="adj" fmla="val 9302"/>
+            </a:avLst>
+          </a:prstGeom>
+          <a:solidFill>
+            <a:srgbClr val="0A3540"/>
+          </a:solidFill>
+          <a:ln/>
+        </p:spPr>
+      </p:sp>
+      <p:sp>
+        <p:nvSpPr>
+          <p:cNvPr id="7" name="Text 5"/>
+          <p:cNvSpPr/>
+          <p:nvPr/>
+        </p:nvSpPr>
+        <p:spPr>
+          <a:xfrm>
+            <a:off x="868680" y="1572768"/>
+            <a:ext cx="10454335" cy="786384"/>
+          </a:xfrm>
+          <a:prstGeom prst="rect">
+            <a:avLst/>
+          </a:prstGeom>
+          <a:noFill/>
+          <a:ln/>
+        </p:spPr>
+        <p:txBody>
+          <a:bodyPr wrap="square" lIns="0" tIns="0" rIns="0" bIns="0" rtlCol="0" anchor="ctr"/>
+          <a:lstStyle/>
+          <a:p>
+            <a:pPr marL="0" marR="0" lvl="0" indent="0" algn="r" defTabSz="914400" rtl="1" eaLnBrk="1" fontAlgn="auto" latinLnBrk="0" hangingPunct="1">
+              <a:lnSpc>
+                <a:spcPct val="100000"/>
+              </a:lnSpc>
+              <a:spcBef>
+                <a:spcPts val="0"/>
+              </a:spcBef>
+              <a:spcAft>
+                <a:spcPts val="0"/>
+              </a:spcAft>
+              <a:buClrTx/>
+              <a:buSzTx/>
+              <a:buFontTx/>
+              <a:buNone/>
+              <a:tabLst/>
+              <a:defRPr/>
+            </a:pPr>
+            <a:r>
+              <a:rPr kumimoji="0" lang="ar-SA" altLang="en-US" sz="2000" b="1" i="0" u="none" strike="noStrike" kern="1200" cap="none" spc="0" normalizeH="0" baseline="0" noProof="0" dirty="0">
+                <a:ln>
+                  <a:noFill/>
+                </a:ln>
+                <a:solidFill>
+                  <a:srgbClr val="FFFFFF"/>
+                </a:solidFill>
+                <a:effectLst/>
+                <a:uLnTx/>
+                <a:uFillTx/>
+                <a:latin typeface="Dubai" panose="020B0503030403030204" pitchFamily="34" charset="-78"/>
+                <a:ea typeface="Arial" pitchFamily="34" charset="-122"/>
+                <a:cs typeface="Dubai" panose="020B0503030403030204" pitchFamily="34" charset="-78"/>
+              </a:rPr>
+              <a:t>٢١٥ اختباراً آلياً — جميعها ناجحة</a:t>
+            </a:r>
+            <a:endParaRPr kumimoji="0" lang="ar-SA" sz="2000" b="0" i="0" u="none" strike="noStrike" kern="1200" cap="none" spc="0" normalizeH="0" baseline="0" noProof="0" dirty="0">
+              <a:ln>
+                <a:noFill/>
+              </a:ln>
+              <a:solidFill>
+                <a:prstClr val="black"/>
+              </a:solidFill>
+              <a:effectLst/>
+              <a:uLnTx/>
+              <a:uFillTx/>
+              <a:latin typeface="Dubai" panose="020B0503030403030204" pitchFamily="34" charset="-78"/>
+              <a:cs typeface="Dubai" panose="020B0503030403030204" pitchFamily="34" charset="-78"/>
+            </a:endParaRPr>
+          </a:p>
+        </p:txBody>
+      </p:sp>
+      <p:sp>
+        <p:nvSpPr>
+          <p:cNvPr id="8" name="Shape 6"/>
+          <p:cNvSpPr/>
+          <p:nvPr/>
+        </p:nvSpPr>
+        <p:spPr>
+          <a:xfrm>
+            <a:off x="6193231" y="2542032"/>
+            <a:ext cx="5449824" cy="1591056"/>
+          </a:xfrm>
+          <a:prstGeom prst="roundRect">
+            <a:avLst>
+              <a:gd name="adj" fmla="val 4598"/>
+            </a:avLst>
+          </a:prstGeom>
+          <a:solidFill>
+            <a:srgbClr val="F2F8F8"/>
+          </a:solidFill>
+          <a:ln w="9525">
+            <a:solidFill>
+              <a:srgbClr val="D9E7E9"/>
+            </a:solidFill>
+            <a:prstDash val="solid"/>
+          </a:ln>
+        </p:spPr>
+      </p:sp>
+      <p:sp>
+        <p:nvSpPr>
+          <p:cNvPr id="9" name="Shape 7"/>
+          <p:cNvSpPr/>
+          <p:nvPr/>
+        </p:nvSpPr>
+        <p:spPr>
+          <a:xfrm>
+            <a:off x="10984687" y="2743200"/>
+            <a:ext cx="402336" cy="402336"/>
+          </a:xfrm>
+          <a:prstGeom prst="ellipse">
+            <a:avLst/>
+          </a:prstGeom>
+          <a:solidFill>
+            <a:srgbClr val="0E7C86"/>
+          </a:solidFill>
+          <a:ln/>
+        </p:spPr>
+      </p:sp>
+      <p:sp>
+        <p:nvSpPr>
+          <p:cNvPr id="10" name="Text 8"/>
+          <p:cNvSpPr/>
+          <p:nvPr/>
+        </p:nvSpPr>
+        <p:spPr>
+          <a:xfrm>
+            <a:off x="6467551" y="2761488"/>
+            <a:ext cx="4352544" cy="457200"/>
+          </a:xfrm>
+          <a:prstGeom prst="rect">
+            <a:avLst/>
+          </a:prstGeom>
+          <a:noFill/>
+          <a:ln/>
+        </p:spPr>
+        <p:txBody>
+          <a:bodyPr wrap="square" lIns="0" tIns="0" rIns="0" bIns="0" rtlCol="0" anchor="ctr"/>
+          <a:lstStyle/>
+          <a:p>
+            <a:pPr marL="0" marR="0" lvl="0" indent="0" algn="r" defTabSz="914400" rtl="1" eaLnBrk="1" fontAlgn="auto" latinLnBrk="0" hangingPunct="1">
+              <a:lnSpc>
+                <a:spcPct val="100000"/>
+              </a:lnSpc>
+              <a:spcBef>
+                <a:spcPts val="0"/>
+              </a:spcBef>
+              <a:spcAft>
+                <a:spcPts val="0"/>
+              </a:spcAft>
+              <a:buClrTx/>
+              <a:buSzTx/>
+              <a:buFontTx/>
+              <a:buNone/>
+              <a:tabLst/>
+              <a:defRPr/>
+            </a:pPr>
+            <a:r>
+              <a:rPr kumimoji="0" lang="ar-SA" altLang="en-US" b="1" i="0" u="none" strike="noStrike" kern="1200" cap="none" spc="0" normalizeH="0" baseline="0" noProof="0" dirty="0">
+                <a:ln>
+                  <a:noFill/>
+                </a:ln>
+                <a:solidFill>
+                  <a:srgbClr val="0A3540"/>
+                </a:solidFill>
+                <a:effectLst/>
+                <a:uLnTx/>
+                <a:uFillTx/>
+                <a:latin typeface="Dubai" panose="020B0503030403030204" pitchFamily="34" charset="-78"/>
+                <a:ea typeface="Arial" pitchFamily="34" charset="-122"/>
+                <a:cs typeface="Dubai" panose="020B0503030403030204" pitchFamily="34" charset="-78"/>
+              </a:rPr>
+              <a:t>الوظائف والواجهة البرمجية</a:t>
+            </a:r>
+            <a:endParaRPr kumimoji="0" lang="ar-SA" b="0" i="0" u="none" strike="noStrike" kern="1200" cap="none" spc="0" normalizeH="0" baseline="0" noProof="0" dirty="0">
+              <a:ln>
+                <a:noFill/>
+              </a:ln>
+              <a:solidFill>
+                <a:prstClr val="black"/>
+              </a:solidFill>
+              <a:effectLst/>
+              <a:uLnTx/>
+              <a:uFillTx/>
+              <a:latin typeface="Dubai" panose="020B0503030403030204" pitchFamily="34" charset="-78"/>
+              <a:cs typeface="Dubai" panose="020B0503030403030204" pitchFamily="34" charset="-78"/>
+            </a:endParaRPr>
+          </a:p>
+        </p:txBody>
+      </p:sp>
+      <p:sp>
+        <p:nvSpPr>
+          <p:cNvPr id="11" name="Text 9"/>
+          <p:cNvSpPr/>
+          <p:nvPr/>
+        </p:nvSpPr>
+        <p:spPr>
+          <a:xfrm>
+            <a:off x="6467551" y="3291840"/>
+            <a:ext cx="4901184" cy="676656"/>
+          </a:xfrm>
+          <a:prstGeom prst="rect">
+            <a:avLst/>
+          </a:prstGeom>
+          <a:noFill/>
+          <a:ln/>
+        </p:spPr>
+        <p:txBody>
+          <a:bodyPr wrap="square" lIns="0" tIns="0" rIns="0" bIns="0" rtlCol="0" anchor="t"/>
+          <a:lstStyle/>
+          <a:p>
+            <a:pPr marL="0" marR="0" lvl="0" indent="0" algn="r" defTabSz="914400" rtl="1" eaLnBrk="1" fontAlgn="auto" latinLnBrk="0" hangingPunct="1">
+              <a:lnSpc>
+                <a:spcPct val="130000"/>
+              </a:lnSpc>
+              <a:spcBef>
+                <a:spcPts val="0"/>
+              </a:spcBef>
+              <a:spcAft>
+                <a:spcPts val="0"/>
+              </a:spcAft>
+              <a:buClrTx/>
+              <a:buSzTx/>
+              <a:buFontTx/>
+              <a:buNone/>
+              <a:tabLst/>
+              <a:defRPr/>
+            </a:pPr>
+            <a:r>
+              <a:rPr kumimoji="0" lang="ar-SA" altLang="en-US" sz="1600" b="0" i="0" u="none" strike="noStrike" kern="1200" cap="none" spc="0" normalizeH="0" baseline="0" noProof="0" dirty="0">
+                <a:ln>
+                  <a:noFill/>
+                </a:ln>
+                <a:solidFill>
+                  <a:srgbClr val="587078"/>
+                </a:solidFill>
+                <a:effectLst/>
+                <a:uLnTx/>
+                <a:uFillTx/>
+                <a:latin typeface="Dubai" panose="020B0503030403030204" pitchFamily="34" charset="-78"/>
+                <a:ea typeface="Arial" pitchFamily="34" charset="-122"/>
+                <a:cs typeface="Dubai" panose="020B0503030403030204" pitchFamily="34" charset="-78"/>
+              </a:rPr>
+              <a:t>دورة حياة السجل كاملةً: إنشاء وتعديل وحفظ النسخ وحذف وبحث — ومطابقة الواجهة لمعيار ‏</a:t>
+            </a:r>
+            <a:r>
+              <a:rPr kumimoji="0" lang="en-US" altLang="en-US" sz="1600" b="0" i="0" u="none" strike="noStrike" kern="1200" cap="none" spc="0" normalizeH="0" baseline="0" noProof="0" dirty="0">
+                <a:ln>
+                  <a:noFill/>
+                </a:ln>
+                <a:solidFill>
+                  <a:srgbClr val="587078"/>
+                </a:solidFill>
+                <a:effectLst/>
+                <a:uLnTx/>
+                <a:uFillTx/>
+                <a:latin typeface="Dubai" panose="020B0503030403030204" pitchFamily="34" charset="-78"/>
+                <a:ea typeface="Arial" pitchFamily="34" charset="-122"/>
+                <a:cs typeface="Dubai" panose="020B0503030403030204" pitchFamily="34" charset="-78"/>
+              </a:rPr>
+              <a:t>FHIR</a:t>
+            </a:r>
+            <a:r>
+              <a:rPr kumimoji="0" lang="ar-SA" altLang="en-US" sz="1600" b="0" i="0" u="none" strike="noStrike" kern="1200" cap="none" spc="0" normalizeH="0" baseline="0" noProof="0" dirty="0">
+                <a:ln>
+                  <a:noFill/>
+                </a:ln>
+                <a:solidFill>
+                  <a:srgbClr val="587078"/>
+                </a:solidFill>
+                <a:effectLst/>
+                <a:uLnTx/>
+                <a:uFillTx/>
+                <a:latin typeface="Dubai" panose="020B0503030403030204" pitchFamily="34" charset="-78"/>
+                <a:ea typeface="Arial" pitchFamily="34" charset="-122"/>
+                <a:cs typeface="Dubai" panose="020B0503030403030204" pitchFamily="34" charset="-78"/>
+              </a:rPr>
+              <a:t>‏.</a:t>
+            </a:r>
+            <a:endParaRPr kumimoji="0" lang="ar-SA" sz="1600" b="0" i="0" u="none" strike="noStrike" kern="1200" cap="none" spc="0" normalizeH="0" baseline="0" noProof="0" dirty="0">
+              <a:ln>
+                <a:noFill/>
+              </a:ln>
+              <a:solidFill>
+                <a:prstClr val="black"/>
+              </a:solidFill>
+              <a:effectLst/>
+              <a:uLnTx/>
+              <a:uFillTx/>
+              <a:latin typeface="Dubai" panose="020B0503030403030204" pitchFamily="34" charset="-78"/>
+              <a:cs typeface="Dubai" panose="020B0503030403030204" pitchFamily="34" charset="-78"/>
+            </a:endParaRPr>
+          </a:p>
+        </p:txBody>
+      </p:sp>
+      <p:sp>
+        <p:nvSpPr>
+          <p:cNvPr id="12" name="Shape 10"/>
+          <p:cNvSpPr/>
+          <p:nvPr/>
+        </p:nvSpPr>
+        <p:spPr>
+          <a:xfrm>
+            <a:off x="551383" y="2542032"/>
+            <a:ext cx="5449824" cy="1591056"/>
+          </a:xfrm>
+          <a:prstGeom prst="roundRect">
+            <a:avLst>
+              <a:gd name="adj" fmla="val 4598"/>
+            </a:avLst>
+          </a:prstGeom>
+          <a:solidFill>
+            <a:srgbClr val="F2F8F8"/>
+          </a:solidFill>
+          <a:ln w="9525">
+            <a:solidFill>
+              <a:srgbClr val="D9E7E9"/>
+            </a:solidFill>
+            <a:prstDash val="solid"/>
+          </a:ln>
+        </p:spPr>
+      </p:sp>
+      <p:sp>
+        <p:nvSpPr>
+          <p:cNvPr id="13" name="Shape 11"/>
+          <p:cNvSpPr/>
+          <p:nvPr/>
+        </p:nvSpPr>
+        <p:spPr>
+          <a:xfrm>
+            <a:off x="5342839" y="2743200"/>
+            <a:ext cx="402336" cy="402336"/>
+          </a:xfrm>
+          <a:prstGeom prst="ellipse">
+            <a:avLst/>
+          </a:prstGeom>
+          <a:solidFill>
+            <a:srgbClr val="0E7C86"/>
+          </a:solidFill>
+          <a:ln/>
+        </p:spPr>
+      </p:sp>
+      <p:sp>
+        <p:nvSpPr>
+          <p:cNvPr id="14" name="Text 12"/>
+          <p:cNvSpPr/>
+          <p:nvPr/>
+        </p:nvSpPr>
+        <p:spPr>
+          <a:xfrm>
+            <a:off x="825703" y="2761488"/>
+            <a:ext cx="4352544" cy="457200"/>
+          </a:xfrm>
+          <a:prstGeom prst="rect">
+            <a:avLst/>
+          </a:prstGeom>
+          <a:noFill/>
+          <a:ln/>
+        </p:spPr>
+        <p:txBody>
+          <a:bodyPr wrap="square" lIns="0" tIns="0" rIns="0" bIns="0" rtlCol="0" anchor="ctr"/>
+          <a:lstStyle/>
+          <a:p>
+            <a:pPr marL="0" marR="0" lvl="0" indent="0" algn="r" defTabSz="914400" rtl="1" eaLnBrk="1" fontAlgn="auto" latinLnBrk="0" hangingPunct="1">
+              <a:lnSpc>
+                <a:spcPct val="100000"/>
+              </a:lnSpc>
+              <a:spcBef>
+                <a:spcPts val="0"/>
+              </a:spcBef>
+              <a:spcAft>
+                <a:spcPts val="0"/>
+              </a:spcAft>
+              <a:buClrTx/>
+              <a:buSzTx/>
+              <a:buFontTx/>
+              <a:buNone/>
+              <a:tabLst/>
+              <a:defRPr/>
+            </a:pPr>
+            <a:r>
+              <a:rPr kumimoji="0" lang="ar-SA" altLang="en-US" b="1" i="0" u="none" strike="noStrike" kern="1200" cap="none" spc="0" normalizeH="0" baseline="0" noProof="0" dirty="0">
+                <a:ln>
+                  <a:noFill/>
+                </a:ln>
+                <a:solidFill>
+                  <a:srgbClr val="0A3540"/>
+                </a:solidFill>
+                <a:effectLst/>
+                <a:uLnTx/>
+                <a:uFillTx/>
+                <a:latin typeface="Dubai" panose="020B0503030403030204" pitchFamily="34" charset="-78"/>
+                <a:ea typeface="Arial" pitchFamily="34" charset="-122"/>
+                <a:cs typeface="Dubai" panose="020B0503030403030204" pitchFamily="34" charset="-78"/>
+              </a:rPr>
+              <a:t>الصلاحيات وحماية الخصوصية</a:t>
+            </a:r>
+            <a:endParaRPr kumimoji="0" lang="ar-SA" b="0" i="0" u="none" strike="noStrike" kern="1200" cap="none" spc="0" normalizeH="0" baseline="0" noProof="0" dirty="0">
+              <a:ln>
+                <a:noFill/>
+              </a:ln>
+              <a:solidFill>
+                <a:prstClr val="black"/>
+              </a:solidFill>
+              <a:effectLst/>
+              <a:uLnTx/>
+              <a:uFillTx/>
+              <a:latin typeface="Dubai" panose="020B0503030403030204" pitchFamily="34" charset="-78"/>
+              <a:cs typeface="Dubai" panose="020B0503030403030204" pitchFamily="34" charset="-78"/>
+            </a:endParaRPr>
+          </a:p>
+        </p:txBody>
+      </p:sp>
+      <p:sp>
+        <p:nvSpPr>
+          <p:cNvPr id="15" name="Text 13"/>
+          <p:cNvSpPr/>
+          <p:nvPr/>
+        </p:nvSpPr>
+        <p:spPr>
+          <a:xfrm>
+            <a:off x="825703" y="3291840"/>
+            <a:ext cx="4901184" cy="676656"/>
+          </a:xfrm>
+          <a:prstGeom prst="rect">
+            <a:avLst/>
+          </a:prstGeom>
+          <a:noFill/>
+          <a:ln/>
+        </p:spPr>
+        <p:txBody>
+          <a:bodyPr wrap="square" lIns="0" tIns="0" rIns="0" bIns="0" rtlCol="0" anchor="t"/>
+          <a:lstStyle/>
+          <a:p>
+            <a:pPr marL="0" marR="0" lvl="0" indent="0" algn="r" defTabSz="914400" rtl="1" eaLnBrk="1" fontAlgn="auto" latinLnBrk="0" hangingPunct="1">
+              <a:lnSpc>
+                <a:spcPct val="130000"/>
+              </a:lnSpc>
+              <a:spcBef>
+                <a:spcPts val="0"/>
+              </a:spcBef>
+              <a:spcAft>
+                <a:spcPts val="0"/>
+              </a:spcAft>
+              <a:buClrTx/>
+              <a:buSzTx/>
+              <a:buFontTx/>
+              <a:buNone/>
+              <a:tabLst/>
+              <a:defRPr/>
+            </a:pPr>
+            <a:r>
+              <a:rPr kumimoji="0" lang="ar-SA" altLang="en-US" sz="1600" b="0" i="0" u="none" strike="noStrike" kern="1200" cap="none" spc="0" normalizeH="0" baseline="0" noProof="0" dirty="0">
+                <a:ln>
+                  <a:noFill/>
+                </a:ln>
+                <a:solidFill>
+                  <a:srgbClr val="587078"/>
+                </a:solidFill>
+                <a:effectLst/>
+                <a:uLnTx/>
+                <a:uFillTx/>
+                <a:latin typeface="Dubai" panose="020B0503030403030204" pitchFamily="34" charset="-78"/>
+                <a:ea typeface="Arial" pitchFamily="34" charset="-122"/>
+                <a:cs typeface="Dubai" panose="020B0503030403030204" pitchFamily="34" charset="-78"/>
+              </a:rPr>
+              <a:t>التأكّد آلياً أنّ المريض لا يصل إلى سجلّ غيره، وأنّ المؤسسة لا تتجاوز حدودها.</a:t>
+            </a:r>
+            <a:endParaRPr kumimoji="0" lang="ar-SA" sz="1600" b="0" i="0" u="none" strike="noStrike" kern="1200" cap="none" spc="0" normalizeH="0" baseline="0" noProof="0" dirty="0">
+              <a:ln>
+                <a:noFill/>
+              </a:ln>
+              <a:solidFill>
+                <a:prstClr val="black"/>
+              </a:solidFill>
+              <a:effectLst/>
+              <a:uLnTx/>
+              <a:uFillTx/>
+              <a:latin typeface="Dubai" panose="020B0503030403030204" pitchFamily="34" charset="-78"/>
+              <a:cs typeface="Dubai" panose="020B0503030403030204" pitchFamily="34" charset="-78"/>
+            </a:endParaRPr>
+          </a:p>
+        </p:txBody>
+      </p:sp>
+      <p:sp>
+        <p:nvSpPr>
+          <p:cNvPr id="16" name="Shape 14"/>
+          <p:cNvSpPr/>
+          <p:nvPr/>
+        </p:nvSpPr>
+        <p:spPr>
+          <a:xfrm>
+            <a:off x="6193231" y="4352544"/>
+            <a:ext cx="5449824" cy="1591056"/>
+          </a:xfrm>
+          <a:prstGeom prst="roundRect">
+            <a:avLst>
+              <a:gd name="adj" fmla="val 4598"/>
+            </a:avLst>
+          </a:prstGeom>
+          <a:solidFill>
+            <a:srgbClr val="F2F8F8"/>
+          </a:solidFill>
+          <a:ln w="9525">
+            <a:solidFill>
+              <a:srgbClr val="D9E7E9"/>
+            </a:solidFill>
+            <a:prstDash val="solid"/>
+          </a:ln>
+        </p:spPr>
+      </p:sp>
+      <p:sp>
+        <p:nvSpPr>
+          <p:cNvPr id="17" name="Shape 15"/>
+          <p:cNvSpPr/>
+          <p:nvPr/>
+        </p:nvSpPr>
+        <p:spPr>
+          <a:xfrm>
+            <a:off x="10984687" y="4553712"/>
+            <a:ext cx="402336" cy="402336"/>
+          </a:xfrm>
+          <a:prstGeom prst="ellipse">
+            <a:avLst/>
+          </a:prstGeom>
+          <a:solidFill>
+            <a:srgbClr val="02C39A"/>
+          </a:solidFill>
+          <a:ln/>
+        </p:spPr>
+      </p:sp>
+      <p:sp>
+        <p:nvSpPr>
+          <p:cNvPr id="18" name="Text 16"/>
+          <p:cNvSpPr/>
+          <p:nvPr/>
+        </p:nvSpPr>
+        <p:spPr>
+          <a:xfrm>
+            <a:off x="6467551" y="4572000"/>
+            <a:ext cx="4352544" cy="457200"/>
+          </a:xfrm>
+          <a:prstGeom prst="rect">
+            <a:avLst/>
+          </a:prstGeom>
+          <a:noFill/>
+          <a:ln/>
+        </p:spPr>
+        <p:txBody>
+          <a:bodyPr wrap="square" lIns="0" tIns="0" rIns="0" bIns="0" rtlCol="0" anchor="ctr"/>
+          <a:lstStyle/>
+          <a:p>
+            <a:pPr marL="0" marR="0" lvl="0" indent="0" algn="r" defTabSz="914400" rtl="1" eaLnBrk="1" fontAlgn="auto" latinLnBrk="0" hangingPunct="1">
+              <a:lnSpc>
+                <a:spcPct val="100000"/>
+              </a:lnSpc>
+              <a:spcBef>
+                <a:spcPts val="0"/>
+              </a:spcBef>
+              <a:spcAft>
+                <a:spcPts val="0"/>
+              </a:spcAft>
+              <a:buClrTx/>
+              <a:buSzTx/>
+              <a:buFontTx/>
+              <a:buNone/>
+              <a:tabLst/>
+              <a:defRPr/>
+            </a:pPr>
+            <a:r>
+              <a:rPr kumimoji="0" lang="ar-SA" altLang="en-US" b="1" i="0" u="none" strike="noStrike" kern="1200" cap="none" spc="0" normalizeH="0" baseline="0" noProof="0" dirty="0">
+                <a:ln>
+                  <a:noFill/>
+                </a:ln>
+                <a:solidFill>
+                  <a:srgbClr val="0A3540"/>
+                </a:solidFill>
+                <a:effectLst/>
+                <a:uLnTx/>
+                <a:uFillTx/>
+                <a:latin typeface="Dubai" panose="020B0503030403030204" pitchFamily="34" charset="-78"/>
+                <a:ea typeface="Arial" pitchFamily="34" charset="-122"/>
+                <a:cs typeface="Dubai" panose="020B0503030403030204" pitchFamily="34" charset="-78"/>
+              </a:rPr>
+              <a:t>نماذج الذكاء الاصطناعي</a:t>
+            </a:r>
+            <a:endParaRPr kumimoji="0" lang="ar-SA" b="0" i="0" u="none" strike="noStrike" kern="1200" cap="none" spc="0" normalizeH="0" baseline="0" noProof="0" dirty="0">
+              <a:ln>
+                <a:noFill/>
+              </a:ln>
+              <a:solidFill>
+                <a:prstClr val="black"/>
+              </a:solidFill>
+              <a:effectLst/>
+              <a:uLnTx/>
+              <a:uFillTx/>
+              <a:latin typeface="Dubai" panose="020B0503030403030204" pitchFamily="34" charset="-78"/>
+              <a:cs typeface="Dubai" panose="020B0503030403030204" pitchFamily="34" charset="-78"/>
+            </a:endParaRPr>
+          </a:p>
+        </p:txBody>
+      </p:sp>
+      <p:sp>
+        <p:nvSpPr>
+          <p:cNvPr id="19" name="Text 17"/>
+          <p:cNvSpPr/>
+          <p:nvPr/>
+        </p:nvSpPr>
+        <p:spPr>
+          <a:xfrm>
+            <a:off x="6467551" y="5102352"/>
+            <a:ext cx="4901184" cy="676656"/>
+          </a:xfrm>
+          <a:prstGeom prst="rect">
+            <a:avLst/>
+          </a:prstGeom>
+          <a:noFill/>
+          <a:ln/>
+        </p:spPr>
+        <p:txBody>
+          <a:bodyPr wrap="square" lIns="0" tIns="0" rIns="0" bIns="0" rtlCol="0" anchor="t"/>
+          <a:lstStyle/>
+          <a:p>
+            <a:pPr marL="0" marR="0" lvl="0" indent="0" algn="r" defTabSz="914400" rtl="1" eaLnBrk="1" fontAlgn="auto" latinLnBrk="0" hangingPunct="1">
+              <a:lnSpc>
+                <a:spcPct val="130000"/>
+              </a:lnSpc>
+              <a:spcBef>
+                <a:spcPts val="0"/>
+              </a:spcBef>
+              <a:spcAft>
+                <a:spcPts val="0"/>
+              </a:spcAft>
+              <a:buClrTx/>
+              <a:buSzTx/>
+              <a:buFontTx/>
+              <a:buNone/>
+              <a:tabLst/>
+              <a:defRPr/>
+            </a:pPr>
+            <a:r>
+              <a:rPr kumimoji="0" lang="ar-SA" altLang="en-US" sz="1600" b="0" i="0" u="none" strike="noStrike" kern="1200" cap="none" spc="0" normalizeH="0" baseline="0" noProof="0" dirty="0">
+                <a:ln>
+                  <a:noFill/>
+                </a:ln>
+                <a:solidFill>
+                  <a:srgbClr val="587078"/>
+                </a:solidFill>
+                <a:effectLst/>
+                <a:uLnTx/>
+                <a:uFillTx/>
+                <a:latin typeface="Dubai" panose="020B0503030403030204" pitchFamily="34" charset="-78"/>
+                <a:ea typeface="Arial" pitchFamily="34" charset="-122"/>
+                <a:cs typeface="Dubai" panose="020B0503030403030204" pitchFamily="34" charset="-78"/>
+              </a:rPr>
+              <a:t>تُشغَّل النماذج فعلياً — لا نسخاً وهمية — ويُتحقَّق من سماتها ونتائجها وحدودها.</a:t>
+            </a:r>
+            <a:endParaRPr kumimoji="0" lang="ar-SA" sz="1600" b="0" i="0" u="none" strike="noStrike" kern="1200" cap="none" spc="0" normalizeH="0" baseline="0" noProof="0" dirty="0">
+              <a:ln>
+                <a:noFill/>
+              </a:ln>
+              <a:solidFill>
+                <a:prstClr val="black"/>
+              </a:solidFill>
+              <a:effectLst/>
+              <a:uLnTx/>
+              <a:uFillTx/>
+              <a:latin typeface="Dubai" panose="020B0503030403030204" pitchFamily="34" charset="-78"/>
+              <a:cs typeface="Dubai" panose="020B0503030403030204" pitchFamily="34" charset="-78"/>
+            </a:endParaRPr>
+          </a:p>
+        </p:txBody>
+      </p:sp>
+      <p:sp>
+        <p:nvSpPr>
+          <p:cNvPr id="20" name="Shape 18"/>
+          <p:cNvSpPr/>
+          <p:nvPr/>
+        </p:nvSpPr>
+        <p:spPr>
+          <a:xfrm>
+            <a:off x="551383" y="4352544"/>
+            <a:ext cx="5449824" cy="1591056"/>
+          </a:xfrm>
+          <a:prstGeom prst="roundRect">
+            <a:avLst>
+              <a:gd name="adj" fmla="val 4598"/>
+            </a:avLst>
+          </a:prstGeom>
+          <a:solidFill>
+            <a:srgbClr val="F2F8F8"/>
+          </a:solidFill>
+          <a:ln w="9525">
+            <a:solidFill>
+              <a:srgbClr val="D9E7E9"/>
+            </a:solidFill>
+            <a:prstDash val="solid"/>
+          </a:ln>
+        </p:spPr>
+      </p:sp>
+      <p:sp>
+        <p:nvSpPr>
+          <p:cNvPr id="21" name="Shape 19"/>
+          <p:cNvSpPr/>
+          <p:nvPr/>
+        </p:nvSpPr>
+        <p:spPr>
+          <a:xfrm>
+            <a:off x="5342839" y="4553712"/>
+            <a:ext cx="402336" cy="402336"/>
+          </a:xfrm>
+          <a:prstGeom prst="ellipse">
+            <a:avLst/>
+          </a:prstGeom>
+          <a:solidFill>
+            <a:srgbClr val="02C39A"/>
+          </a:solidFill>
+          <a:ln/>
+        </p:spPr>
+      </p:sp>
+      <p:sp>
+        <p:nvSpPr>
+          <p:cNvPr id="22" name="Text 20"/>
+          <p:cNvSpPr/>
+          <p:nvPr/>
+        </p:nvSpPr>
+        <p:spPr>
+          <a:xfrm>
+            <a:off x="825703" y="4572000"/>
+            <a:ext cx="4352544" cy="457200"/>
+          </a:xfrm>
+          <a:prstGeom prst="rect">
+            <a:avLst/>
+          </a:prstGeom>
+          <a:noFill/>
+          <a:ln/>
+        </p:spPr>
+        <p:txBody>
+          <a:bodyPr wrap="square" lIns="0" tIns="0" rIns="0" bIns="0" rtlCol="0" anchor="ctr"/>
+          <a:lstStyle/>
+          <a:p>
+            <a:pPr marL="0" marR="0" lvl="0" indent="0" algn="r" defTabSz="914400" rtl="1" eaLnBrk="1" fontAlgn="auto" latinLnBrk="0" hangingPunct="1">
+              <a:lnSpc>
+                <a:spcPct val="100000"/>
+              </a:lnSpc>
+              <a:spcBef>
+                <a:spcPts val="0"/>
+              </a:spcBef>
+              <a:spcAft>
+                <a:spcPts val="0"/>
+              </a:spcAft>
+              <a:buClrTx/>
+              <a:buSzTx/>
+              <a:buFontTx/>
+              <a:buNone/>
+              <a:tabLst/>
+              <a:defRPr/>
+            </a:pPr>
+            <a:r>
+              <a:rPr kumimoji="0" lang="ar-SA" altLang="en-US" b="1" i="0" u="none" strike="noStrike" kern="1200" cap="none" spc="0" normalizeH="0" baseline="0" noProof="0" dirty="0">
+                <a:ln>
+                  <a:noFill/>
+                </a:ln>
+                <a:solidFill>
+                  <a:srgbClr val="0A3540"/>
+                </a:solidFill>
+                <a:effectLst/>
+                <a:uLnTx/>
+                <a:uFillTx/>
+                <a:latin typeface="Dubai" panose="020B0503030403030204" pitchFamily="34" charset="-78"/>
+                <a:ea typeface="Arial" pitchFamily="34" charset="-122"/>
+                <a:cs typeface="Dubai" panose="020B0503030403030204" pitchFamily="34" charset="-78"/>
+              </a:rPr>
+              <a:t>تعدّد المستخدمين والأداء</a:t>
+            </a:r>
+            <a:endParaRPr kumimoji="0" lang="ar-SA" b="0" i="0" u="none" strike="noStrike" kern="1200" cap="none" spc="0" normalizeH="0" baseline="0" noProof="0" dirty="0">
+              <a:ln>
+                <a:noFill/>
+              </a:ln>
+              <a:solidFill>
+                <a:prstClr val="black"/>
+              </a:solidFill>
+              <a:effectLst/>
+              <a:uLnTx/>
+              <a:uFillTx/>
+              <a:latin typeface="Dubai" panose="020B0503030403030204" pitchFamily="34" charset="-78"/>
+              <a:cs typeface="Dubai" panose="020B0503030403030204" pitchFamily="34" charset="-78"/>
+            </a:endParaRPr>
+          </a:p>
+        </p:txBody>
+      </p:sp>
+      <p:sp>
+        <p:nvSpPr>
+          <p:cNvPr id="23" name="Text 21"/>
+          <p:cNvSpPr/>
+          <p:nvPr/>
+        </p:nvSpPr>
+        <p:spPr>
+          <a:xfrm>
+            <a:off x="825703" y="5102352"/>
+            <a:ext cx="4901184" cy="676656"/>
+          </a:xfrm>
+          <a:prstGeom prst="rect">
+            <a:avLst/>
+          </a:prstGeom>
+          <a:noFill/>
+          <a:ln/>
+        </p:spPr>
+        <p:txBody>
+          <a:bodyPr wrap="square" lIns="0" tIns="0" rIns="0" bIns="0" rtlCol="0" anchor="t"/>
+          <a:lstStyle/>
+          <a:p>
+            <a:pPr marL="0" marR="0" lvl="0" indent="0" algn="r" defTabSz="914400" rtl="1" eaLnBrk="1" fontAlgn="auto" latinLnBrk="0" hangingPunct="1">
+              <a:lnSpc>
+                <a:spcPct val="130000"/>
+              </a:lnSpc>
+              <a:spcBef>
+                <a:spcPts val="0"/>
+              </a:spcBef>
+              <a:spcAft>
+                <a:spcPts val="0"/>
+              </a:spcAft>
+              <a:buClrTx/>
+              <a:buSzTx/>
+              <a:buFontTx/>
+              <a:buNone/>
+              <a:tabLst/>
+              <a:defRPr/>
+            </a:pPr>
+            <a:r>
+              <a:rPr kumimoji="0" lang="ar-SA" altLang="en-US" sz="1600" b="0" i="0" u="none" strike="noStrike" kern="1200" cap="none" spc="0" normalizeH="0" baseline="0" noProof="0" dirty="0">
+                <a:ln>
+                  <a:noFill/>
+                </a:ln>
+                <a:solidFill>
+                  <a:srgbClr val="587078"/>
+                </a:solidFill>
+                <a:effectLst/>
+                <a:uLnTx/>
+                <a:uFillTx/>
+                <a:latin typeface="Dubai" panose="020B0503030403030204" pitchFamily="34" charset="-78"/>
+                <a:ea typeface="Arial" pitchFamily="34" charset="-122"/>
+                <a:cs typeface="Dubai" panose="020B0503030403030204" pitchFamily="34" charset="-78"/>
+              </a:rPr>
+              <a:t>عزل بيانات كلّ مستخدم تحت الاستخدام المتزامن، وقياس تحسّن الأداء نحو ١٩ ضعفاً.</a:t>
+            </a:r>
+            <a:endParaRPr kumimoji="0" lang="ar-SA" sz="1600" b="0" i="0" u="none" strike="noStrike" kern="1200" cap="none" spc="0" normalizeH="0" baseline="0" noProof="0" dirty="0">
+              <a:ln>
+                <a:noFill/>
+              </a:ln>
+              <a:solidFill>
+                <a:prstClr val="black"/>
+              </a:solidFill>
+              <a:effectLst/>
+              <a:uLnTx/>
+              <a:uFillTx/>
+              <a:latin typeface="Dubai" panose="020B0503030403030204" pitchFamily="34" charset="-78"/>
+              <a:cs typeface="Dubai" panose="020B0503030403030204" pitchFamily="34" charset="-78"/>
+            </a:endParaRPr>
+          </a:p>
+        </p:txBody>
+      </p:sp>
+      <p:sp>
+        <p:nvSpPr>
+          <p:cNvPr id="24" name="Text 22"/>
+          <p:cNvSpPr/>
+          <p:nvPr/>
+        </p:nvSpPr>
+        <p:spPr>
+          <a:xfrm>
+            <a:off x="548640" y="6016752"/>
+            <a:ext cx="11094415" cy="365760"/>
+          </a:xfrm>
+          <a:prstGeom prst="rect">
+            <a:avLst/>
+          </a:prstGeom>
+          <a:noFill/>
+          <a:ln/>
+        </p:spPr>
+        <p:txBody>
+          <a:bodyPr wrap="square" lIns="0" tIns="0" rIns="0" bIns="0" rtlCol="0" anchor="ctr"/>
+          <a:lstStyle/>
+          <a:p>
+            <a:pPr marL="0" marR="0" lvl="0" indent="0" algn="r" defTabSz="914400" rtl="1" eaLnBrk="1" fontAlgn="auto" latinLnBrk="0" hangingPunct="1">
+              <a:lnSpc>
+                <a:spcPct val="100000"/>
+              </a:lnSpc>
+              <a:spcBef>
+                <a:spcPts val="0"/>
+              </a:spcBef>
+              <a:spcAft>
+                <a:spcPts val="0"/>
+              </a:spcAft>
+              <a:buClrTx/>
+              <a:buSzTx/>
+              <a:buFontTx/>
+              <a:buNone/>
+              <a:tabLst/>
+              <a:defRPr/>
+            </a:pPr>
+            <a:r>
+              <a:rPr kumimoji="0" lang="ar-SA" altLang="en-US" sz="1200" b="0" i="1" u="none" strike="noStrike" kern="1200" cap="none" spc="0" normalizeH="0" baseline="0" noProof="0" dirty="0">
+                <a:ln>
+                  <a:noFill/>
+                </a:ln>
+                <a:solidFill>
+                  <a:srgbClr val="587078"/>
+                </a:solidFill>
+                <a:effectLst/>
+                <a:uLnTx/>
+                <a:uFillTx/>
+                <a:latin typeface="Dubai" panose="020B0503030403030204" pitchFamily="34" charset="-78"/>
+                <a:ea typeface="Arial" pitchFamily="34" charset="-122"/>
+                <a:cs typeface="Dubai" panose="020B0503030403030204" pitchFamily="34" charset="-78"/>
+              </a:rPr>
+              <a:t>وأثبتت الاختبارات قدرتها على كشف الخطأ فعلياً: عند تعطيل فحصٍ أمني عمداً على سبيل التجربة، أخفق اختبارا عزل المريض وحدهما دون سواهما.</a:t>
+            </a:r>
+            <a:endParaRPr kumimoji="0" lang="ar-SA" sz="1200" b="0" i="0" u="none" strike="noStrike" kern="1200" cap="none" spc="0" normalizeH="0" baseline="0" noProof="0" dirty="0">
+              <a:ln>
+                <a:noFill/>
+              </a:ln>
+              <a:solidFill>
+                <a:prstClr val="black"/>
+              </a:solidFill>
+              <a:effectLst/>
+              <a:uLnTx/>
+              <a:uFillTx/>
+              <a:latin typeface="Dubai" panose="020B0503030403030204" pitchFamily="34" charset="-78"/>
+              <a:cs typeface="Dubai" panose="020B0503030403030204" pitchFamily="34" charset="-78"/>
+            </a:endParaRPr>
+          </a:p>
+        </p:txBody>
+      </p:sp>
+    </p:spTree>
+    <p:extLst>
+      <p:ext uri="{BB962C8B-B14F-4D97-AF65-F5344CB8AC3E}">
+        <p14:creationId xmlns:p14="http://schemas.microsoft.com/office/powerpoint/2010/main" val="2016552987"/>
+      </p:ext>
+    </p:extLst>
+  </p:cSld>
+  <p:clrMapOvr>
+    <a:masterClrMapping/>
+  </p:clrMapOvr>
+</p:sld>
+</file>
+
+<file path=ppt/slides/slide14.xml><?xml version="1.0" encoding="utf-8"?>
+<p:sld xmlns:a="http://schemas.openxmlformats.org/drawingml/2006/main" xmlns:r="http://schemas.openxmlformats.org/officeDocument/2006/relationships" xmlns:p="http://schemas.openxmlformats.org/presentationml/2006/main">
   <p:cSld name="Slide 15">
     <p:bg>
       <p:bgPr>
@@ -5214,8 +6631,27 @@
                 <a:ea typeface="Arial" pitchFamily="34" charset="-122"/>
                 <a:cs typeface="Arial" pitchFamily="34" charset="-120"/>
               </a:rPr>
-              <a:t>13</a:t>
-            </a:r>
+              <a:t>1</a:t>
+            </a:r>
+            <a:r>
+              <a:rPr lang="en-US" sz="900" dirty="0">
+                <a:solidFill>
+                  <a:srgbClr val="587078"/>
+                </a:solidFill>
+                <a:latin typeface="Arial" pitchFamily="34" charset="0"/>
+                <a:ea typeface="Arial" pitchFamily="34" charset="-122"/>
+                <a:cs typeface="Arial" pitchFamily="34" charset="-120"/>
+              </a:rPr>
+              <a:t>4</a:t>
+            </a:r>
+            <a:endParaRPr lang="ar-SY" sz="900" dirty="0">
+              <a:solidFill>
+                <a:srgbClr val="587078"/>
+              </a:solidFill>
+              <a:latin typeface="Arial" pitchFamily="34" charset="0"/>
+              <a:ea typeface="Arial" pitchFamily="34" charset="-122"/>
+              <a:cs typeface="Arial" pitchFamily="34" charset="-120"/>
+            </a:endParaRPr>
           </a:p>
         </p:txBody>
       </p:sp>
@@ -5847,7 +7283,7 @@
 </p:sld>
 </file>
 
-<file path=ppt/slides/slide14.xml><?xml version="1.0" encoding="utf-8"?>
+<file path=ppt/slides/slide15.xml><?xml version="1.0" encoding="utf-8"?>
 <p:sld xmlns:a="http://schemas.openxmlformats.org/drawingml/2006/main" xmlns:r="http://schemas.openxmlformats.org/officeDocument/2006/relationships" xmlns:p="http://schemas.openxmlformats.org/presentationml/2006/main">
   <p:cSld name="Slide 16">
     <p:bg>
@@ -5968,7 +7404,7 @@
               <a:buNone/>
             </a:pPr>
             <a:r>
-              <a:rPr lang="ar-SY" sz="900" dirty="0">
+              <a:rPr lang="en-US" sz="900" dirty="0">
                 <a:solidFill>
                   <a:srgbClr val="CFE8EA"/>
                 </a:solidFill>
@@ -5976,8 +7412,16 @@
                 <a:ea typeface="Arial" pitchFamily="34" charset="-122"/>
                 <a:cs typeface="Arial" pitchFamily="34" charset="-120"/>
               </a:rPr>
-              <a:t>14</a:t>
-            </a:r>
+              <a:t>15</a:t>
+            </a:r>
+            <a:endParaRPr lang="ar-SY" sz="900" dirty="0">
+              <a:solidFill>
+                <a:srgbClr val="CFE8EA"/>
+              </a:solidFill>
+              <a:latin typeface="Arial" pitchFamily="34" charset="0"/>
+              <a:ea typeface="Arial" pitchFamily="34" charset="-122"/>
+              <a:cs typeface="Arial" pitchFamily="34" charset="-120"/>
+            </a:endParaRPr>
           </a:p>
         </p:txBody>
       </p:sp>
@@ -6576,7 +8020,7 @@
 </p:sld>
 </file>
 
-<file path=ppt/slides/slide15.xml><?xml version="1.0" encoding="utf-8"?>
+<file path=ppt/slides/slide16.xml><?xml version="1.0" encoding="utf-8"?>
 <p:sld xmlns:a="http://schemas.openxmlformats.org/drawingml/2006/main" xmlns:r="http://schemas.openxmlformats.org/officeDocument/2006/relationships" xmlns:p="http://schemas.openxmlformats.org/presentationml/2006/main">
   <p:cSld name="Slide 17">
     <p:bg>

</xml_diff>

<commit_message>
presentation 100 percent done
</commit_message>
<xml_diff>
--- a/docs/عرض المشروع.pptx
+++ b/docs/عرض المشروع.pptx
@@ -2717,6 +2717,9 @@
   <p:clrMapOvr>
     <a:masterClrMapping/>
   </p:clrMapOvr>
+  <p:transition spd="slow">
+    <p:wipe dir="r"/>
+  </p:transition>
 </p:sld>
 </file>
 
@@ -3495,6 +3498,9 @@
   <p:clrMapOvr>
     <a:masterClrMapping/>
   </p:clrMapOvr>
+  <p:transition spd="slow">
+    <p:wipe dir="r"/>
+  </p:transition>
 </p:sld>
 </file>
 
@@ -4164,6 +4170,9 @@
   <p:clrMapOvr>
     <a:masterClrMapping/>
   </p:clrMapOvr>
+  <p:transition spd="slow">
+    <p:wipe dir="r"/>
+  </p:transition>
 </p:sld>
 </file>
 
@@ -5259,6 +5268,9 @@
   <p:clrMapOvr>
     <a:masterClrMapping/>
   </p:clrMapOvr>
+  <p:transition spd="slow">
+    <p:wipe dir="r"/>
+  </p:transition>
 </p:sld>
 </file>
 
@@ -6528,6 +6540,9 @@
   <p:clrMapOvr>
     <a:masterClrMapping/>
   </p:clrMapOvr>
+  <p:transition spd="slow">
+    <p:wipe dir="r"/>
+  </p:transition>
 </p:sld>
 </file>
 
@@ -7280,6 +7295,9 @@
   <p:clrMapOvr>
     <a:masterClrMapping/>
   </p:clrMapOvr>
+  <p:transition spd="slow">
+    <p:wipe dir="r"/>
+  </p:transition>
 </p:sld>
 </file>
 
@@ -8017,6 +8035,9 @@
   <p:clrMapOvr>
     <a:masterClrMapping/>
   </p:clrMapOvr>
+  <p:transition spd="slow">
+    <p:wipe dir="r"/>
+  </p:transition>
 </p:sld>
 </file>
 
@@ -8242,6 +8263,9 @@
   <p:clrMapOvr>
     <a:masterClrMapping/>
   </p:clrMapOvr>
+  <p:transition spd="slow">
+    <p:wipe dir="r"/>
+  </p:transition>
 </p:sld>
 </file>
 
@@ -9166,6 +9190,9 @@
   <p:clrMapOvr>
     <a:masterClrMapping/>
   </p:clrMapOvr>
+  <p:transition spd="slow">
+    <p:wipe dir="r"/>
+  </p:transition>
 </p:sld>
 </file>
 
@@ -10056,6 +10083,1511 @@
   <p:clrMapOvr>
     <a:masterClrMapping/>
   </p:clrMapOvr>
+  <p:transition spd="slow">
+    <p:wipe dir="r"/>
+  </p:transition>
+  <p:timing>
+    <p:tnLst>
+      <p:par>
+        <p:cTn id="1" dur="indefinite" restart="never" nodeType="tmRoot">
+          <p:childTnLst>
+            <p:seq concurrent="1" nextAc="seek">
+              <p:cTn id="2" dur="indefinite" nodeType="mainSeq">
+                <p:childTnLst>
+                  <p:par>
+                    <p:cTn id="3" fill="hold">
+                      <p:stCondLst>
+                        <p:cond delay="indefinite"/>
+                      </p:stCondLst>
+                      <p:childTnLst>
+                        <p:par>
+                          <p:cTn id="4" fill="hold">
+                            <p:stCondLst>
+                              <p:cond delay="0"/>
+                            </p:stCondLst>
+                            <p:childTnLst>
+                              <p:par>
+                                <p:cTn id="5" presetID="2" presetClass="entr" presetSubtype="1" fill="hold" nodeType="clickEffect">
+                                  <p:stCondLst>
+                                    <p:cond delay="0"/>
+                                  </p:stCondLst>
+                                  <p:childTnLst>
+                                    <p:set>
+                                      <p:cBhvr>
+                                        <p:cTn id="6" dur="1" fill="hold">
+                                          <p:stCondLst>
+                                            <p:cond delay="0"/>
+                                          </p:stCondLst>
+                                        </p:cTn>
+                                        <p:tgtEl>
+                                          <p:spTgt spid="6"/>
+                                        </p:tgtEl>
+                                        <p:attrNameLst>
+                                          <p:attrName>style.visibility</p:attrName>
+                                        </p:attrNameLst>
+                                      </p:cBhvr>
+                                      <p:to>
+                                        <p:strVal val="visible"/>
+                                      </p:to>
+                                    </p:set>
+                                    <p:anim calcmode="lin" valueType="num">
+                                      <p:cBhvr additive="base">
+                                        <p:cTn id="7" dur="500" fill="hold"/>
+                                        <p:tgtEl>
+                                          <p:spTgt spid="6"/>
+                                        </p:tgtEl>
+                                        <p:attrNameLst>
+                                          <p:attrName>ppt_x</p:attrName>
+                                        </p:attrNameLst>
+                                      </p:cBhvr>
+                                      <p:tavLst>
+                                        <p:tav tm="0">
+                                          <p:val>
+                                            <p:strVal val="#ppt_x"/>
+                                          </p:val>
+                                        </p:tav>
+                                        <p:tav tm="100000">
+                                          <p:val>
+                                            <p:strVal val="#ppt_x"/>
+                                          </p:val>
+                                        </p:tav>
+                                      </p:tavLst>
+                                    </p:anim>
+                                    <p:anim calcmode="lin" valueType="num">
+                                      <p:cBhvr additive="base">
+                                        <p:cTn id="8" dur="500" fill="hold"/>
+                                        <p:tgtEl>
+                                          <p:spTgt spid="6"/>
+                                        </p:tgtEl>
+                                        <p:attrNameLst>
+                                          <p:attrName>ppt_y</p:attrName>
+                                        </p:attrNameLst>
+                                      </p:cBhvr>
+                                      <p:tavLst>
+                                        <p:tav tm="0">
+                                          <p:val>
+                                            <p:strVal val="0-#ppt_h/2"/>
+                                          </p:val>
+                                        </p:tav>
+                                        <p:tav tm="100000">
+                                          <p:val>
+                                            <p:strVal val="#ppt_y"/>
+                                          </p:val>
+                                        </p:tav>
+                                      </p:tavLst>
+                                    </p:anim>
+                                  </p:childTnLst>
+                                </p:cTn>
+                              </p:par>
+                              <p:par>
+                                <p:cTn id="9" presetID="2" presetClass="entr" presetSubtype="1" fill="hold" grpId="0" nodeType="withEffect">
+                                  <p:stCondLst>
+                                    <p:cond delay="0"/>
+                                  </p:stCondLst>
+                                  <p:childTnLst>
+                                    <p:set>
+                                      <p:cBhvr>
+                                        <p:cTn id="10" dur="1" fill="hold">
+                                          <p:stCondLst>
+                                            <p:cond delay="0"/>
+                                          </p:stCondLst>
+                                        </p:cTn>
+                                        <p:tgtEl>
+                                          <p:spTgt spid="9"/>
+                                        </p:tgtEl>
+                                        <p:attrNameLst>
+                                          <p:attrName>style.visibility</p:attrName>
+                                        </p:attrNameLst>
+                                      </p:cBhvr>
+                                      <p:to>
+                                        <p:strVal val="visible"/>
+                                      </p:to>
+                                    </p:set>
+                                    <p:anim calcmode="lin" valueType="num">
+                                      <p:cBhvr additive="base">
+                                        <p:cTn id="11" dur="500" fill="hold"/>
+                                        <p:tgtEl>
+                                          <p:spTgt spid="9"/>
+                                        </p:tgtEl>
+                                        <p:attrNameLst>
+                                          <p:attrName>ppt_x</p:attrName>
+                                        </p:attrNameLst>
+                                      </p:cBhvr>
+                                      <p:tavLst>
+                                        <p:tav tm="0">
+                                          <p:val>
+                                            <p:strVal val="#ppt_x"/>
+                                          </p:val>
+                                        </p:tav>
+                                        <p:tav tm="100000">
+                                          <p:val>
+                                            <p:strVal val="#ppt_x"/>
+                                          </p:val>
+                                        </p:tav>
+                                      </p:tavLst>
+                                    </p:anim>
+                                    <p:anim calcmode="lin" valueType="num">
+                                      <p:cBhvr additive="base">
+                                        <p:cTn id="12" dur="500" fill="hold"/>
+                                        <p:tgtEl>
+                                          <p:spTgt spid="9"/>
+                                        </p:tgtEl>
+                                        <p:attrNameLst>
+                                          <p:attrName>ppt_y</p:attrName>
+                                        </p:attrNameLst>
+                                      </p:cBhvr>
+                                      <p:tavLst>
+                                        <p:tav tm="0">
+                                          <p:val>
+                                            <p:strVal val="0-#ppt_h/2"/>
+                                          </p:val>
+                                        </p:tav>
+                                        <p:tav tm="100000">
+                                          <p:val>
+                                            <p:strVal val="#ppt_y"/>
+                                          </p:val>
+                                        </p:tav>
+                                      </p:tavLst>
+                                    </p:anim>
+                                  </p:childTnLst>
+                                </p:cTn>
+                              </p:par>
+                              <p:par>
+                                <p:cTn id="13" presetID="2" presetClass="entr" presetSubtype="1" fill="hold" nodeType="withEffect">
+                                  <p:stCondLst>
+                                    <p:cond delay="0"/>
+                                  </p:stCondLst>
+                                  <p:childTnLst>
+                                    <p:set>
+                                      <p:cBhvr>
+                                        <p:cTn id="14" dur="1" fill="hold">
+                                          <p:stCondLst>
+                                            <p:cond delay="0"/>
+                                          </p:stCondLst>
+                                        </p:cTn>
+                                        <p:tgtEl>
+                                          <p:spTgt spid="7"/>
+                                        </p:tgtEl>
+                                        <p:attrNameLst>
+                                          <p:attrName>style.visibility</p:attrName>
+                                        </p:attrNameLst>
+                                      </p:cBhvr>
+                                      <p:to>
+                                        <p:strVal val="visible"/>
+                                      </p:to>
+                                    </p:set>
+                                    <p:anim calcmode="lin" valueType="num">
+                                      <p:cBhvr additive="base">
+                                        <p:cTn id="15" dur="500" fill="hold"/>
+                                        <p:tgtEl>
+                                          <p:spTgt spid="7"/>
+                                        </p:tgtEl>
+                                        <p:attrNameLst>
+                                          <p:attrName>ppt_x</p:attrName>
+                                        </p:attrNameLst>
+                                      </p:cBhvr>
+                                      <p:tavLst>
+                                        <p:tav tm="0">
+                                          <p:val>
+                                            <p:strVal val="#ppt_x"/>
+                                          </p:val>
+                                        </p:tav>
+                                        <p:tav tm="100000">
+                                          <p:val>
+                                            <p:strVal val="#ppt_x"/>
+                                          </p:val>
+                                        </p:tav>
+                                      </p:tavLst>
+                                    </p:anim>
+                                    <p:anim calcmode="lin" valueType="num">
+                                      <p:cBhvr additive="base">
+                                        <p:cTn id="16" dur="500" fill="hold"/>
+                                        <p:tgtEl>
+                                          <p:spTgt spid="7"/>
+                                        </p:tgtEl>
+                                        <p:attrNameLst>
+                                          <p:attrName>ppt_y</p:attrName>
+                                        </p:attrNameLst>
+                                      </p:cBhvr>
+                                      <p:tavLst>
+                                        <p:tav tm="0">
+                                          <p:val>
+                                            <p:strVal val="0-#ppt_h/2"/>
+                                          </p:val>
+                                        </p:tav>
+                                        <p:tav tm="100000">
+                                          <p:val>
+                                            <p:strVal val="#ppt_y"/>
+                                          </p:val>
+                                        </p:tav>
+                                      </p:tavLst>
+                                    </p:anim>
+                                  </p:childTnLst>
+                                </p:cTn>
+                              </p:par>
+                              <p:par>
+                                <p:cTn id="17" presetID="2" presetClass="entr" presetSubtype="1" fill="hold" grpId="0" nodeType="withEffect">
+                                  <p:stCondLst>
+                                    <p:cond delay="0"/>
+                                  </p:stCondLst>
+                                  <p:childTnLst>
+                                    <p:set>
+                                      <p:cBhvr>
+                                        <p:cTn id="18" dur="1" fill="hold">
+                                          <p:stCondLst>
+                                            <p:cond delay="0"/>
+                                          </p:stCondLst>
+                                        </p:cTn>
+                                        <p:tgtEl>
+                                          <p:spTgt spid="10"/>
+                                        </p:tgtEl>
+                                        <p:attrNameLst>
+                                          <p:attrName>style.visibility</p:attrName>
+                                        </p:attrNameLst>
+                                      </p:cBhvr>
+                                      <p:to>
+                                        <p:strVal val="visible"/>
+                                      </p:to>
+                                    </p:set>
+                                    <p:anim calcmode="lin" valueType="num">
+                                      <p:cBhvr additive="base">
+                                        <p:cTn id="19" dur="500" fill="hold"/>
+                                        <p:tgtEl>
+                                          <p:spTgt spid="10"/>
+                                        </p:tgtEl>
+                                        <p:attrNameLst>
+                                          <p:attrName>ppt_x</p:attrName>
+                                        </p:attrNameLst>
+                                      </p:cBhvr>
+                                      <p:tavLst>
+                                        <p:tav tm="0">
+                                          <p:val>
+                                            <p:strVal val="#ppt_x"/>
+                                          </p:val>
+                                        </p:tav>
+                                        <p:tav tm="100000">
+                                          <p:val>
+                                            <p:strVal val="#ppt_x"/>
+                                          </p:val>
+                                        </p:tav>
+                                      </p:tavLst>
+                                    </p:anim>
+                                    <p:anim calcmode="lin" valueType="num">
+                                      <p:cBhvr additive="base">
+                                        <p:cTn id="20" dur="500" fill="hold"/>
+                                        <p:tgtEl>
+                                          <p:spTgt spid="10"/>
+                                        </p:tgtEl>
+                                        <p:attrNameLst>
+                                          <p:attrName>ppt_y</p:attrName>
+                                        </p:attrNameLst>
+                                      </p:cBhvr>
+                                      <p:tavLst>
+                                        <p:tav tm="0">
+                                          <p:val>
+                                            <p:strVal val="0-#ppt_h/2"/>
+                                          </p:val>
+                                        </p:tav>
+                                        <p:tav tm="100000">
+                                          <p:val>
+                                            <p:strVal val="#ppt_y"/>
+                                          </p:val>
+                                        </p:tav>
+                                      </p:tavLst>
+                                    </p:anim>
+                                  </p:childTnLst>
+                                </p:cTn>
+                              </p:par>
+                            </p:childTnLst>
+                          </p:cTn>
+                        </p:par>
+                      </p:childTnLst>
+                    </p:cTn>
+                  </p:par>
+                  <p:par>
+                    <p:cTn id="21" fill="hold">
+                      <p:stCondLst>
+                        <p:cond delay="indefinite"/>
+                      </p:stCondLst>
+                      <p:childTnLst>
+                        <p:par>
+                          <p:cTn id="22" fill="hold">
+                            <p:stCondLst>
+                              <p:cond delay="0"/>
+                            </p:stCondLst>
+                            <p:childTnLst>
+                              <p:par>
+                                <p:cTn id="23" presetID="2" presetClass="entr" presetSubtype="1" fill="hold" nodeType="clickEffect">
+                                  <p:stCondLst>
+                                    <p:cond delay="0"/>
+                                  </p:stCondLst>
+                                  <p:childTnLst>
+                                    <p:set>
+                                      <p:cBhvr>
+                                        <p:cTn id="24" dur="1" fill="hold">
+                                          <p:stCondLst>
+                                            <p:cond delay="0"/>
+                                          </p:stCondLst>
+                                        </p:cTn>
+                                        <p:tgtEl>
+                                          <p:spTgt spid="11"/>
+                                        </p:tgtEl>
+                                        <p:attrNameLst>
+                                          <p:attrName>style.visibility</p:attrName>
+                                        </p:attrNameLst>
+                                      </p:cBhvr>
+                                      <p:to>
+                                        <p:strVal val="visible"/>
+                                      </p:to>
+                                    </p:set>
+                                    <p:anim calcmode="lin" valueType="num">
+                                      <p:cBhvr additive="base">
+                                        <p:cTn id="25" dur="500" fill="hold"/>
+                                        <p:tgtEl>
+                                          <p:spTgt spid="11"/>
+                                        </p:tgtEl>
+                                        <p:attrNameLst>
+                                          <p:attrName>ppt_x</p:attrName>
+                                        </p:attrNameLst>
+                                      </p:cBhvr>
+                                      <p:tavLst>
+                                        <p:tav tm="0">
+                                          <p:val>
+                                            <p:strVal val="#ppt_x"/>
+                                          </p:val>
+                                        </p:tav>
+                                        <p:tav tm="100000">
+                                          <p:val>
+                                            <p:strVal val="#ppt_x"/>
+                                          </p:val>
+                                        </p:tav>
+                                      </p:tavLst>
+                                    </p:anim>
+                                    <p:anim calcmode="lin" valueType="num">
+                                      <p:cBhvr additive="base">
+                                        <p:cTn id="26" dur="500" fill="hold"/>
+                                        <p:tgtEl>
+                                          <p:spTgt spid="11"/>
+                                        </p:tgtEl>
+                                        <p:attrNameLst>
+                                          <p:attrName>ppt_y</p:attrName>
+                                        </p:attrNameLst>
+                                      </p:cBhvr>
+                                      <p:tavLst>
+                                        <p:tav tm="0">
+                                          <p:val>
+                                            <p:strVal val="0-#ppt_h/2"/>
+                                          </p:val>
+                                        </p:tav>
+                                        <p:tav tm="100000">
+                                          <p:val>
+                                            <p:strVal val="#ppt_y"/>
+                                          </p:val>
+                                        </p:tav>
+                                      </p:tavLst>
+                                    </p:anim>
+                                  </p:childTnLst>
+                                </p:cTn>
+                              </p:par>
+                              <p:par>
+                                <p:cTn id="27" presetID="2" presetClass="entr" presetSubtype="1" fill="hold" grpId="0" nodeType="withEffect">
+                                  <p:stCondLst>
+                                    <p:cond delay="0"/>
+                                  </p:stCondLst>
+                                  <p:childTnLst>
+                                    <p:set>
+                                      <p:cBhvr>
+                                        <p:cTn id="28" dur="1" fill="hold">
+                                          <p:stCondLst>
+                                            <p:cond delay="0"/>
+                                          </p:stCondLst>
+                                        </p:cTn>
+                                        <p:tgtEl>
+                                          <p:spTgt spid="13"/>
+                                        </p:tgtEl>
+                                        <p:attrNameLst>
+                                          <p:attrName>style.visibility</p:attrName>
+                                        </p:attrNameLst>
+                                      </p:cBhvr>
+                                      <p:to>
+                                        <p:strVal val="visible"/>
+                                      </p:to>
+                                    </p:set>
+                                    <p:anim calcmode="lin" valueType="num">
+                                      <p:cBhvr additive="base">
+                                        <p:cTn id="29" dur="500" fill="hold"/>
+                                        <p:tgtEl>
+                                          <p:spTgt spid="13"/>
+                                        </p:tgtEl>
+                                        <p:attrNameLst>
+                                          <p:attrName>ppt_x</p:attrName>
+                                        </p:attrNameLst>
+                                      </p:cBhvr>
+                                      <p:tavLst>
+                                        <p:tav tm="0">
+                                          <p:val>
+                                            <p:strVal val="#ppt_x"/>
+                                          </p:val>
+                                        </p:tav>
+                                        <p:tav tm="100000">
+                                          <p:val>
+                                            <p:strVal val="#ppt_x"/>
+                                          </p:val>
+                                        </p:tav>
+                                      </p:tavLst>
+                                    </p:anim>
+                                    <p:anim calcmode="lin" valueType="num">
+                                      <p:cBhvr additive="base">
+                                        <p:cTn id="30" dur="500" fill="hold"/>
+                                        <p:tgtEl>
+                                          <p:spTgt spid="13"/>
+                                        </p:tgtEl>
+                                        <p:attrNameLst>
+                                          <p:attrName>ppt_y</p:attrName>
+                                        </p:attrNameLst>
+                                      </p:cBhvr>
+                                      <p:tavLst>
+                                        <p:tav tm="0">
+                                          <p:val>
+                                            <p:strVal val="0-#ppt_h/2"/>
+                                          </p:val>
+                                        </p:tav>
+                                        <p:tav tm="100000">
+                                          <p:val>
+                                            <p:strVal val="#ppt_y"/>
+                                          </p:val>
+                                        </p:tav>
+                                      </p:tavLst>
+                                    </p:anim>
+                                  </p:childTnLst>
+                                </p:cTn>
+                              </p:par>
+                              <p:par>
+                                <p:cTn id="31" presetID="2" presetClass="entr" presetSubtype="1" fill="hold" grpId="0" nodeType="withEffect">
+                                  <p:stCondLst>
+                                    <p:cond delay="0"/>
+                                  </p:stCondLst>
+                                  <p:childTnLst>
+                                    <p:set>
+                                      <p:cBhvr>
+                                        <p:cTn id="32" dur="1" fill="hold">
+                                          <p:stCondLst>
+                                            <p:cond delay="0"/>
+                                          </p:stCondLst>
+                                        </p:cTn>
+                                        <p:tgtEl>
+                                          <p:spTgt spid="14"/>
+                                        </p:tgtEl>
+                                        <p:attrNameLst>
+                                          <p:attrName>style.visibility</p:attrName>
+                                        </p:attrNameLst>
+                                      </p:cBhvr>
+                                      <p:to>
+                                        <p:strVal val="visible"/>
+                                      </p:to>
+                                    </p:set>
+                                    <p:anim calcmode="lin" valueType="num">
+                                      <p:cBhvr additive="base">
+                                        <p:cTn id="33" dur="500" fill="hold"/>
+                                        <p:tgtEl>
+                                          <p:spTgt spid="14"/>
+                                        </p:tgtEl>
+                                        <p:attrNameLst>
+                                          <p:attrName>ppt_x</p:attrName>
+                                        </p:attrNameLst>
+                                      </p:cBhvr>
+                                      <p:tavLst>
+                                        <p:tav tm="0">
+                                          <p:val>
+                                            <p:strVal val="#ppt_x"/>
+                                          </p:val>
+                                        </p:tav>
+                                        <p:tav tm="100000">
+                                          <p:val>
+                                            <p:strVal val="#ppt_x"/>
+                                          </p:val>
+                                        </p:tav>
+                                      </p:tavLst>
+                                    </p:anim>
+                                    <p:anim calcmode="lin" valueType="num">
+                                      <p:cBhvr additive="base">
+                                        <p:cTn id="34" dur="500" fill="hold"/>
+                                        <p:tgtEl>
+                                          <p:spTgt spid="14"/>
+                                        </p:tgtEl>
+                                        <p:attrNameLst>
+                                          <p:attrName>ppt_y</p:attrName>
+                                        </p:attrNameLst>
+                                      </p:cBhvr>
+                                      <p:tavLst>
+                                        <p:tav tm="0">
+                                          <p:val>
+                                            <p:strVal val="0-#ppt_h/2"/>
+                                          </p:val>
+                                        </p:tav>
+                                        <p:tav tm="100000">
+                                          <p:val>
+                                            <p:strVal val="#ppt_y"/>
+                                          </p:val>
+                                        </p:tav>
+                                      </p:tavLst>
+                                    </p:anim>
+                                  </p:childTnLst>
+                                </p:cTn>
+                              </p:par>
+                              <p:par>
+                                <p:cTn id="35" presetID="2" presetClass="entr" presetSubtype="1" fill="hold" nodeType="withEffect">
+                                  <p:stCondLst>
+                                    <p:cond delay="0"/>
+                                  </p:stCondLst>
+                                  <p:childTnLst>
+                                    <p:set>
+                                      <p:cBhvr>
+                                        <p:cTn id="36" dur="1" fill="hold">
+                                          <p:stCondLst>
+                                            <p:cond delay="0"/>
+                                          </p:stCondLst>
+                                        </p:cTn>
+                                        <p:tgtEl>
+                                          <p:spTgt spid="12"/>
+                                        </p:tgtEl>
+                                        <p:attrNameLst>
+                                          <p:attrName>style.visibility</p:attrName>
+                                        </p:attrNameLst>
+                                      </p:cBhvr>
+                                      <p:to>
+                                        <p:strVal val="visible"/>
+                                      </p:to>
+                                    </p:set>
+                                    <p:anim calcmode="lin" valueType="num">
+                                      <p:cBhvr additive="base">
+                                        <p:cTn id="37" dur="500" fill="hold"/>
+                                        <p:tgtEl>
+                                          <p:spTgt spid="12"/>
+                                        </p:tgtEl>
+                                        <p:attrNameLst>
+                                          <p:attrName>ppt_x</p:attrName>
+                                        </p:attrNameLst>
+                                      </p:cBhvr>
+                                      <p:tavLst>
+                                        <p:tav tm="0">
+                                          <p:val>
+                                            <p:strVal val="#ppt_x"/>
+                                          </p:val>
+                                        </p:tav>
+                                        <p:tav tm="100000">
+                                          <p:val>
+                                            <p:strVal val="#ppt_x"/>
+                                          </p:val>
+                                        </p:tav>
+                                      </p:tavLst>
+                                    </p:anim>
+                                    <p:anim calcmode="lin" valueType="num">
+                                      <p:cBhvr additive="base">
+                                        <p:cTn id="38" dur="500" fill="hold"/>
+                                        <p:tgtEl>
+                                          <p:spTgt spid="12"/>
+                                        </p:tgtEl>
+                                        <p:attrNameLst>
+                                          <p:attrName>ppt_y</p:attrName>
+                                        </p:attrNameLst>
+                                      </p:cBhvr>
+                                      <p:tavLst>
+                                        <p:tav tm="0">
+                                          <p:val>
+                                            <p:strVal val="0-#ppt_h/2"/>
+                                          </p:val>
+                                        </p:tav>
+                                        <p:tav tm="100000">
+                                          <p:val>
+                                            <p:strVal val="#ppt_y"/>
+                                          </p:val>
+                                        </p:tav>
+                                      </p:tavLst>
+                                    </p:anim>
+                                  </p:childTnLst>
+                                </p:cTn>
+                              </p:par>
+                              <p:par>
+                                <p:cTn id="39" presetID="2" presetClass="entr" presetSubtype="1" fill="hold" grpId="0" nodeType="withEffect">
+                                  <p:stCondLst>
+                                    <p:cond delay="0"/>
+                                  </p:stCondLst>
+                                  <p:childTnLst>
+                                    <p:set>
+                                      <p:cBhvr>
+                                        <p:cTn id="40" dur="1" fill="hold">
+                                          <p:stCondLst>
+                                            <p:cond delay="0"/>
+                                          </p:stCondLst>
+                                        </p:cTn>
+                                        <p:tgtEl>
+                                          <p:spTgt spid="15"/>
+                                        </p:tgtEl>
+                                        <p:attrNameLst>
+                                          <p:attrName>style.visibility</p:attrName>
+                                        </p:attrNameLst>
+                                      </p:cBhvr>
+                                      <p:to>
+                                        <p:strVal val="visible"/>
+                                      </p:to>
+                                    </p:set>
+                                    <p:anim calcmode="lin" valueType="num">
+                                      <p:cBhvr additive="base">
+                                        <p:cTn id="41" dur="500" fill="hold"/>
+                                        <p:tgtEl>
+                                          <p:spTgt spid="15"/>
+                                        </p:tgtEl>
+                                        <p:attrNameLst>
+                                          <p:attrName>ppt_x</p:attrName>
+                                        </p:attrNameLst>
+                                      </p:cBhvr>
+                                      <p:tavLst>
+                                        <p:tav tm="0">
+                                          <p:val>
+                                            <p:strVal val="#ppt_x"/>
+                                          </p:val>
+                                        </p:tav>
+                                        <p:tav tm="100000">
+                                          <p:val>
+                                            <p:strVal val="#ppt_x"/>
+                                          </p:val>
+                                        </p:tav>
+                                      </p:tavLst>
+                                    </p:anim>
+                                    <p:anim calcmode="lin" valueType="num">
+                                      <p:cBhvr additive="base">
+                                        <p:cTn id="42" dur="500" fill="hold"/>
+                                        <p:tgtEl>
+                                          <p:spTgt spid="15"/>
+                                        </p:tgtEl>
+                                        <p:attrNameLst>
+                                          <p:attrName>ppt_y</p:attrName>
+                                        </p:attrNameLst>
+                                      </p:cBhvr>
+                                      <p:tavLst>
+                                        <p:tav tm="0">
+                                          <p:val>
+                                            <p:strVal val="0-#ppt_h/2"/>
+                                          </p:val>
+                                        </p:tav>
+                                        <p:tav tm="100000">
+                                          <p:val>
+                                            <p:strVal val="#ppt_y"/>
+                                          </p:val>
+                                        </p:tav>
+                                      </p:tavLst>
+                                    </p:anim>
+                                  </p:childTnLst>
+                                </p:cTn>
+                              </p:par>
+                            </p:childTnLst>
+                          </p:cTn>
+                        </p:par>
+                      </p:childTnLst>
+                    </p:cTn>
+                  </p:par>
+                  <p:par>
+                    <p:cTn id="43" fill="hold">
+                      <p:stCondLst>
+                        <p:cond delay="indefinite"/>
+                      </p:stCondLst>
+                      <p:childTnLst>
+                        <p:par>
+                          <p:cTn id="44" fill="hold">
+                            <p:stCondLst>
+                              <p:cond delay="0"/>
+                            </p:stCondLst>
+                            <p:childTnLst>
+                              <p:par>
+                                <p:cTn id="45" presetID="2" presetClass="entr" presetSubtype="4" fill="hold" nodeType="clickEffect">
+                                  <p:stCondLst>
+                                    <p:cond delay="0"/>
+                                  </p:stCondLst>
+                                  <p:childTnLst>
+                                    <p:set>
+                                      <p:cBhvr>
+                                        <p:cTn id="46" dur="1" fill="hold">
+                                          <p:stCondLst>
+                                            <p:cond delay="0"/>
+                                          </p:stCondLst>
+                                        </p:cTn>
+                                        <p:tgtEl>
+                                          <p:spTgt spid="16"/>
+                                        </p:tgtEl>
+                                        <p:attrNameLst>
+                                          <p:attrName>style.visibility</p:attrName>
+                                        </p:attrNameLst>
+                                      </p:cBhvr>
+                                      <p:to>
+                                        <p:strVal val="visible"/>
+                                      </p:to>
+                                    </p:set>
+                                    <p:anim calcmode="lin" valueType="num">
+                                      <p:cBhvr additive="base">
+                                        <p:cTn id="47" dur="500" fill="hold"/>
+                                        <p:tgtEl>
+                                          <p:spTgt spid="16"/>
+                                        </p:tgtEl>
+                                        <p:attrNameLst>
+                                          <p:attrName>ppt_x</p:attrName>
+                                        </p:attrNameLst>
+                                      </p:cBhvr>
+                                      <p:tavLst>
+                                        <p:tav tm="0">
+                                          <p:val>
+                                            <p:strVal val="#ppt_x"/>
+                                          </p:val>
+                                        </p:tav>
+                                        <p:tav tm="100000">
+                                          <p:val>
+                                            <p:strVal val="#ppt_x"/>
+                                          </p:val>
+                                        </p:tav>
+                                      </p:tavLst>
+                                    </p:anim>
+                                    <p:anim calcmode="lin" valueType="num">
+                                      <p:cBhvr additive="base">
+                                        <p:cTn id="48" dur="500" fill="hold"/>
+                                        <p:tgtEl>
+                                          <p:spTgt spid="16"/>
+                                        </p:tgtEl>
+                                        <p:attrNameLst>
+                                          <p:attrName>ppt_y</p:attrName>
+                                        </p:attrNameLst>
+                                      </p:cBhvr>
+                                      <p:tavLst>
+                                        <p:tav tm="0">
+                                          <p:val>
+                                            <p:strVal val="1+#ppt_h/2"/>
+                                          </p:val>
+                                        </p:tav>
+                                        <p:tav tm="100000">
+                                          <p:val>
+                                            <p:strVal val="#ppt_y"/>
+                                          </p:val>
+                                        </p:tav>
+                                      </p:tavLst>
+                                    </p:anim>
+                                  </p:childTnLst>
+                                </p:cTn>
+                              </p:par>
+                              <p:par>
+                                <p:cTn id="49" presetID="2" presetClass="entr" presetSubtype="4" fill="hold" grpId="0" nodeType="withEffect">
+                                  <p:stCondLst>
+                                    <p:cond delay="0"/>
+                                  </p:stCondLst>
+                                  <p:childTnLst>
+                                    <p:set>
+                                      <p:cBhvr>
+                                        <p:cTn id="50" dur="1" fill="hold">
+                                          <p:stCondLst>
+                                            <p:cond delay="0"/>
+                                          </p:stCondLst>
+                                        </p:cTn>
+                                        <p:tgtEl>
+                                          <p:spTgt spid="19"/>
+                                        </p:tgtEl>
+                                        <p:attrNameLst>
+                                          <p:attrName>style.visibility</p:attrName>
+                                        </p:attrNameLst>
+                                      </p:cBhvr>
+                                      <p:to>
+                                        <p:strVal val="visible"/>
+                                      </p:to>
+                                    </p:set>
+                                    <p:anim calcmode="lin" valueType="num">
+                                      <p:cBhvr additive="base">
+                                        <p:cTn id="51" dur="500" fill="hold"/>
+                                        <p:tgtEl>
+                                          <p:spTgt spid="19"/>
+                                        </p:tgtEl>
+                                        <p:attrNameLst>
+                                          <p:attrName>ppt_x</p:attrName>
+                                        </p:attrNameLst>
+                                      </p:cBhvr>
+                                      <p:tavLst>
+                                        <p:tav tm="0">
+                                          <p:val>
+                                            <p:strVal val="#ppt_x"/>
+                                          </p:val>
+                                        </p:tav>
+                                        <p:tav tm="100000">
+                                          <p:val>
+                                            <p:strVal val="#ppt_x"/>
+                                          </p:val>
+                                        </p:tav>
+                                      </p:tavLst>
+                                    </p:anim>
+                                    <p:anim calcmode="lin" valueType="num">
+                                      <p:cBhvr additive="base">
+                                        <p:cTn id="52" dur="500" fill="hold"/>
+                                        <p:tgtEl>
+                                          <p:spTgt spid="19"/>
+                                        </p:tgtEl>
+                                        <p:attrNameLst>
+                                          <p:attrName>ppt_y</p:attrName>
+                                        </p:attrNameLst>
+                                      </p:cBhvr>
+                                      <p:tavLst>
+                                        <p:tav tm="0">
+                                          <p:val>
+                                            <p:strVal val="1+#ppt_h/2"/>
+                                          </p:val>
+                                        </p:tav>
+                                        <p:tav tm="100000">
+                                          <p:val>
+                                            <p:strVal val="#ppt_y"/>
+                                          </p:val>
+                                        </p:tav>
+                                      </p:tavLst>
+                                    </p:anim>
+                                  </p:childTnLst>
+                                </p:cTn>
+                              </p:par>
+                              <p:par>
+                                <p:cTn id="53" presetID="2" presetClass="entr" presetSubtype="4" fill="hold" grpId="0" nodeType="withEffect">
+                                  <p:stCondLst>
+                                    <p:cond delay="0"/>
+                                  </p:stCondLst>
+                                  <p:childTnLst>
+                                    <p:set>
+                                      <p:cBhvr>
+                                        <p:cTn id="54" dur="1" fill="hold">
+                                          <p:stCondLst>
+                                            <p:cond delay="0"/>
+                                          </p:stCondLst>
+                                        </p:cTn>
+                                        <p:tgtEl>
+                                          <p:spTgt spid="20"/>
+                                        </p:tgtEl>
+                                        <p:attrNameLst>
+                                          <p:attrName>style.visibility</p:attrName>
+                                        </p:attrNameLst>
+                                      </p:cBhvr>
+                                      <p:to>
+                                        <p:strVal val="visible"/>
+                                      </p:to>
+                                    </p:set>
+                                    <p:anim calcmode="lin" valueType="num">
+                                      <p:cBhvr additive="base">
+                                        <p:cTn id="55" dur="500" fill="hold"/>
+                                        <p:tgtEl>
+                                          <p:spTgt spid="20"/>
+                                        </p:tgtEl>
+                                        <p:attrNameLst>
+                                          <p:attrName>ppt_x</p:attrName>
+                                        </p:attrNameLst>
+                                      </p:cBhvr>
+                                      <p:tavLst>
+                                        <p:tav tm="0">
+                                          <p:val>
+                                            <p:strVal val="#ppt_x"/>
+                                          </p:val>
+                                        </p:tav>
+                                        <p:tav tm="100000">
+                                          <p:val>
+                                            <p:strVal val="#ppt_x"/>
+                                          </p:val>
+                                        </p:tav>
+                                      </p:tavLst>
+                                    </p:anim>
+                                    <p:anim calcmode="lin" valueType="num">
+                                      <p:cBhvr additive="base">
+                                        <p:cTn id="56" dur="500" fill="hold"/>
+                                        <p:tgtEl>
+                                          <p:spTgt spid="20"/>
+                                        </p:tgtEl>
+                                        <p:attrNameLst>
+                                          <p:attrName>ppt_y</p:attrName>
+                                        </p:attrNameLst>
+                                      </p:cBhvr>
+                                      <p:tavLst>
+                                        <p:tav tm="0">
+                                          <p:val>
+                                            <p:strVal val="1+#ppt_h/2"/>
+                                          </p:val>
+                                        </p:tav>
+                                        <p:tav tm="100000">
+                                          <p:val>
+                                            <p:strVal val="#ppt_y"/>
+                                          </p:val>
+                                        </p:tav>
+                                      </p:tavLst>
+                                    </p:anim>
+                                  </p:childTnLst>
+                                </p:cTn>
+                              </p:par>
+                              <p:par>
+                                <p:cTn id="57" presetID="2" presetClass="entr" presetSubtype="4" fill="hold" grpId="0" nodeType="withEffect">
+                                  <p:stCondLst>
+                                    <p:cond delay="0"/>
+                                  </p:stCondLst>
+                                  <p:childTnLst>
+                                    <p:set>
+                                      <p:cBhvr>
+                                        <p:cTn id="58" dur="1" fill="hold">
+                                          <p:stCondLst>
+                                            <p:cond delay="0"/>
+                                          </p:stCondLst>
+                                        </p:cTn>
+                                        <p:tgtEl>
+                                          <p:spTgt spid="18"/>
+                                        </p:tgtEl>
+                                        <p:attrNameLst>
+                                          <p:attrName>style.visibility</p:attrName>
+                                        </p:attrNameLst>
+                                      </p:cBhvr>
+                                      <p:to>
+                                        <p:strVal val="visible"/>
+                                      </p:to>
+                                    </p:set>
+                                    <p:anim calcmode="lin" valueType="num">
+                                      <p:cBhvr additive="base">
+                                        <p:cTn id="59" dur="500" fill="hold"/>
+                                        <p:tgtEl>
+                                          <p:spTgt spid="18"/>
+                                        </p:tgtEl>
+                                        <p:attrNameLst>
+                                          <p:attrName>ppt_x</p:attrName>
+                                        </p:attrNameLst>
+                                      </p:cBhvr>
+                                      <p:tavLst>
+                                        <p:tav tm="0">
+                                          <p:val>
+                                            <p:strVal val="#ppt_x"/>
+                                          </p:val>
+                                        </p:tav>
+                                        <p:tav tm="100000">
+                                          <p:val>
+                                            <p:strVal val="#ppt_x"/>
+                                          </p:val>
+                                        </p:tav>
+                                      </p:tavLst>
+                                    </p:anim>
+                                    <p:anim calcmode="lin" valueType="num">
+                                      <p:cBhvr additive="base">
+                                        <p:cTn id="60" dur="500" fill="hold"/>
+                                        <p:tgtEl>
+                                          <p:spTgt spid="18"/>
+                                        </p:tgtEl>
+                                        <p:attrNameLst>
+                                          <p:attrName>ppt_y</p:attrName>
+                                        </p:attrNameLst>
+                                      </p:cBhvr>
+                                      <p:tavLst>
+                                        <p:tav tm="0">
+                                          <p:val>
+                                            <p:strVal val="1+#ppt_h/2"/>
+                                          </p:val>
+                                        </p:tav>
+                                        <p:tav tm="100000">
+                                          <p:val>
+                                            <p:strVal val="#ppt_y"/>
+                                          </p:val>
+                                        </p:tav>
+                                      </p:tavLst>
+                                    </p:anim>
+                                  </p:childTnLst>
+                                </p:cTn>
+                              </p:par>
+                              <p:par>
+                                <p:cTn id="61" presetID="2" presetClass="entr" presetSubtype="4" fill="hold" nodeType="withEffect">
+                                  <p:stCondLst>
+                                    <p:cond delay="0"/>
+                                  </p:stCondLst>
+                                  <p:childTnLst>
+                                    <p:set>
+                                      <p:cBhvr>
+                                        <p:cTn id="62" dur="1" fill="hold">
+                                          <p:stCondLst>
+                                            <p:cond delay="0"/>
+                                          </p:stCondLst>
+                                        </p:cTn>
+                                        <p:tgtEl>
+                                          <p:spTgt spid="17"/>
+                                        </p:tgtEl>
+                                        <p:attrNameLst>
+                                          <p:attrName>style.visibility</p:attrName>
+                                        </p:attrNameLst>
+                                      </p:cBhvr>
+                                      <p:to>
+                                        <p:strVal val="visible"/>
+                                      </p:to>
+                                    </p:set>
+                                    <p:anim calcmode="lin" valueType="num">
+                                      <p:cBhvr additive="base">
+                                        <p:cTn id="63" dur="500" fill="hold"/>
+                                        <p:tgtEl>
+                                          <p:spTgt spid="17"/>
+                                        </p:tgtEl>
+                                        <p:attrNameLst>
+                                          <p:attrName>ppt_x</p:attrName>
+                                        </p:attrNameLst>
+                                      </p:cBhvr>
+                                      <p:tavLst>
+                                        <p:tav tm="0">
+                                          <p:val>
+                                            <p:strVal val="#ppt_x"/>
+                                          </p:val>
+                                        </p:tav>
+                                        <p:tav tm="100000">
+                                          <p:val>
+                                            <p:strVal val="#ppt_x"/>
+                                          </p:val>
+                                        </p:tav>
+                                      </p:tavLst>
+                                    </p:anim>
+                                    <p:anim calcmode="lin" valueType="num">
+                                      <p:cBhvr additive="base">
+                                        <p:cTn id="64" dur="500" fill="hold"/>
+                                        <p:tgtEl>
+                                          <p:spTgt spid="17"/>
+                                        </p:tgtEl>
+                                        <p:attrNameLst>
+                                          <p:attrName>ppt_y</p:attrName>
+                                        </p:attrNameLst>
+                                      </p:cBhvr>
+                                      <p:tavLst>
+                                        <p:tav tm="0">
+                                          <p:val>
+                                            <p:strVal val="1+#ppt_h/2"/>
+                                          </p:val>
+                                        </p:tav>
+                                        <p:tav tm="100000">
+                                          <p:val>
+                                            <p:strVal val="#ppt_y"/>
+                                          </p:val>
+                                        </p:tav>
+                                      </p:tavLst>
+                                    </p:anim>
+                                  </p:childTnLst>
+                                </p:cTn>
+                              </p:par>
+                            </p:childTnLst>
+                          </p:cTn>
+                        </p:par>
+                      </p:childTnLst>
+                    </p:cTn>
+                  </p:par>
+                  <p:par>
+                    <p:cTn id="65" fill="hold">
+                      <p:stCondLst>
+                        <p:cond delay="indefinite"/>
+                      </p:stCondLst>
+                      <p:childTnLst>
+                        <p:par>
+                          <p:cTn id="66" fill="hold">
+                            <p:stCondLst>
+                              <p:cond delay="0"/>
+                            </p:stCondLst>
+                            <p:childTnLst>
+                              <p:par>
+                                <p:cTn id="67" presetID="2" presetClass="entr" presetSubtype="4" fill="hold" nodeType="clickEffect">
+                                  <p:stCondLst>
+                                    <p:cond delay="0"/>
+                                  </p:stCondLst>
+                                  <p:childTnLst>
+                                    <p:set>
+                                      <p:cBhvr>
+                                        <p:cTn id="68" dur="1" fill="hold">
+                                          <p:stCondLst>
+                                            <p:cond delay="0"/>
+                                          </p:stCondLst>
+                                        </p:cTn>
+                                        <p:tgtEl>
+                                          <p:spTgt spid="21"/>
+                                        </p:tgtEl>
+                                        <p:attrNameLst>
+                                          <p:attrName>style.visibility</p:attrName>
+                                        </p:attrNameLst>
+                                      </p:cBhvr>
+                                      <p:to>
+                                        <p:strVal val="visible"/>
+                                      </p:to>
+                                    </p:set>
+                                    <p:anim calcmode="lin" valueType="num">
+                                      <p:cBhvr additive="base">
+                                        <p:cTn id="69" dur="500" fill="hold"/>
+                                        <p:tgtEl>
+                                          <p:spTgt spid="21"/>
+                                        </p:tgtEl>
+                                        <p:attrNameLst>
+                                          <p:attrName>ppt_x</p:attrName>
+                                        </p:attrNameLst>
+                                      </p:cBhvr>
+                                      <p:tavLst>
+                                        <p:tav tm="0">
+                                          <p:val>
+                                            <p:strVal val="#ppt_x"/>
+                                          </p:val>
+                                        </p:tav>
+                                        <p:tav tm="100000">
+                                          <p:val>
+                                            <p:strVal val="#ppt_x"/>
+                                          </p:val>
+                                        </p:tav>
+                                      </p:tavLst>
+                                    </p:anim>
+                                    <p:anim calcmode="lin" valueType="num">
+                                      <p:cBhvr additive="base">
+                                        <p:cTn id="70" dur="500" fill="hold"/>
+                                        <p:tgtEl>
+                                          <p:spTgt spid="21"/>
+                                        </p:tgtEl>
+                                        <p:attrNameLst>
+                                          <p:attrName>ppt_y</p:attrName>
+                                        </p:attrNameLst>
+                                      </p:cBhvr>
+                                      <p:tavLst>
+                                        <p:tav tm="0">
+                                          <p:val>
+                                            <p:strVal val="1+#ppt_h/2"/>
+                                          </p:val>
+                                        </p:tav>
+                                        <p:tav tm="100000">
+                                          <p:val>
+                                            <p:strVal val="#ppt_y"/>
+                                          </p:val>
+                                        </p:tav>
+                                      </p:tavLst>
+                                    </p:anim>
+                                  </p:childTnLst>
+                                </p:cTn>
+                              </p:par>
+                              <p:par>
+                                <p:cTn id="71" presetID="2" presetClass="entr" presetSubtype="4" fill="hold" grpId="0" nodeType="withEffect">
+                                  <p:stCondLst>
+                                    <p:cond delay="0"/>
+                                  </p:stCondLst>
+                                  <p:childTnLst>
+                                    <p:set>
+                                      <p:cBhvr>
+                                        <p:cTn id="72" dur="1" fill="hold">
+                                          <p:stCondLst>
+                                            <p:cond delay="0"/>
+                                          </p:stCondLst>
+                                        </p:cTn>
+                                        <p:tgtEl>
+                                          <p:spTgt spid="23"/>
+                                        </p:tgtEl>
+                                        <p:attrNameLst>
+                                          <p:attrName>style.visibility</p:attrName>
+                                        </p:attrNameLst>
+                                      </p:cBhvr>
+                                      <p:to>
+                                        <p:strVal val="visible"/>
+                                      </p:to>
+                                    </p:set>
+                                    <p:anim calcmode="lin" valueType="num">
+                                      <p:cBhvr additive="base">
+                                        <p:cTn id="73" dur="500" fill="hold"/>
+                                        <p:tgtEl>
+                                          <p:spTgt spid="23"/>
+                                        </p:tgtEl>
+                                        <p:attrNameLst>
+                                          <p:attrName>ppt_x</p:attrName>
+                                        </p:attrNameLst>
+                                      </p:cBhvr>
+                                      <p:tavLst>
+                                        <p:tav tm="0">
+                                          <p:val>
+                                            <p:strVal val="#ppt_x"/>
+                                          </p:val>
+                                        </p:tav>
+                                        <p:tav tm="100000">
+                                          <p:val>
+                                            <p:strVal val="#ppt_x"/>
+                                          </p:val>
+                                        </p:tav>
+                                      </p:tavLst>
+                                    </p:anim>
+                                    <p:anim calcmode="lin" valueType="num">
+                                      <p:cBhvr additive="base">
+                                        <p:cTn id="74" dur="500" fill="hold"/>
+                                        <p:tgtEl>
+                                          <p:spTgt spid="23"/>
+                                        </p:tgtEl>
+                                        <p:attrNameLst>
+                                          <p:attrName>ppt_y</p:attrName>
+                                        </p:attrNameLst>
+                                      </p:cBhvr>
+                                      <p:tavLst>
+                                        <p:tav tm="0">
+                                          <p:val>
+                                            <p:strVal val="1+#ppt_h/2"/>
+                                          </p:val>
+                                        </p:tav>
+                                        <p:tav tm="100000">
+                                          <p:val>
+                                            <p:strVal val="#ppt_y"/>
+                                          </p:val>
+                                        </p:tav>
+                                      </p:tavLst>
+                                    </p:anim>
+                                  </p:childTnLst>
+                                </p:cTn>
+                              </p:par>
+                              <p:par>
+                                <p:cTn id="75" presetID="2" presetClass="entr" presetSubtype="4" fill="hold" grpId="0" nodeType="withEffect">
+                                  <p:stCondLst>
+                                    <p:cond delay="0"/>
+                                  </p:stCondLst>
+                                  <p:childTnLst>
+                                    <p:set>
+                                      <p:cBhvr>
+                                        <p:cTn id="76" dur="1" fill="hold">
+                                          <p:stCondLst>
+                                            <p:cond delay="0"/>
+                                          </p:stCondLst>
+                                        </p:cTn>
+                                        <p:tgtEl>
+                                          <p:spTgt spid="24"/>
+                                        </p:tgtEl>
+                                        <p:attrNameLst>
+                                          <p:attrName>style.visibility</p:attrName>
+                                        </p:attrNameLst>
+                                      </p:cBhvr>
+                                      <p:to>
+                                        <p:strVal val="visible"/>
+                                      </p:to>
+                                    </p:set>
+                                    <p:anim calcmode="lin" valueType="num">
+                                      <p:cBhvr additive="base">
+                                        <p:cTn id="77" dur="500" fill="hold"/>
+                                        <p:tgtEl>
+                                          <p:spTgt spid="24"/>
+                                        </p:tgtEl>
+                                        <p:attrNameLst>
+                                          <p:attrName>ppt_x</p:attrName>
+                                        </p:attrNameLst>
+                                      </p:cBhvr>
+                                      <p:tavLst>
+                                        <p:tav tm="0">
+                                          <p:val>
+                                            <p:strVal val="#ppt_x"/>
+                                          </p:val>
+                                        </p:tav>
+                                        <p:tav tm="100000">
+                                          <p:val>
+                                            <p:strVal val="#ppt_x"/>
+                                          </p:val>
+                                        </p:tav>
+                                      </p:tavLst>
+                                    </p:anim>
+                                    <p:anim calcmode="lin" valueType="num">
+                                      <p:cBhvr additive="base">
+                                        <p:cTn id="78" dur="500" fill="hold"/>
+                                        <p:tgtEl>
+                                          <p:spTgt spid="24"/>
+                                        </p:tgtEl>
+                                        <p:attrNameLst>
+                                          <p:attrName>ppt_y</p:attrName>
+                                        </p:attrNameLst>
+                                      </p:cBhvr>
+                                      <p:tavLst>
+                                        <p:tav tm="0">
+                                          <p:val>
+                                            <p:strVal val="1+#ppt_h/2"/>
+                                          </p:val>
+                                        </p:tav>
+                                        <p:tav tm="100000">
+                                          <p:val>
+                                            <p:strVal val="#ppt_y"/>
+                                          </p:val>
+                                        </p:tav>
+                                      </p:tavLst>
+                                    </p:anim>
+                                  </p:childTnLst>
+                                </p:cTn>
+                              </p:par>
+                              <p:par>
+                                <p:cTn id="79" presetID="2" presetClass="entr" presetSubtype="4" fill="hold" grpId="0" nodeType="withEffect">
+                                  <p:stCondLst>
+                                    <p:cond delay="0"/>
+                                  </p:stCondLst>
+                                  <p:childTnLst>
+                                    <p:set>
+                                      <p:cBhvr>
+                                        <p:cTn id="80" dur="1" fill="hold">
+                                          <p:stCondLst>
+                                            <p:cond delay="0"/>
+                                          </p:stCondLst>
+                                        </p:cTn>
+                                        <p:tgtEl>
+                                          <p:spTgt spid="25"/>
+                                        </p:tgtEl>
+                                        <p:attrNameLst>
+                                          <p:attrName>style.visibility</p:attrName>
+                                        </p:attrNameLst>
+                                      </p:cBhvr>
+                                      <p:to>
+                                        <p:strVal val="visible"/>
+                                      </p:to>
+                                    </p:set>
+                                    <p:anim calcmode="lin" valueType="num">
+                                      <p:cBhvr additive="base">
+                                        <p:cTn id="81" dur="500" fill="hold"/>
+                                        <p:tgtEl>
+                                          <p:spTgt spid="25"/>
+                                        </p:tgtEl>
+                                        <p:attrNameLst>
+                                          <p:attrName>ppt_x</p:attrName>
+                                        </p:attrNameLst>
+                                      </p:cBhvr>
+                                      <p:tavLst>
+                                        <p:tav tm="0">
+                                          <p:val>
+                                            <p:strVal val="#ppt_x"/>
+                                          </p:val>
+                                        </p:tav>
+                                        <p:tav tm="100000">
+                                          <p:val>
+                                            <p:strVal val="#ppt_x"/>
+                                          </p:val>
+                                        </p:tav>
+                                      </p:tavLst>
+                                    </p:anim>
+                                    <p:anim calcmode="lin" valueType="num">
+                                      <p:cBhvr additive="base">
+                                        <p:cTn id="82" dur="500" fill="hold"/>
+                                        <p:tgtEl>
+                                          <p:spTgt spid="25"/>
+                                        </p:tgtEl>
+                                        <p:attrNameLst>
+                                          <p:attrName>ppt_y</p:attrName>
+                                        </p:attrNameLst>
+                                      </p:cBhvr>
+                                      <p:tavLst>
+                                        <p:tav tm="0">
+                                          <p:val>
+                                            <p:strVal val="1+#ppt_h/2"/>
+                                          </p:val>
+                                        </p:tav>
+                                        <p:tav tm="100000">
+                                          <p:val>
+                                            <p:strVal val="#ppt_y"/>
+                                          </p:val>
+                                        </p:tav>
+                                      </p:tavLst>
+                                    </p:anim>
+                                  </p:childTnLst>
+                                </p:cTn>
+                              </p:par>
+                              <p:par>
+                                <p:cTn id="83" presetID="2" presetClass="entr" presetSubtype="4" fill="hold" nodeType="withEffect">
+                                  <p:stCondLst>
+                                    <p:cond delay="0"/>
+                                  </p:stCondLst>
+                                  <p:childTnLst>
+                                    <p:set>
+                                      <p:cBhvr>
+                                        <p:cTn id="84" dur="1" fill="hold">
+                                          <p:stCondLst>
+                                            <p:cond delay="0"/>
+                                          </p:stCondLst>
+                                        </p:cTn>
+                                        <p:tgtEl>
+                                          <p:spTgt spid="22"/>
+                                        </p:tgtEl>
+                                        <p:attrNameLst>
+                                          <p:attrName>style.visibility</p:attrName>
+                                        </p:attrNameLst>
+                                      </p:cBhvr>
+                                      <p:to>
+                                        <p:strVal val="visible"/>
+                                      </p:to>
+                                    </p:set>
+                                    <p:anim calcmode="lin" valueType="num">
+                                      <p:cBhvr additive="base">
+                                        <p:cTn id="85" dur="500" fill="hold"/>
+                                        <p:tgtEl>
+                                          <p:spTgt spid="22"/>
+                                        </p:tgtEl>
+                                        <p:attrNameLst>
+                                          <p:attrName>ppt_x</p:attrName>
+                                        </p:attrNameLst>
+                                      </p:cBhvr>
+                                      <p:tavLst>
+                                        <p:tav tm="0">
+                                          <p:val>
+                                            <p:strVal val="#ppt_x"/>
+                                          </p:val>
+                                        </p:tav>
+                                        <p:tav tm="100000">
+                                          <p:val>
+                                            <p:strVal val="#ppt_x"/>
+                                          </p:val>
+                                        </p:tav>
+                                      </p:tavLst>
+                                    </p:anim>
+                                    <p:anim calcmode="lin" valueType="num">
+                                      <p:cBhvr additive="base">
+                                        <p:cTn id="86" dur="500" fill="hold"/>
+                                        <p:tgtEl>
+                                          <p:spTgt spid="22"/>
+                                        </p:tgtEl>
+                                        <p:attrNameLst>
+                                          <p:attrName>ppt_y</p:attrName>
+                                        </p:attrNameLst>
+                                      </p:cBhvr>
+                                      <p:tavLst>
+                                        <p:tav tm="0">
+                                          <p:val>
+                                            <p:strVal val="1+#ppt_h/2"/>
+                                          </p:val>
+                                        </p:tav>
+                                        <p:tav tm="100000">
+                                          <p:val>
+                                            <p:strVal val="#ppt_y"/>
+                                          </p:val>
+                                        </p:tav>
+                                      </p:tavLst>
+                                    </p:anim>
+                                  </p:childTnLst>
+                                </p:cTn>
+                              </p:par>
+                            </p:childTnLst>
+                          </p:cTn>
+                        </p:par>
+                      </p:childTnLst>
+                    </p:cTn>
+                  </p:par>
+                </p:childTnLst>
+              </p:cTn>
+              <p:prevCondLst>
+                <p:cond evt="onPrev" delay="0">
+                  <p:tgtEl>
+                    <p:sldTgt/>
+                  </p:tgtEl>
+                </p:cond>
+              </p:prevCondLst>
+              <p:nextCondLst>
+                <p:cond evt="onNext" delay="0">
+                  <p:tgtEl>
+                    <p:sldTgt/>
+                  </p:tgtEl>
+                </p:cond>
+              </p:nextCondLst>
+            </p:seq>
+          </p:childTnLst>
+        </p:cTn>
+      </p:par>
+    </p:tnLst>
+    <p:bldLst>
+      <p:bldP spid="9" grpId="0" animBg="1"/>
+      <p:bldP spid="10" grpId="0" animBg="1"/>
+      <p:bldP spid="13" grpId="0" animBg="1"/>
+      <p:bldP spid="14" grpId="0" animBg="1"/>
+      <p:bldP spid="15" grpId="0" animBg="1"/>
+      <p:bldP spid="18" grpId="0" animBg="1"/>
+      <p:bldP spid="19" grpId="0" animBg="1"/>
+      <p:bldP spid="20" grpId="0" animBg="1"/>
+      <p:bldP spid="23" grpId="0" animBg="1"/>
+      <p:bldP spid="24" grpId="0" animBg="1"/>
+      <p:bldP spid="25" grpId="0" animBg="1"/>
+    </p:bldLst>
+  </p:timing>
 </p:sld>
 </file>
 
@@ -10860,6 +12392,1237 @@
   <p:clrMapOvr>
     <a:masterClrMapping/>
   </p:clrMapOvr>
+  <p:transition spd="slow">
+    <p:wipe dir="r"/>
+  </p:transition>
+  <p:timing>
+    <p:tnLst>
+      <p:par>
+        <p:cTn id="1" dur="indefinite" restart="never" nodeType="tmRoot">
+          <p:childTnLst>
+            <p:seq concurrent="1" nextAc="seek">
+              <p:cTn id="2" dur="indefinite" nodeType="mainSeq">
+                <p:childTnLst>
+                  <p:par>
+                    <p:cTn id="3" fill="hold">
+                      <p:stCondLst>
+                        <p:cond delay="indefinite"/>
+                      </p:stCondLst>
+                      <p:childTnLst>
+                        <p:par>
+                          <p:cTn id="4" fill="hold">
+                            <p:stCondLst>
+                              <p:cond delay="0"/>
+                            </p:stCondLst>
+                            <p:childTnLst>
+                              <p:par>
+                                <p:cTn id="5" presetID="42" presetClass="entr" presetSubtype="0" fill="hold" nodeType="clickEffect">
+                                  <p:stCondLst>
+                                    <p:cond delay="0"/>
+                                  </p:stCondLst>
+                                  <p:childTnLst>
+                                    <p:set>
+                                      <p:cBhvr>
+                                        <p:cTn id="6" dur="1" fill="hold">
+                                          <p:stCondLst>
+                                            <p:cond delay="0"/>
+                                          </p:stCondLst>
+                                        </p:cTn>
+                                        <p:tgtEl>
+                                          <p:spTgt spid="7"/>
+                                        </p:tgtEl>
+                                        <p:attrNameLst>
+                                          <p:attrName>style.visibility</p:attrName>
+                                        </p:attrNameLst>
+                                      </p:cBhvr>
+                                      <p:to>
+                                        <p:strVal val="visible"/>
+                                      </p:to>
+                                    </p:set>
+                                    <p:animEffect transition="in" filter="fade">
+                                      <p:cBhvr>
+                                        <p:cTn id="7" dur="1000"/>
+                                        <p:tgtEl>
+                                          <p:spTgt spid="7"/>
+                                        </p:tgtEl>
+                                      </p:cBhvr>
+                                    </p:animEffect>
+                                    <p:anim calcmode="lin" valueType="num">
+                                      <p:cBhvr>
+                                        <p:cTn id="8" dur="1000" fill="hold"/>
+                                        <p:tgtEl>
+                                          <p:spTgt spid="7"/>
+                                        </p:tgtEl>
+                                        <p:attrNameLst>
+                                          <p:attrName>ppt_x</p:attrName>
+                                        </p:attrNameLst>
+                                      </p:cBhvr>
+                                      <p:tavLst>
+                                        <p:tav tm="0">
+                                          <p:val>
+                                            <p:strVal val="#ppt_x"/>
+                                          </p:val>
+                                        </p:tav>
+                                        <p:tav tm="100000">
+                                          <p:val>
+                                            <p:strVal val="#ppt_x"/>
+                                          </p:val>
+                                        </p:tav>
+                                      </p:tavLst>
+                                    </p:anim>
+                                    <p:anim calcmode="lin" valueType="num">
+                                      <p:cBhvr>
+                                        <p:cTn id="9" dur="1000" fill="hold"/>
+                                        <p:tgtEl>
+                                          <p:spTgt spid="7"/>
+                                        </p:tgtEl>
+                                        <p:attrNameLst>
+                                          <p:attrName>ppt_y</p:attrName>
+                                        </p:attrNameLst>
+                                      </p:cBhvr>
+                                      <p:tavLst>
+                                        <p:tav tm="0">
+                                          <p:val>
+                                            <p:strVal val="#ppt_y+.1"/>
+                                          </p:val>
+                                        </p:tav>
+                                        <p:tav tm="100000">
+                                          <p:val>
+                                            <p:strVal val="#ppt_y"/>
+                                          </p:val>
+                                        </p:tav>
+                                      </p:tavLst>
+                                    </p:anim>
+                                  </p:childTnLst>
+                                </p:cTn>
+                              </p:par>
+                              <p:par>
+                                <p:cTn id="10" presetID="42" presetClass="entr" presetSubtype="0" fill="hold" grpId="0" nodeType="withEffect">
+                                  <p:stCondLst>
+                                    <p:cond delay="0"/>
+                                  </p:stCondLst>
+                                  <p:childTnLst>
+                                    <p:set>
+                                      <p:cBhvr>
+                                        <p:cTn id="11" dur="1" fill="hold">
+                                          <p:stCondLst>
+                                            <p:cond delay="0"/>
+                                          </p:stCondLst>
+                                        </p:cTn>
+                                        <p:tgtEl>
+                                          <p:spTgt spid="9"/>
+                                        </p:tgtEl>
+                                        <p:attrNameLst>
+                                          <p:attrName>style.visibility</p:attrName>
+                                        </p:attrNameLst>
+                                      </p:cBhvr>
+                                      <p:to>
+                                        <p:strVal val="visible"/>
+                                      </p:to>
+                                    </p:set>
+                                    <p:animEffect transition="in" filter="fade">
+                                      <p:cBhvr>
+                                        <p:cTn id="12" dur="1000"/>
+                                        <p:tgtEl>
+                                          <p:spTgt spid="9"/>
+                                        </p:tgtEl>
+                                      </p:cBhvr>
+                                    </p:animEffect>
+                                    <p:anim calcmode="lin" valueType="num">
+                                      <p:cBhvr>
+                                        <p:cTn id="13" dur="1000" fill="hold"/>
+                                        <p:tgtEl>
+                                          <p:spTgt spid="9"/>
+                                        </p:tgtEl>
+                                        <p:attrNameLst>
+                                          <p:attrName>ppt_x</p:attrName>
+                                        </p:attrNameLst>
+                                      </p:cBhvr>
+                                      <p:tavLst>
+                                        <p:tav tm="0">
+                                          <p:val>
+                                            <p:strVal val="#ppt_x"/>
+                                          </p:val>
+                                        </p:tav>
+                                        <p:tav tm="100000">
+                                          <p:val>
+                                            <p:strVal val="#ppt_x"/>
+                                          </p:val>
+                                        </p:tav>
+                                      </p:tavLst>
+                                    </p:anim>
+                                    <p:anim calcmode="lin" valueType="num">
+                                      <p:cBhvr>
+                                        <p:cTn id="14" dur="1000" fill="hold"/>
+                                        <p:tgtEl>
+                                          <p:spTgt spid="9"/>
+                                        </p:tgtEl>
+                                        <p:attrNameLst>
+                                          <p:attrName>ppt_y</p:attrName>
+                                        </p:attrNameLst>
+                                      </p:cBhvr>
+                                      <p:tavLst>
+                                        <p:tav tm="0">
+                                          <p:val>
+                                            <p:strVal val="#ppt_y+.1"/>
+                                          </p:val>
+                                        </p:tav>
+                                        <p:tav tm="100000">
+                                          <p:val>
+                                            <p:strVal val="#ppt_y"/>
+                                          </p:val>
+                                        </p:tav>
+                                      </p:tavLst>
+                                    </p:anim>
+                                  </p:childTnLst>
+                                </p:cTn>
+                              </p:par>
+                              <p:par>
+                                <p:cTn id="15" presetID="42" presetClass="entr" presetSubtype="0" fill="hold" grpId="0" nodeType="withEffect">
+                                  <p:stCondLst>
+                                    <p:cond delay="0"/>
+                                  </p:stCondLst>
+                                  <p:childTnLst>
+                                    <p:set>
+                                      <p:cBhvr>
+                                        <p:cTn id="16" dur="1" fill="hold">
+                                          <p:stCondLst>
+                                            <p:cond delay="0"/>
+                                          </p:stCondLst>
+                                        </p:cTn>
+                                        <p:tgtEl>
+                                          <p:spTgt spid="10"/>
+                                        </p:tgtEl>
+                                        <p:attrNameLst>
+                                          <p:attrName>style.visibility</p:attrName>
+                                        </p:attrNameLst>
+                                      </p:cBhvr>
+                                      <p:to>
+                                        <p:strVal val="visible"/>
+                                      </p:to>
+                                    </p:set>
+                                    <p:animEffect transition="in" filter="fade">
+                                      <p:cBhvr>
+                                        <p:cTn id="17" dur="1000"/>
+                                        <p:tgtEl>
+                                          <p:spTgt spid="10"/>
+                                        </p:tgtEl>
+                                      </p:cBhvr>
+                                    </p:animEffect>
+                                    <p:anim calcmode="lin" valueType="num">
+                                      <p:cBhvr>
+                                        <p:cTn id="18" dur="1000" fill="hold"/>
+                                        <p:tgtEl>
+                                          <p:spTgt spid="10"/>
+                                        </p:tgtEl>
+                                        <p:attrNameLst>
+                                          <p:attrName>ppt_x</p:attrName>
+                                        </p:attrNameLst>
+                                      </p:cBhvr>
+                                      <p:tavLst>
+                                        <p:tav tm="0">
+                                          <p:val>
+                                            <p:strVal val="#ppt_x"/>
+                                          </p:val>
+                                        </p:tav>
+                                        <p:tav tm="100000">
+                                          <p:val>
+                                            <p:strVal val="#ppt_x"/>
+                                          </p:val>
+                                        </p:tav>
+                                      </p:tavLst>
+                                    </p:anim>
+                                    <p:anim calcmode="lin" valueType="num">
+                                      <p:cBhvr>
+                                        <p:cTn id="19" dur="1000" fill="hold"/>
+                                        <p:tgtEl>
+                                          <p:spTgt spid="10"/>
+                                        </p:tgtEl>
+                                        <p:attrNameLst>
+                                          <p:attrName>ppt_y</p:attrName>
+                                        </p:attrNameLst>
+                                      </p:cBhvr>
+                                      <p:tavLst>
+                                        <p:tav tm="0">
+                                          <p:val>
+                                            <p:strVal val="#ppt_y+.1"/>
+                                          </p:val>
+                                        </p:tav>
+                                        <p:tav tm="100000">
+                                          <p:val>
+                                            <p:strVal val="#ppt_y"/>
+                                          </p:val>
+                                        </p:tav>
+                                      </p:tavLst>
+                                    </p:anim>
+                                  </p:childTnLst>
+                                </p:cTn>
+                              </p:par>
+                              <p:par>
+                                <p:cTn id="20" presetID="42" presetClass="entr" presetSubtype="0" fill="hold" grpId="0" nodeType="withEffect">
+                                  <p:stCondLst>
+                                    <p:cond delay="0"/>
+                                  </p:stCondLst>
+                                  <p:childTnLst>
+                                    <p:set>
+                                      <p:cBhvr>
+                                        <p:cTn id="21" dur="1" fill="hold">
+                                          <p:stCondLst>
+                                            <p:cond delay="0"/>
+                                          </p:stCondLst>
+                                        </p:cTn>
+                                        <p:tgtEl>
+                                          <p:spTgt spid="11"/>
+                                        </p:tgtEl>
+                                        <p:attrNameLst>
+                                          <p:attrName>style.visibility</p:attrName>
+                                        </p:attrNameLst>
+                                      </p:cBhvr>
+                                      <p:to>
+                                        <p:strVal val="visible"/>
+                                      </p:to>
+                                    </p:set>
+                                    <p:animEffect transition="in" filter="fade">
+                                      <p:cBhvr>
+                                        <p:cTn id="22" dur="1000"/>
+                                        <p:tgtEl>
+                                          <p:spTgt spid="11"/>
+                                        </p:tgtEl>
+                                      </p:cBhvr>
+                                    </p:animEffect>
+                                    <p:anim calcmode="lin" valueType="num">
+                                      <p:cBhvr>
+                                        <p:cTn id="23" dur="1000" fill="hold"/>
+                                        <p:tgtEl>
+                                          <p:spTgt spid="11"/>
+                                        </p:tgtEl>
+                                        <p:attrNameLst>
+                                          <p:attrName>ppt_x</p:attrName>
+                                        </p:attrNameLst>
+                                      </p:cBhvr>
+                                      <p:tavLst>
+                                        <p:tav tm="0">
+                                          <p:val>
+                                            <p:strVal val="#ppt_x"/>
+                                          </p:val>
+                                        </p:tav>
+                                        <p:tav tm="100000">
+                                          <p:val>
+                                            <p:strVal val="#ppt_x"/>
+                                          </p:val>
+                                        </p:tav>
+                                      </p:tavLst>
+                                    </p:anim>
+                                    <p:anim calcmode="lin" valueType="num">
+                                      <p:cBhvr>
+                                        <p:cTn id="24" dur="1000" fill="hold"/>
+                                        <p:tgtEl>
+                                          <p:spTgt spid="11"/>
+                                        </p:tgtEl>
+                                        <p:attrNameLst>
+                                          <p:attrName>ppt_y</p:attrName>
+                                        </p:attrNameLst>
+                                      </p:cBhvr>
+                                      <p:tavLst>
+                                        <p:tav tm="0">
+                                          <p:val>
+                                            <p:strVal val="#ppt_y+.1"/>
+                                          </p:val>
+                                        </p:tav>
+                                        <p:tav tm="100000">
+                                          <p:val>
+                                            <p:strVal val="#ppt_y"/>
+                                          </p:val>
+                                        </p:tav>
+                                      </p:tavLst>
+                                    </p:anim>
+                                  </p:childTnLst>
+                                </p:cTn>
+                              </p:par>
+                              <p:par>
+                                <p:cTn id="25" presetID="42" presetClass="entr" presetSubtype="0" fill="hold" nodeType="withEffect">
+                                  <p:stCondLst>
+                                    <p:cond delay="0"/>
+                                  </p:stCondLst>
+                                  <p:childTnLst>
+                                    <p:set>
+                                      <p:cBhvr>
+                                        <p:cTn id="26" dur="1" fill="hold">
+                                          <p:stCondLst>
+                                            <p:cond delay="0"/>
+                                          </p:stCondLst>
+                                        </p:cTn>
+                                        <p:tgtEl>
+                                          <p:spTgt spid="8"/>
+                                        </p:tgtEl>
+                                        <p:attrNameLst>
+                                          <p:attrName>style.visibility</p:attrName>
+                                        </p:attrNameLst>
+                                      </p:cBhvr>
+                                      <p:to>
+                                        <p:strVal val="visible"/>
+                                      </p:to>
+                                    </p:set>
+                                    <p:animEffect transition="in" filter="fade">
+                                      <p:cBhvr>
+                                        <p:cTn id="27" dur="1000"/>
+                                        <p:tgtEl>
+                                          <p:spTgt spid="8"/>
+                                        </p:tgtEl>
+                                      </p:cBhvr>
+                                    </p:animEffect>
+                                    <p:anim calcmode="lin" valueType="num">
+                                      <p:cBhvr>
+                                        <p:cTn id="28" dur="1000" fill="hold"/>
+                                        <p:tgtEl>
+                                          <p:spTgt spid="8"/>
+                                        </p:tgtEl>
+                                        <p:attrNameLst>
+                                          <p:attrName>ppt_x</p:attrName>
+                                        </p:attrNameLst>
+                                      </p:cBhvr>
+                                      <p:tavLst>
+                                        <p:tav tm="0">
+                                          <p:val>
+                                            <p:strVal val="#ppt_x"/>
+                                          </p:val>
+                                        </p:tav>
+                                        <p:tav tm="100000">
+                                          <p:val>
+                                            <p:strVal val="#ppt_x"/>
+                                          </p:val>
+                                        </p:tav>
+                                      </p:tavLst>
+                                    </p:anim>
+                                    <p:anim calcmode="lin" valueType="num">
+                                      <p:cBhvr>
+                                        <p:cTn id="29" dur="1000" fill="hold"/>
+                                        <p:tgtEl>
+                                          <p:spTgt spid="8"/>
+                                        </p:tgtEl>
+                                        <p:attrNameLst>
+                                          <p:attrName>ppt_y</p:attrName>
+                                        </p:attrNameLst>
+                                      </p:cBhvr>
+                                      <p:tavLst>
+                                        <p:tav tm="0">
+                                          <p:val>
+                                            <p:strVal val="#ppt_y+.1"/>
+                                          </p:val>
+                                        </p:tav>
+                                        <p:tav tm="100000">
+                                          <p:val>
+                                            <p:strVal val="#ppt_y"/>
+                                          </p:val>
+                                        </p:tav>
+                                      </p:tavLst>
+                                    </p:anim>
+                                  </p:childTnLst>
+                                </p:cTn>
+                              </p:par>
+                            </p:childTnLst>
+                          </p:cTn>
+                        </p:par>
+                      </p:childTnLst>
+                    </p:cTn>
+                  </p:par>
+                  <p:par>
+                    <p:cTn id="30" fill="hold">
+                      <p:stCondLst>
+                        <p:cond delay="indefinite"/>
+                      </p:stCondLst>
+                      <p:childTnLst>
+                        <p:par>
+                          <p:cTn id="31" fill="hold">
+                            <p:stCondLst>
+                              <p:cond delay="0"/>
+                            </p:stCondLst>
+                            <p:childTnLst>
+                              <p:par>
+                                <p:cTn id="32" presetID="42" presetClass="entr" presetSubtype="0" fill="hold" grpId="0" nodeType="clickEffect">
+                                  <p:stCondLst>
+                                    <p:cond delay="0"/>
+                                  </p:stCondLst>
+                                  <p:childTnLst>
+                                    <p:set>
+                                      <p:cBhvr>
+                                        <p:cTn id="33" dur="1" fill="hold">
+                                          <p:stCondLst>
+                                            <p:cond delay="0"/>
+                                          </p:stCondLst>
+                                        </p:cTn>
+                                        <p:tgtEl>
+                                          <p:spTgt spid="16"/>
+                                        </p:tgtEl>
+                                        <p:attrNameLst>
+                                          <p:attrName>style.visibility</p:attrName>
+                                        </p:attrNameLst>
+                                      </p:cBhvr>
+                                      <p:to>
+                                        <p:strVal val="visible"/>
+                                      </p:to>
+                                    </p:set>
+                                    <p:animEffect transition="in" filter="fade">
+                                      <p:cBhvr>
+                                        <p:cTn id="34" dur="1000"/>
+                                        <p:tgtEl>
+                                          <p:spTgt spid="16"/>
+                                        </p:tgtEl>
+                                      </p:cBhvr>
+                                    </p:animEffect>
+                                    <p:anim calcmode="lin" valueType="num">
+                                      <p:cBhvr>
+                                        <p:cTn id="35" dur="1000" fill="hold"/>
+                                        <p:tgtEl>
+                                          <p:spTgt spid="16"/>
+                                        </p:tgtEl>
+                                        <p:attrNameLst>
+                                          <p:attrName>ppt_x</p:attrName>
+                                        </p:attrNameLst>
+                                      </p:cBhvr>
+                                      <p:tavLst>
+                                        <p:tav tm="0">
+                                          <p:val>
+                                            <p:strVal val="#ppt_x"/>
+                                          </p:val>
+                                        </p:tav>
+                                        <p:tav tm="100000">
+                                          <p:val>
+                                            <p:strVal val="#ppt_x"/>
+                                          </p:val>
+                                        </p:tav>
+                                      </p:tavLst>
+                                    </p:anim>
+                                    <p:anim calcmode="lin" valueType="num">
+                                      <p:cBhvr>
+                                        <p:cTn id="36" dur="1000" fill="hold"/>
+                                        <p:tgtEl>
+                                          <p:spTgt spid="16"/>
+                                        </p:tgtEl>
+                                        <p:attrNameLst>
+                                          <p:attrName>ppt_y</p:attrName>
+                                        </p:attrNameLst>
+                                      </p:cBhvr>
+                                      <p:tavLst>
+                                        <p:tav tm="0">
+                                          <p:val>
+                                            <p:strVal val="#ppt_y+.1"/>
+                                          </p:val>
+                                        </p:tav>
+                                        <p:tav tm="100000">
+                                          <p:val>
+                                            <p:strVal val="#ppt_y"/>
+                                          </p:val>
+                                        </p:tav>
+                                      </p:tavLst>
+                                    </p:anim>
+                                  </p:childTnLst>
+                                </p:cTn>
+                              </p:par>
+                              <p:par>
+                                <p:cTn id="37" presetID="42" presetClass="entr" presetSubtype="0" fill="hold" nodeType="withEffect">
+                                  <p:stCondLst>
+                                    <p:cond delay="0"/>
+                                  </p:stCondLst>
+                                  <p:childTnLst>
+                                    <p:set>
+                                      <p:cBhvr>
+                                        <p:cTn id="38" dur="1" fill="hold">
+                                          <p:stCondLst>
+                                            <p:cond delay="0"/>
+                                          </p:stCondLst>
+                                        </p:cTn>
+                                        <p:tgtEl>
+                                          <p:spTgt spid="13"/>
+                                        </p:tgtEl>
+                                        <p:attrNameLst>
+                                          <p:attrName>style.visibility</p:attrName>
+                                        </p:attrNameLst>
+                                      </p:cBhvr>
+                                      <p:to>
+                                        <p:strVal val="visible"/>
+                                      </p:to>
+                                    </p:set>
+                                    <p:animEffect transition="in" filter="fade">
+                                      <p:cBhvr>
+                                        <p:cTn id="39" dur="1000"/>
+                                        <p:tgtEl>
+                                          <p:spTgt spid="13"/>
+                                        </p:tgtEl>
+                                      </p:cBhvr>
+                                    </p:animEffect>
+                                    <p:anim calcmode="lin" valueType="num">
+                                      <p:cBhvr>
+                                        <p:cTn id="40" dur="1000" fill="hold"/>
+                                        <p:tgtEl>
+                                          <p:spTgt spid="13"/>
+                                        </p:tgtEl>
+                                        <p:attrNameLst>
+                                          <p:attrName>ppt_x</p:attrName>
+                                        </p:attrNameLst>
+                                      </p:cBhvr>
+                                      <p:tavLst>
+                                        <p:tav tm="0">
+                                          <p:val>
+                                            <p:strVal val="#ppt_x"/>
+                                          </p:val>
+                                        </p:tav>
+                                        <p:tav tm="100000">
+                                          <p:val>
+                                            <p:strVal val="#ppt_x"/>
+                                          </p:val>
+                                        </p:tav>
+                                      </p:tavLst>
+                                    </p:anim>
+                                    <p:anim calcmode="lin" valueType="num">
+                                      <p:cBhvr>
+                                        <p:cTn id="41" dur="1000" fill="hold"/>
+                                        <p:tgtEl>
+                                          <p:spTgt spid="13"/>
+                                        </p:tgtEl>
+                                        <p:attrNameLst>
+                                          <p:attrName>ppt_y</p:attrName>
+                                        </p:attrNameLst>
+                                      </p:cBhvr>
+                                      <p:tavLst>
+                                        <p:tav tm="0">
+                                          <p:val>
+                                            <p:strVal val="#ppt_y+.1"/>
+                                          </p:val>
+                                        </p:tav>
+                                        <p:tav tm="100000">
+                                          <p:val>
+                                            <p:strVal val="#ppt_y"/>
+                                          </p:val>
+                                        </p:tav>
+                                      </p:tavLst>
+                                    </p:anim>
+                                  </p:childTnLst>
+                                </p:cTn>
+                              </p:par>
+                              <p:par>
+                                <p:cTn id="42" presetID="42" presetClass="entr" presetSubtype="0" fill="hold" grpId="0" nodeType="withEffect">
+                                  <p:stCondLst>
+                                    <p:cond delay="0"/>
+                                  </p:stCondLst>
+                                  <p:childTnLst>
+                                    <p:set>
+                                      <p:cBhvr>
+                                        <p:cTn id="43" dur="1" fill="hold">
+                                          <p:stCondLst>
+                                            <p:cond delay="0"/>
+                                          </p:stCondLst>
+                                        </p:cTn>
+                                        <p:tgtEl>
+                                          <p:spTgt spid="15"/>
+                                        </p:tgtEl>
+                                        <p:attrNameLst>
+                                          <p:attrName>style.visibility</p:attrName>
+                                        </p:attrNameLst>
+                                      </p:cBhvr>
+                                      <p:to>
+                                        <p:strVal val="visible"/>
+                                      </p:to>
+                                    </p:set>
+                                    <p:animEffect transition="in" filter="fade">
+                                      <p:cBhvr>
+                                        <p:cTn id="44" dur="1000"/>
+                                        <p:tgtEl>
+                                          <p:spTgt spid="15"/>
+                                        </p:tgtEl>
+                                      </p:cBhvr>
+                                    </p:animEffect>
+                                    <p:anim calcmode="lin" valueType="num">
+                                      <p:cBhvr>
+                                        <p:cTn id="45" dur="1000" fill="hold"/>
+                                        <p:tgtEl>
+                                          <p:spTgt spid="15"/>
+                                        </p:tgtEl>
+                                        <p:attrNameLst>
+                                          <p:attrName>ppt_x</p:attrName>
+                                        </p:attrNameLst>
+                                      </p:cBhvr>
+                                      <p:tavLst>
+                                        <p:tav tm="0">
+                                          <p:val>
+                                            <p:strVal val="#ppt_x"/>
+                                          </p:val>
+                                        </p:tav>
+                                        <p:tav tm="100000">
+                                          <p:val>
+                                            <p:strVal val="#ppt_x"/>
+                                          </p:val>
+                                        </p:tav>
+                                      </p:tavLst>
+                                    </p:anim>
+                                    <p:anim calcmode="lin" valueType="num">
+                                      <p:cBhvr>
+                                        <p:cTn id="46" dur="1000" fill="hold"/>
+                                        <p:tgtEl>
+                                          <p:spTgt spid="15"/>
+                                        </p:tgtEl>
+                                        <p:attrNameLst>
+                                          <p:attrName>ppt_y</p:attrName>
+                                        </p:attrNameLst>
+                                      </p:cBhvr>
+                                      <p:tavLst>
+                                        <p:tav tm="0">
+                                          <p:val>
+                                            <p:strVal val="#ppt_y+.1"/>
+                                          </p:val>
+                                        </p:tav>
+                                        <p:tav tm="100000">
+                                          <p:val>
+                                            <p:strVal val="#ppt_y"/>
+                                          </p:val>
+                                        </p:tav>
+                                      </p:tavLst>
+                                    </p:anim>
+                                  </p:childTnLst>
+                                </p:cTn>
+                              </p:par>
+                              <p:par>
+                                <p:cTn id="47" presetID="42" presetClass="entr" presetSubtype="0" fill="hold" nodeType="withEffect">
+                                  <p:stCondLst>
+                                    <p:cond delay="0"/>
+                                  </p:stCondLst>
+                                  <p:childTnLst>
+                                    <p:set>
+                                      <p:cBhvr>
+                                        <p:cTn id="48" dur="1" fill="hold">
+                                          <p:stCondLst>
+                                            <p:cond delay="0"/>
+                                          </p:stCondLst>
+                                        </p:cTn>
+                                        <p:tgtEl>
+                                          <p:spTgt spid="12"/>
+                                        </p:tgtEl>
+                                        <p:attrNameLst>
+                                          <p:attrName>style.visibility</p:attrName>
+                                        </p:attrNameLst>
+                                      </p:cBhvr>
+                                      <p:to>
+                                        <p:strVal val="visible"/>
+                                      </p:to>
+                                    </p:set>
+                                    <p:animEffect transition="in" filter="fade">
+                                      <p:cBhvr>
+                                        <p:cTn id="49" dur="1000"/>
+                                        <p:tgtEl>
+                                          <p:spTgt spid="12"/>
+                                        </p:tgtEl>
+                                      </p:cBhvr>
+                                    </p:animEffect>
+                                    <p:anim calcmode="lin" valueType="num">
+                                      <p:cBhvr>
+                                        <p:cTn id="50" dur="1000" fill="hold"/>
+                                        <p:tgtEl>
+                                          <p:spTgt spid="12"/>
+                                        </p:tgtEl>
+                                        <p:attrNameLst>
+                                          <p:attrName>ppt_x</p:attrName>
+                                        </p:attrNameLst>
+                                      </p:cBhvr>
+                                      <p:tavLst>
+                                        <p:tav tm="0">
+                                          <p:val>
+                                            <p:strVal val="#ppt_x"/>
+                                          </p:val>
+                                        </p:tav>
+                                        <p:tav tm="100000">
+                                          <p:val>
+                                            <p:strVal val="#ppt_x"/>
+                                          </p:val>
+                                        </p:tav>
+                                      </p:tavLst>
+                                    </p:anim>
+                                    <p:anim calcmode="lin" valueType="num">
+                                      <p:cBhvr>
+                                        <p:cTn id="51" dur="1000" fill="hold"/>
+                                        <p:tgtEl>
+                                          <p:spTgt spid="12"/>
+                                        </p:tgtEl>
+                                        <p:attrNameLst>
+                                          <p:attrName>ppt_y</p:attrName>
+                                        </p:attrNameLst>
+                                      </p:cBhvr>
+                                      <p:tavLst>
+                                        <p:tav tm="0">
+                                          <p:val>
+                                            <p:strVal val="#ppt_y+.1"/>
+                                          </p:val>
+                                        </p:tav>
+                                        <p:tav tm="100000">
+                                          <p:val>
+                                            <p:strVal val="#ppt_y"/>
+                                          </p:val>
+                                        </p:tav>
+                                      </p:tavLst>
+                                    </p:anim>
+                                  </p:childTnLst>
+                                </p:cTn>
+                              </p:par>
+                            </p:childTnLst>
+                          </p:cTn>
+                        </p:par>
+                      </p:childTnLst>
+                    </p:cTn>
+                  </p:par>
+                  <p:par>
+                    <p:cTn id="52" fill="hold">
+                      <p:stCondLst>
+                        <p:cond delay="indefinite"/>
+                      </p:stCondLst>
+                      <p:childTnLst>
+                        <p:par>
+                          <p:cTn id="53" fill="hold">
+                            <p:stCondLst>
+                              <p:cond delay="0"/>
+                            </p:stCondLst>
+                            <p:childTnLst>
+                              <p:par>
+                                <p:cTn id="54" presetID="42" presetClass="entr" presetSubtype="0" fill="hold" grpId="0" nodeType="clickEffect">
+                                  <p:stCondLst>
+                                    <p:cond delay="0"/>
+                                  </p:stCondLst>
+                                  <p:childTnLst>
+                                    <p:set>
+                                      <p:cBhvr>
+                                        <p:cTn id="55" dur="1" fill="hold">
+                                          <p:stCondLst>
+                                            <p:cond delay="0"/>
+                                          </p:stCondLst>
+                                        </p:cTn>
+                                        <p:tgtEl>
+                                          <p:spTgt spid="19"/>
+                                        </p:tgtEl>
+                                        <p:attrNameLst>
+                                          <p:attrName>style.visibility</p:attrName>
+                                        </p:attrNameLst>
+                                      </p:cBhvr>
+                                      <p:to>
+                                        <p:strVal val="visible"/>
+                                      </p:to>
+                                    </p:set>
+                                    <p:animEffect transition="in" filter="fade">
+                                      <p:cBhvr>
+                                        <p:cTn id="56" dur="1000"/>
+                                        <p:tgtEl>
+                                          <p:spTgt spid="19"/>
+                                        </p:tgtEl>
+                                      </p:cBhvr>
+                                    </p:animEffect>
+                                    <p:anim calcmode="lin" valueType="num">
+                                      <p:cBhvr>
+                                        <p:cTn id="57" dur="1000" fill="hold"/>
+                                        <p:tgtEl>
+                                          <p:spTgt spid="19"/>
+                                        </p:tgtEl>
+                                        <p:attrNameLst>
+                                          <p:attrName>ppt_x</p:attrName>
+                                        </p:attrNameLst>
+                                      </p:cBhvr>
+                                      <p:tavLst>
+                                        <p:tav tm="0">
+                                          <p:val>
+                                            <p:strVal val="#ppt_x"/>
+                                          </p:val>
+                                        </p:tav>
+                                        <p:tav tm="100000">
+                                          <p:val>
+                                            <p:strVal val="#ppt_x"/>
+                                          </p:val>
+                                        </p:tav>
+                                      </p:tavLst>
+                                    </p:anim>
+                                    <p:anim calcmode="lin" valueType="num">
+                                      <p:cBhvr>
+                                        <p:cTn id="58" dur="1000" fill="hold"/>
+                                        <p:tgtEl>
+                                          <p:spTgt spid="19"/>
+                                        </p:tgtEl>
+                                        <p:attrNameLst>
+                                          <p:attrName>ppt_y</p:attrName>
+                                        </p:attrNameLst>
+                                      </p:cBhvr>
+                                      <p:tavLst>
+                                        <p:tav tm="0">
+                                          <p:val>
+                                            <p:strVal val="#ppt_y+.1"/>
+                                          </p:val>
+                                        </p:tav>
+                                        <p:tav tm="100000">
+                                          <p:val>
+                                            <p:strVal val="#ppt_y"/>
+                                          </p:val>
+                                        </p:tav>
+                                      </p:tavLst>
+                                    </p:anim>
+                                  </p:childTnLst>
+                                </p:cTn>
+                              </p:par>
+                              <p:par>
+                                <p:cTn id="59" presetID="42" presetClass="entr" presetSubtype="0" fill="hold" nodeType="withEffect">
+                                  <p:stCondLst>
+                                    <p:cond delay="0"/>
+                                  </p:stCondLst>
+                                  <p:childTnLst>
+                                    <p:set>
+                                      <p:cBhvr>
+                                        <p:cTn id="60" dur="1" fill="hold">
+                                          <p:stCondLst>
+                                            <p:cond delay="0"/>
+                                          </p:stCondLst>
+                                        </p:cTn>
+                                        <p:tgtEl>
+                                          <p:spTgt spid="17"/>
+                                        </p:tgtEl>
+                                        <p:attrNameLst>
+                                          <p:attrName>style.visibility</p:attrName>
+                                        </p:attrNameLst>
+                                      </p:cBhvr>
+                                      <p:to>
+                                        <p:strVal val="visible"/>
+                                      </p:to>
+                                    </p:set>
+                                    <p:animEffect transition="in" filter="fade">
+                                      <p:cBhvr>
+                                        <p:cTn id="61" dur="1000"/>
+                                        <p:tgtEl>
+                                          <p:spTgt spid="17"/>
+                                        </p:tgtEl>
+                                      </p:cBhvr>
+                                    </p:animEffect>
+                                    <p:anim calcmode="lin" valueType="num">
+                                      <p:cBhvr>
+                                        <p:cTn id="62" dur="1000" fill="hold"/>
+                                        <p:tgtEl>
+                                          <p:spTgt spid="17"/>
+                                        </p:tgtEl>
+                                        <p:attrNameLst>
+                                          <p:attrName>ppt_x</p:attrName>
+                                        </p:attrNameLst>
+                                      </p:cBhvr>
+                                      <p:tavLst>
+                                        <p:tav tm="0">
+                                          <p:val>
+                                            <p:strVal val="#ppt_x"/>
+                                          </p:val>
+                                        </p:tav>
+                                        <p:tav tm="100000">
+                                          <p:val>
+                                            <p:strVal val="#ppt_x"/>
+                                          </p:val>
+                                        </p:tav>
+                                      </p:tavLst>
+                                    </p:anim>
+                                    <p:anim calcmode="lin" valueType="num">
+                                      <p:cBhvr>
+                                        <p:cTn id="63" dur="1000" fill="hold"/>
+                                        <p:tgtEl>
+                                          <p:spTgt spid="17"/>
+                                        </p:tgtEl>
+                                        <p:attrNameLst>
+                                          <p:attrName>ppt_y</p:attrName>
+                                        </p:attrNameLst>
+                                      </p:cBhvr>
+                                      <p:tavLst>
+                                        <p:tav tm="0">
+                                          <p:val>
+                                            <p:strVal val="#ppt_y+.1"/>
+                                          </p:val>
+                                        </p:tav>
+                                        <p:tav tm="100000">
+                                          <p:val>
+                                            <p:strVal val="#ppt_y"/>
+                                          </p:val>
+                                        </p:tav>
+                                      </p:tavLst>
+                                    </p:anim>
+                                  </p:childTnLst>
+                                </p:cTn>
+                              </p:par>
+                              <p:par>
+                                <p:cTn id="64" presetID="42" presetClass="entr" presetSubtype="0" fill="hold" grpId="0" nodeType="withEffect">
+                                  <p:stCondLst>
+                                    <p:cond delay="0"/>
+                                  </p:stCondLst>
+                                  <p:childTnLst>
+                                    <p:set>
+                                      <p:cBhvr>
+                                        <p:cTn id="65" dur="1" fill="hold">
+                                          <p:stCondLst>
+                                            <p:cond delay="0"/>
+                                          </p:stCondLst>
+                                        </p:cTn>
+                                        <p:tgtEl>
+                                          <p:spTgt spid="20"/>
+                                        </p:tgtEl>
+                                        <p:attrNameLst>
+                                          <p:attrName>style.visibility</p:attrName>
+                                        </p:attrNameLst>
+                                      </p:cBhvr>
+                                      <p:to>
+                                        <p:strVal val="visible"/>
+                                      </p:to>
+                                    </p:set>
+                                    <p:animEffect transition="in" filter="fade">
+                                      <p:cBhvr>
+                                        <p:cTn id="66" dur="1000"/>
+                                        <p:tgtEl>
+                                          <p:spTgt spid="20"/>
+                                        </p:tgtEl>
+                                      </p:cBhvr>
+                                    </p:animEffect>
+                                    <p:anim calcmode="lin" valueType="num">
+                                      <p:cBhvr>
+                                        <p:cTn id="67" dur="1000" fill="hold"/>
+                                        <p:tgtEl>
+                                          <p:spTgt spid="20"/>
+                                        </p:tgtEl>
+                                        <p:attrNameLst>
+                                          <p:attrName>ppt_x</p:attrName>
+                                        </p:attrNameLst>
+                                      </p:cBhvr>
+                                      <p:tavLst>
+                                        <p:tav tm="0">
+                                          <p:val>
+                                            <p:strVal val="#ppt_x"/>
+                                          </p:val>
+                                        </p:tav>
+                                        <p:tav tm="100000">
+                                          <p:val>
+                                            <p:strVal val="#ppt_x"/>
+                                          </p:val>
+                                        </p:tav>
+                                      </p:tavLst>
+                                    </p:anim>
+                                    <p:anim calcmode="lin" valueType="num">
+                                      <p:cBhvr>
+                                        <p:cTn id="68" dur="1000" fill="hold"/>
+                                        <p:tgtEl>
+                                          <p:spTgt spid="20"/>
+                                        </p:tgtEl>
+                                        <p:attrNameLst>
+                                          <p:attrName>ppt_y</p:attrName>
+                                        </p:attrNameLst>
+                                      </p:cBhvr>
+                                      <p:tavLst>
+                                        <p:tav tm="0">
+                                          <p:val>
+                                            <p:strVal val="#ppt_y+.1"/>
+                                          </p:val>
+                                        </p:tav>
+                                        <p:tav tm="100000">
+                                          <p:val>
+                                            <p:strVal val="#ppt_y"/>
+                                          </p:val>
+                                        </p:tav>
+                                      </p:tavLst>
+                                    </p:anim>
+                                  </p:childTnLst>
+                                </p:cTn>
+                              </p:par>
+                              <p:par>
+                                <p:cTn id="69" presetID="42" presetClass="entr" presetSubtype="0" fill="hold" grpId="0" nodeType="withEffect">
+                                  <p:stCondLst>
+                                    <p:cond delay="0"/>
+                                  </p:stCondLst>
+                                  <p:childTnLst>
+                                    <p:set>
+                                      <p:cBhvr>
+                                        <p:cTn id="70" dur="1" fill="hold">
+                                          <p:stCondLst>
+                                            <p:cond delay="0"/>
+                                          </p:stCondLst>
+                                        </p:cTn>
+                                        <p:tgtEl>
+                                          <p:spTgt spid="21"/>
+                                        </p:tgtEl>
+                                        <p:attrNameLst>
+                                          <p:attrName>style.visibility</p:attrName>
+                                        </p:attrNameLst>
+                                      </p:cBhvr>
+                                      <p:to>
+                                        <p:strVal val="visible"/>
+                                      </p:to>
+                                    </p:set>
+                                    <p:animEffect transition="in" filter="fade">
+                                      <p:cBhvr>
+                                        <p:cTn id="71" dur="1000"/>
+                                        <p:tgtEl>
+                                          <p:spTgt spid="21"/>
+                                        </p:tgtEl>
+                                      </p:cBhvr>
+                                    </p:animEffect>
+                                    <p:anim calcmode="lin" valueType="num">
+                                      <p:cBhvr>
+                                        <p:cTn id="72" dur="1000" fill="hold"/>
+                                        <p:tgtEl>
+                                          <p:spTgt spid="21"/>
+                                        </p:tgtEl>
+                                        <p:attrNameLst>
+                                          <p:attrName>ppt_x</p:attrName>
+                                        </p:attrNameLst>
+                                      </p:cBhvr>
+                                      <p:tavLst>
+                                        <p:tav tm="0">
+                                          <p:val>
+                                            <p:strVal val="#ppt_x"/>
+                                          </p:val>
+                                        </p:tav>
+                                        <p:tav tm="100000">
+                                          <p:val>
+                                            <p:strVal val="#ppt_x"/>
+                                          </p:val>
+                                        </p:tav>
+                                      </p:tavLst>
+                                    </p:anim>
+                                    <p:anim calcmode="lin" valueType="num">
+                                      <p:cBhvr>
+                                        <p:cTn id="73" dur="1000" fill="hold"/>
+                                        <p:tgtEl>
+                                          <p:spTgt spid="21"/>
+                                        </p:tgtEl>
+                                        <p:attrNameLst>
+                                          <p:attrName>ppt_y</p:attrName>
+                                        </p:attrNameLst>
+                                      </p:cBhvr>
+                                      <p:tavLst>
+                                        <p:tav tm="0">
+                                          <p:val>
+                                            <p:strVal val="#ppt_y+.1"/>
+                                          </p:val>
+                                        </p:tav>
+                                        <p:tav tm="100000">
+                                          <p:val>
+                                            <p:strVal val="#ppt_y"/>
+                                          </p:val>
+                                        </p:tav>
+                                      </p:tavLst>
+                                    </p:anim>
+                                  </p:childTnLst>
+                                </p:cTn>
+                              </p:par>
+                              <p:par>
+                                <p:cTn id="74" presetID="42" presetClass="entr" presetSubtype="0" fill="hold" nodeType="withEffect">
+                                  <p:stCondLst>
+                                    <p:cond delay="0"/>
+                                  </p:stCondLst>
+                                  <p:childTnLst>
+                                    <p:set>
+                                      <p:cBhvr>
+                                        <p:cTn id="75" dur="1" fill="hold">
+                                          <p:stCondLst>
+                                            <p:cond delay="0"/>
+                                          </p:stCondLst>
+                                        </p:cTn>
+                                        <p:tgtEl>
+                                          <p:spTgt spid="18"/>
+                                        </p:tgtEl>
+                                        <p:attrNameLst>
+                                          <p:attrName>style.visibility</p:attrName>
+                                        </p:attrNameLst>
+                                      </p:cBhvr>
+                                      <p:to>
+                                        <p:strVal val="visible"/>
+                                      </p:to>
+                                    </p:set>
+                                    <p:animEffect transition="in" filter="fade">
+                                      <p:cBhvr>
+                                        <p:cTn id="76" dur="1000"/>
+                                        <p:tgtEl>
+                                          <p:spTgt spid="18"/>
+                                        </p:tgtEl>
+                                      </p:cBhvr>
+                                    </p:animEffect>
+                                    <p:anim calcmode="lin" valueType="num">
+                                      <p:cBhvr>
+                                        <p:cTn id="77" dur="1000" fill="hold"/>
+                                        <p:tgtEl>
+                                          <p:spTgt spid="18"/>
+                                        </p:tgtEl>
+                                        <p:attrNameLst>
+                                          <p:attrName>ppt_x</p:attrName>
+                                        </p:attrNameLst>
+                                      </p:cBhvr>
+                                      <p:tavLst>
+                                        <p:tav tm="0">
+                                          <p:val>
+                                            <p:strVal val="#ppt_x"/>
+                                          </p:val>
+                                        </p:tav>
+                                        <p:tav tm="100000">
+                                          <p:val>
+                                            <p:strVal val="#ppt_x"/>
+                                          </p:val>
+                                        </p:tav>
+                                      </p:tavLst>
+                                    </p:anim>
+                                    <p:anim calcmode="lin" valueType="num">
+                                      <p:cBhvr>
+                                        <p:cTn id="78" dur="1000" fill="hold"/>
+                                        <p:tgtEl>
+                                          <p:spTgt spid="18"/>
+                                        </p:tgtEl>
+                                        <p:attrNameLst>
+                                          <p:attrName>ppt_y</p:attrName>
+                                        </p:attrNameLst>
+                                      </p:cBhvr>
+                                      <p:tavLst>
+                                        <p:tav tm="0">
+                                          <p:val>
+                                            <p:strVal val="#ppt_y+.1"/>
+                                          </p:val>
+                                        </p:tav>
+                                        <p:tav tm="100000">
+                                          <p:val>
+                                            <p:strVal val="#ppt_y"/>
+                                          </p:val>
+                                        </p:tav>
+                                      </p:tavLst>
+                                    </p:anim>
+                                  </p:childTnLst>
+                                </p:cTn>
+                              </p:par>
+                            </p:childTnLst>
+                          </p:cTn>
+                        </p:par>
+                      </p:childTnLst>
+                    </p:cTn>
+                  </p:par>
+                </p:childTnLst>
+              </p:cTn>
+              <p:prevCondLst>
+                <p:cond evt="onPrev" delay="0">
+                  <p:tgtEl>
+                    <p:sldTgt/>
+                  </p:tgtEl>
+                </p:cond>
+              </p:prevCondLst>
+              <p:nextCondLst>
+                <p:cond evt="onNext" delay="0">
+                  <p:tgtEl>
+                    <p:sldTgt/>
+                  </p:tgtEl>
+                </p:cond>
+              </p:nextCondLst>
+            </p:seq>
+          </p:childTnLst>
+        </p:cTn>
+      </p:par>
+    </p:tnLst>
+    <p:bldLst>
+      <p:bldP spid="9" grpId="0" animBg="1"/>
+      <p:bldP spid="10" grpId="0" animBg="1"/>
+      <p:bldP spid="11" grpId="0" animBg="1"/>
+      <p:bldP spid="15" grpId="0" animBg="1"/>
+      <p:bldP spid="16" grpId="0" animBg="1"/>
+      <p:bldP spid="19" grpId="0" animBg="1"/>
+      <p:bldP spid="20" grpId="0" animBg="1"/>
+      <p:bldP spid="21" grpId="0" animBg="1"/>
+    </p:bldLst>
+  </p:timing>
 </p:sld>
 </file>
 
@@ -11602,6 +14365,1335 @@
   <p:clrMapOvr>
     <a:masterClrMapping/>
   </p:clrMapOvr>
+  <p:transition spd="slow">
+    <p:wipe dir="r"/>
+  </p:transition>
+  <p:timing>
+    <p:tnLst>
+      <p:par>
+        <p:cTn id="1" dur="indefinite" restart="never" nodeType="tmRoot">
+          <p:childTnLst>
+            <p:seq concurrent="1" nextAc="seek">
+              <p:cTn id="2" dur="indefinite" nodeType="mainSeq">
+                <p:childTnLst>
+                  <p:par>
+                    <p:cTn id="3" fill="hold">
+                      <p:stCondLst>
+                        <p:cond delay="indefinite"/>
+                      </p:stCondLst>
+                      <p:childTnLst>
+                        <p:par>
+                          <p:cTn id="4" fill="hold">
+                            <p:stCondLst>
+                              <p:cond delay="0"/>
+                            </p:stCondLst>
+                            <p:childTnLst>
+                              <p:par>
+                                <p:cTn id="5" presetID="47" presetClass="entr" presetSubtype="0" fill="hold" grpId="0" nodeType="clickEffect">
+                                  <p:stCondLst>
+                                    <p:cond delay="0"/>
+                                  </p:stCondLst>
+                                  <p:childTnLst>
+                                    <p:set>
+                                      <p:cBhvr>
+                                        <p:cTn id="6" dur="1" fill="hold">
+                                          <p:stCondLst>
+                                            <p:cond delay="0"/>
+                                          </p:stCondLst>
+                                        </p:cTn>
+                                        <p:tgtEl>
+                                          <p:spTgt spid="9"/>
+                                        </p:tgtEl>
+                                        <p:attrNameLst>
+                                          <p:attrName>style.visibility</p:attrName>
+                                        </p:attrNameLst>
+                                      </p:cBhvr>
+                                      <p:to>
+                                        <p:strVal val="visible"/>
+                                      </p:to>
+                                    </p:set>
+                                    <p:animEffect transition="in" filter="fade">
+                                      <p:cBhvr>
+                                        <p:cTn id="7" dur="1000"/>
+                                        <p:tgtEl>
+                                          <p:spTgt spid="9"/>
+                                        </p:tgtEl>
+                                      </p:cBhvr>
+                                    </p:animEffect>
+                                    <p:anim calcmode="lin" valueType="num">
+                                      <p:cBhvr>
+                                        <p:cTn id="8" dur="1000" fill="hold"/>
+                                        <p:tgtEl>
+                                          <p:spTgt spid="9"/>
+                                        </p:tgtEl>
+                                        <p:attrNameLst>
+                                          <p:attrName>ppt_x</p:attrName>
+                                        </p:attrNameLst>
+                                      </p:cBhvr>
+                                      <p:tavLst>
+                                        <p:tav tm="0">
+                                          <p:val>
+                                            <p:strVal val="#ppt_x"/>
+                                          </p:val>
+                                        </p:tav>
+                                        <p:tav tm="100000">
+                                          <p:val>
+                                            <p:strVal val="#ppt_x"/>
+                                          </p:val>
+                                        </p:tav>
+                                      </p:tavLst>
+                                    </p:anim>
+                                    <p:anim calcmode="lin" valueType="num">
+                                      <p:cBhvr>
+                                        <p:cTn id="9" dur="1000" fill="hold"/>
+                                        <p:tgtEl>
+                                          <p:spTgt spid="9"/>
+                                        </p:tgtEl>
+                                        <p:attrNameLst>
+                                          <p:attrName>ppt_y</p:attrName>
+                                        </p:attrNameLst>
+                                      </p:cBhvr>
+                                      <p:tavLst>
+                                        <p:tav tm="0">
+                                          <p:val>
+                                            <p:strVal val="#ppt_y-.1"/>
+                                          </p:val>
+                                        </p:tav>
+                                        <p:tav tm="100000">
+                                          <p:val>
+                                            <p:strVal val="#ppt_y"/>
+                                          </p:val>
+                                        </p:tav>
+                                      </p:tavLst>
+                                    </p:anim>
+                                  </p:childTnLst>
+                                </p:cTn>
+                              </p:par>
+                              <p:par>
+                                <p:cTn id="10" presetID="47" presetClass="entr" presetSubtype="0" fill="hold" nodeType="withEffect">
+                                  <p:stCondLst>
+                                    <p:cond delay="0"/>
+                                  </p:stCondLst>
+                                  <p:childTnLst>
+                                    <p:set>
+                                      <p:cBhvr>
+                                        <p:cTn id="11" dur="1" fill="hold">
+                                          <p:stCondLst>
+                                            <p:cond delay="0"/>
+                                          </p:stCondLst>
+                                        </p:cTn>
+                                        <p:tgtEl>
+                                          <p:spTgt spid="6"/>
+                                        </p:tgtEl>
+                                        <p:attrNameLst>
+                                          <p:attrName>style.visibility</p:attrName>
+                                        </p:attrNameLst>
+                                      </p:cBhvr>
+                                      <p:to>
+                                        <p:strVal val="visible"/>
+                                      </p:to>
+                                    </p:set>
+                                    <p:animEffect transition="in" filter="fade">
+                                      <p:cBhvr>
+                                        <p:cTn id="12" dur="1000"/>
+                                        <p:tgtEl>
+                                          <p:spTgt spid="6"/>
+                                        </p:tgtEl>
+                                      </p:cBhvr>
+                                    </p:animEffect>
+                                    <p:anim calcmode="lin" valueType="num">
+                                      <p:cBhvr>
+                                        <p:cTn id="13" dur="1000" fill="hold"/>
+                                        <p:tgtEl>
+                                          <p:spTgt spid="6"/>
+                                        </p:tgtEl>
+                                        <p:attrNameLst>
+                                          <p:attrName>ppt_x</p:attrName>
+                                        </p:attrNameLst>
+                                      </p:cBhvr>
+                                      <p:tavLst>
+                                        <p:tav tm="0">
+                                          <p:val>
+                                            <p:strVal val="#ppt_x"/>
+                                          </p:val>
+                                        </p:tav>
+                                        <p:tav tm="100000">
+                                          <p:val>
+                                            <p:strVal val="#ppt_x"/>
+                                          </p:val>
+                                        </p:tav>
+                                      </p:tavLst>
+                                    </p:anim>
+                                    <p:anim calcmode="lin" valueType="num">
+                                      <p:cBhvr>
+                                        <p:cTn id="14" dur="1000" fill="hold"/>
+                                        <p:tgtEl>
+                                          <p:spTgt spid="6"/>
+                                        </p:tgtEl>
+                                        <p:attrNameLst>
+                                          <p:attrName>ppt_y</p:attrName>
+                                        </p:attrNameLst>
+                                      </p:cBhvr>
+                                      <p:tavLst>
+                                        <p:tav tm="0">
+                                          <p:val>
+                                            <p:strVal val="#ppt_y-.1"/>
+                                          </p:val>
+                                        </p:tav>
+                                        <p:tav tm="100000">
+                                          <p:val>
+                                            <p:strVal val="#ppt_y"/>
+                                          </p:val>
+                                        </p:tav>
+                                      </p:tavLst>
+                                    </p:anim>
+                                  </p:childTnLst>
+                                </p:cTn>
+                              </p:par>
+                              <p:par>
+                                <p:cTn id="15" presetID="47" presetClass="entr" presetSubtype="0" fill="hold" nodeType="withEffect">
+                                  <p:stCondLst>
+                                    <p:cond delay="0"/>
+                                  </p:stCondLst>
+                                  <p:childTnLst>
+                                    <p:set>
+                                      <p:cBhvr>
+                                        <p:cTn id="16" dur="1" fill="hold">
+                                          <p:stCondLst>
+                                            <p:cond delay="0"/>
+                                          </p:stCondLst>
+                                        </p:cTn>
+                                        <p:tgtEl>
+                                          <p:spTgt spid="7"/>
+                                        </p:tgtEl>
+                                        <p:attrNameLst>
+                                          <p:attrName>style.visibility</p:attrName>
+                                        </p:attrNameLst>
+                                      </p:cBhvr>
+                                      <p:to>
+                                        <p:strVal val="visible"/>
+                                      </p:to>
+                                    </p:set>
+                                    <p:animEffect transition="in" filter="fade">
+                                      <p:cBhvr>
+                                        <p:cTn id="17" dur="1000"/>
+                                        <p:tgtEl>
+                                          <p:spTgt spid="7"/>
+                                        </p:tgtEl>
+                                      </p:cBhvr>
+                                    </p:animEffect>
+                                    <p:anim calcmode="lin" valueType="num">
+                                      <p:cBhvr>
+                                        <p:cTn id="18" dur="1000" fill="hold"/>
+                                        <p:tgtEl>
+                                          <p:spTgt spid="7"/>
+                                        </p:tgtEl>
+                                        <p:attrNameLst>
+                                          <p:attrName>ppt_x</p:attrName>
+                                        </p:attrNameLst>
+                                      </p:cBhvr>
+                                      <p:tavLst>
+                                        <p:tav tm="0">
+                                          <p:val>
+                                            <p:strVal val="#ppt_x"/>
+                                          </p:val>
+                                        </p:tav>
+                                        <p:tav tm="100000">
+                                          <p:val>
+                                            <p:strVal val="#ppt_x"/>
+                                          </p:val>
+                                        </p:tav>
+                                      </p:tavLst>
+                                    </p:anim>
+                                    <p:anim calcmode="lin" valueType="num">
+                                      <p:cBhvr>
+                                        <p:cTn id="19" dur="1000" fill="hold"/>
+                                        <p:tgtEl>
+                                          <p:spTgt spid="7"/>
+                                        </p:tgtEl>
+                                        <p:attrNameLst>
+                                          <p:attrName>ppt_y</p:attrName>
+                                        </p:attrNameLst>
+                                      </p:cBhvr>
+                                      <p:tavLst>
+                                        <p:tav tm="0">
+                                          <p:val>
+                                            <p:strVal val="#ppt_y-.1"/>
+                                          </p:val>
+                                        </p:tav>
+                                        <p:tav tm="100000">
+                                          <p:val>
+                                            <p:strVal val="#ppt_y"/>
+                                          </p:val>
+                                        </p:tav>
+                                      </p:tavLst>
+                                    </p:anim>
+                                  </p:childTnLst>
+                                </p:cTn>
+                              </p:par>
+                              <p:par>
+                                <p:cTn id="20" presetID="47" presetClass="entr" presetSubtype="0" fill="hold" grpId="0" nodeType="withEffect">
+                                  <p:stCondLst>
+                                    <p:cond delay="0"/>
+                                  </p:stCondLst>
+                                  <p:childTnLst>
+                                    <p:set>
+                                      <p:cBhvr>
+                                        <p:cTn id="21" dur="1" fill="hold">
+                                          <p:stCondLst>
+                                            <p:cond delay="0"/>
+                                          </p:stCondLst>
+                                        </p:cTn>
+                                        <p:tgtEl>
+                                          <p:spTgt spid="8"/>
+                                        </p:tgtEl>
+                                        <p:attrNameLst>
+                                          <p:attrName>style.visibility</p:attrName>
+                                        </p:attrNameLst>
+                                      </p:cBhvr>
+                                      <p:to>
+                                        <p:strVal val="visible"/>
+                                      </p:to>
+                                    </p:set>
+                                    <p:animEffect transition="in" filter="fade">
+                                      <p:cBhvr>
+                                        <p:cTn id="22" dur="1000"/>
+                                        <p:tgtEl>
+                                          <p:spTgt spid="8"/>
+                                        </p:tgtEl>
+                                      </p:cBhvr>
+                                    </p:animEffect>
+                                    <p:anim calcmode="lin" valueType="num">
+                                      <p:cBhvr>
+                                        <p:cTn id="23" dur="1000" fill="hold"/>
+                                        <p:tgtEl>
+                                          <p:spTgt spid="8"/>
+                                        </p:tgtEl>
+                                        <p:attrNameLst>
+                                          <p:attrName>ppt_x</p:attrName>
+                                        </p:attrNameLst>
+                                      </p:cBhvr>
+                                      <p:tavLst>
+                                        <p:tav tm="0">
+                                          <p:val>
+                                            <p:strVal val="#ppt_x"/>
+                                          </p:val>
+                                        </p:tav>
+                                        <p:tav tm="100000">
+                                          <p:val>
+                                            <p:strVal val="#ppt_x"/>
+                                          </p:val>
+                                        </p:tav>
+                                      </p:tavLst>
+                                    </p:anim>
+                                    <p:anim calcmode="lin" valueType="num">
+                                      <p:cBhvr>
+                                        <p:cTn id="24" dur="1000" fill="hold"/>
+                                        <p:tgtEl>
+                                          <p:spTgt spid="8"/>
+                                        </p:tgtEl>
+                                        <p:attrNameLst>
+                                          <p:attrName>ppt_y</p:attrName>
+                                        </p:attrNameLst>
+                                      </p:cBhvr>
+                                      <p:tavLst>
+                                        <p:tav tm="0">
+                                          <p:val>
+                                            <p:strVal val="#ppt_y-.1"/>
+                                          </p:val>
+                                        </p:tav>
+                                        <p:tav tm="100000">
+                                          <p:val>
+                                            <p:strVal val="#ppt_y"/>
+                                          </p:val>
+                                        </p:tav>
+                                      </p:tavLst>
+                                    </p:anim>
+                                  </p:childTnLst>
+                                </p:cTn>
+                              </p:par>
+                            </p:childTnLst>
+                          </p:cTn>
+                        </p:par>
+                      </p:childTnLst>
+                    </p:cTn>
+                  </p:par>
+                  <p:par>
+                    <p:cTn id="25" fill="hold">
+                      <p:stCondLst>
+                        <p:cond delay="indefinite"/>
+                      </p:stCondLst>
+                      <p:childTnLst>
+                        <p:par>
+                          <p:cTn id="26" fill="hold">
+                            <p:stCondLst>
+                              <p:cond delay="0"/>
+                            </p:stCondLst>
+                            <p:childTnLst>
+                              <p:par>
+                                <p:cTn id="27" presetID="47" presetClass="entr" presetSubtype="0" fill="hold" nodeType="clickEffect">
+                                  <p:stCondLst>
+                                    <p:cond delay="0"/>
+                                  </p:stCondLst>
+                                  <p:childTnLst>
+                                    <p:set>
+                                      <p:cBhvr>
+                                        <p:cTn id="28" dur="1" fill="hold">
+                                          <p:stCondLst>
+                                            <p:cond delay="0"/>
+                                          </p:stCondLst>
+                                        </p:cTn>
+                                        <p:tgtEl>
+                                          <p:spTgt spid="11"/>
+                                        </p:tgtEl>
+                                        <p:attrNameLst>
+                                          <p:attrName>style.visibility</p:attrName>
+                                        </p:attrNameLst>
+                                      </p:cBhvr>
+                                      <p:to>
+                                        <p:strVal val="visible"/>
+                                      </p:to>
+                                    </p:set>
+                                    <p:animEffect transition="in" filter="fade">
+                                      <p:cBhvr>
+                                        <p:cTn id="29" dur="1000"/>
+                                        <p:tgtEl>
+                                          <p:spTgt spid="11"/>
+                                        </p:tgtEl>
+                                      </p:cBhvr>
+                                    </p:animEffect>
+                                    <p:anim calcmode="lin" valueType="num">
+                                      <p:cBhvr>
+                                        <p:cTn id="30" dur="1000" fill="hold"/>
+                                        <p:tgtEl>
+                                          <p:spTgt spid="11"/>
+                                        </p:tgtEl>
+                                        <p:attrNameLst>
+                                          <p:attrName>ppt_x</p:attrName>
+                                        </p:attrNameLst>
+                                      </p:cBhvr>
+                                      <p:tavLst>
+                                        <p:tav tm="0">
+                                          <p:val>
+                                            <p:strVal val="#ppt_x"/>
+                                          </p:val>
+                                        </p:tav>
+                                        <p:tav tm="100000">
+                                          <p:val>
+                                            <p:strVal val="#ppt_x"/>
+                                          </p:val>
+                                        </p:tav>
+                                      </p:tavLst>
+                                    </p:anim>
+                                    <p:anim calcmode="lin" valueType="num">
+                                      <p:cBhvr>
+                                        <p:cTn id="31" dur="1000" fill="hold"/>
+                                        <p:tgtEl>
+                                          <p:spTgt spid="11"/>
+                                        </p:tgtEl>
+                                        <p:attrNameLst>
+                                          <p:attrName>ppt_y</p:attrName>
+                                        </p:attrNameLst>
+                                      </p:cBhvr>
+                                      <p:tavLst>
+                                        <p:tav tm="0">
+                                          <p:val>
+                                            <p:strVal val="#ppt_y-.1"/>
+                                          </p:val>
+                                        </p:tav>
+                                        <p:tav tm="100000">
+                                          <p:val>
+                                            <p:strVal val="#ppt_y"/>
+                                          </p:val>
+                                        </p:tav>
+                                      </p:tavLst>
+                                    </p:anim>
+                                  </p:childTnLst>
+                                </p:cTn>
+                              </p:par>
+                              <p:par>
+                                <p:cTn id="32" presetID="47" presetClass="entr" presetSubtype="0" fill="hold" nodeType="withEffect">
+                                  <p:stCondLst>
+                                    <p:cond delay="0"/>
+                                  </p:stCondLst>
+                                  <p:childTnLst>
+                                    <p:set>
+                                      <p:cBhvr>
+                                        <p:cTn id="33" dur="1" fill="hold">
+                                          <p:stCondLst>
+                                            <p:cond delay="0"/>
+                                          </p:stCondLst>
+                                        </p:cTn>
+                                        <p:tgtEl>
+                                          <p:spTgt spid="10"/>
+                                        </p:tgtEl>
+                                        <p:attrNameLst>
+                                          <p:attrName>style.visibility</p:attrName>
+                                        </p:attrNameLst>
+                                      </p:cBhvr>
+                                      <p:to>
+                                        <p:strVal val="visible"/>
+                                      </p:to>
+                                    </p:set>
+                                    <p:animEffect transition="in" filter="fade">
+                                      <p:cBhvr>
+                                        <p:cTn id="34" dur="1000"/>
+                                        <p:tgtEl>
+                                          <p:spTgt spid="10"/>
+                                        </p:tgtEl>
+                                      </p:cBhvr>
+                                    </p:animEffect>
+                                    <p:anim calcmode="lin" valueType="num">
+                                      <p:cBhvr>
+                                        <p:cTn id="35" dur="1000" fill="hold"/>
+                                        <p:tgtEl>
+                                          <p:spTgt spid="10"/>
+                                        </p:tgtEl>
+                                        <p:attrNameLst>
+                                          <p:attrName>ppt_x</p:attrName>
+                                        </p:attrNameLst>
+                                      </p:cBhvr>
+                                      <p:tavLst>
+                                        <p:tav tm="0">
+                                          <p:val>
+                                            <p:strVal val="#ppt_x"/>
+                                          </p:val>
+                                        </p:tav>
+                                        <p:tav tm="100000">
+                                          <p:val>
+                                            <p:strVal val="#ppt_x"/>
+                                          </p:val>
+                                        </p:tav>
+                                      </p:tavLst>
+                                    </p:anim>
+                                    <p:anim calcmode="lin" valueType="num">
+                                      <p:cBhvr>
+                                        <p:cTn id="36" dur="1000" fill="hold"/>
+                                        <p:tgtEl>
+                                          <p:spTgt spid="10"/>
+                                        </p:tgtEl>
+                                        <p:attrNameLst>
+                                          <p:attrName>ppt_y</p:attrName>
+                                        </p:attrNameLst>
+                                      </p:cBhvr>
+                                      <p:tavLst>
+                                        <p:tav tm="0">
+                                          <p:val>
+                                            <p:strVal val="#ppt_y-.1"/>
+                                          </p:val>
+                                        </p:tav>
+                                        <p:tav tm="100000">
+                                          <p:val>
+                                            <p:strVal val="#ppt_y"/>
+                                          </p:val>
+                                        </p:tav>
+                                      </p:tavLst>
+                                    </p:anim>
+                                  </p:childTnLst>
+                                </p:cTn>
+                              </p:par>
+                              <p:par>
+                                <p:cTn id="37" presetID="47" presetClass="entr" presetSubtype="0" fill="hold" grpId="0" nodeType="withEffect">
+                                  <p:stCondLst>
+                                    <p:cond delay="0"/>
+                                  </p:stCondLst>
+                                  <p:childTnLst>
+                                    <p:set>
+                                      <p:cBhvr>
+                                        <p:cTn id="38" dur="1" fill="hold">
+                                          <p:stCondLst>
+                                            <p:cond delay="0"/>
+                                          </p:stCondLst>
+                                        </p:cTn>
+                                        <p:tgtEl>
+                                          <p:spTgt spid="13"/>
+                                        </p:tgtEl>
+                                        <p:attrNameLst>
+                                          <p:attrName>style.visibility</p:attrName>
+                                        </p:attrNameLst>
+                                      </p:cBhvr>
+                                      <p:to>
+                                        <p:strVal val="visible"/>
+                                      </p:to>
+                                    </p:set>
+                                    <p:animEffect transition="in" filter="fade">
+                                      <p:cBhvr>
+                                        <p:cTn id="39" dur="1000"/>
+                                        <p:tgtEl>
+                                          <p:spTgt spid="13"/>
+                                        </p:tgtEl>
+                                      </p:cBhvr>
+                                    </p:animEffect>
+                                    <p:anim calcmode="lin" valueType="num">
+                                      <p:cBhvr>
+                                        <p:cTn id="40" dur="1000" fill="hold"/>
+                                        <p:tgtEl>
+                                          <p:spTgt spid="13"/>
+                                        </p:tgtEl>
+                                        <p:attrNameLst>
+                                          <p:attrName>ppt_x</p:attrName>
+                                        </p:attrNameLst>
+                                      </p:cBhvr>
+                                      <p:tavLst>
+                                        <p:tav tm="0">
+                                          <p:val>
+                                            <p:strVal val="#ppt_x"/>
+                                          </p:val>
+                                        </p:tav>
+                                        <p:tav tm="100000">
+                                          <p:val>
+                                            <p:strVal val="#ppt_x"/>
+                                          </p:val>
+                                        </p:tav>
+                                      </p:tavLst>
+                                    </p:anim>
+                                    <p:anim calcmode="lin" valueType="num">
+                                      <p:cBhvr>
+                                        <p:cTn id="41" dur="1000" fill="hold"/>
+                                        <p:tgtEl>
+                                          <p:spTgt spid="13"/>
+                                        </p:tgtEl>
+                                        <p:attrNameLst>
+                                          <p:attrName>ppt_y</p:attrName>
+                                        </p:attrNameLst>
+                                      </p:cBhvr>
+                                      <p:tavLst>
+                                        <p:tav tm="0">
+                                          <p:val>
+                                            <p:strVal val="#ppt_y-.1"/>
+                                          </p:val>
+                                        </p:tav>
+                                        <p:tav tm="100000">
+                                          <p:val>
+                                            <p:strVal val="#ppt_y"/>
+                                          </p:val>
+                                        </p:tav>
+                                      </p:tavLst>
+                                    </p:anim>
+                                  </p:childTnLst>
+                                </p:cTn>
+                              </p:par>
+                            </p:childTnLst>
+                          </p:cTn>
+                        </p:par>
+                      </p:childTnLst>
+                    </p:cTn>
+                  </p:par>
+                  <p:par>
+                    <p:cTn id="42" fill="hold">
+                      <p:stCondLst>
+                        <p:cond delay="indefinite"/>
+                      </p:stCondLst>
+                      <p:childTnLst>
+                        <p:par>
+                          <p:cTn id="43" fill="hold">
+                            <p:stCondLst>
+                              <p:cond delay="0"/>
+                            </p:stCondLst>
+                            <p:childTnLst>
+                              <p:par>
+                                <p:cTn id="44" presetID="42" presetClass="entr" presetSubtype="0" fill="hold" grpId="0" nodeType="clickEffect">
+                                  <p:stCondLst>
+                                    <p:cond delay="0"/>
+                                  </p:stCondLst>
+                                  <p:childTnLst>
+                                    <p:set>
+                                      <p:cBhvr>
+                                        <p:cTn id="45" dur="1" fill="hold">
+                                          <p:stCondLst>
+                                            <p:cond delay="0"/>
+                                          </p:stCondLst>
+                                        </p:cTn>
+                                        <p:tgtEl>
+                                          <p:spTgt spid="16"/>
+                                        </p:tgtEl>
+                                        <p:attrNameLst>
+                                          <p:attrName>style.visibility</p:attrName>
+                                        </p:attrNameLst>
+                                      </p:cBhvr>
+                                      <p:to>
+                                        <p:strVal val="visible"/>
+                                      </p:to>
+                                    </p:set>
+                                    <p:animEffect transition="in" filter="fade">
+                                      <p:cBhvr>
+                                        <p:cTn id="46" dur="1000"/>
+                                        <p:tgtEl>
+                                          <p:spTgt spid="16"/>
+                                        </p:tgtEl>
+                                      </p:cBhvr>
+                                    </p:animEffect>
+                                    <p:anim calcmode="lin" valueType="num">
+                                      <p:cBhvr>
+                                        <p:cTn id="47" dur="1000" fill="hold"/>
+                                        <p:tgtEl>
+                                          <p:spTgt spid="16"/>
+                                        </p:tgtEl>
+                                        <p:attrNameLst>
+                                          <p:attrName>ppt_x</p:attrName>
+                                        </p:attrNameLst>
+                                      </p:cBhvr>
+                                      <p:tavLst>
+                                        <p:tav tm="0">
+                                          <p:val>
+                                            <p:strVal val="#ppt_x"/>
+                                          </p:val>
+                                        </p:tav>
+                                        <p:tav tm="100000">
+                                          <p:val>
+                                            <p:strVal val="#ppt_x"/>
+                                          </p:val>
+                                        </p:tav>
+                                      </p:tavLst>
+                                    </p:anim>
+                                    <p:anim calcmode="lin" valueType="num">
+                                      <p:cBhvr>
+                                        <p:cTn id="48" dur="1000" fill="hold"/>
+                                        <p:tgtEl>
+                                          <p:spTgt spid="16"/>
+                                        </p:tgtEl>
+                                        <p:attrNameLst>
+                                          <p:attrName>ppt_y</p:attrName>
+                                        </p:attrNameLst>
+                                      </p:cBhvr>
+                                      <p:tavLst>
+                                        <p:tav tm="0">
+                                          <p:val>
+                                            <p:strVal val="#ppt_y+.1"/>
+                                          </p:val>
+                                        </p:tav>
+                                        <p:tav tm="100000">
+                                          <p:val>
+                                            <p:strVal val="#ppt_y"/>
+                                          </p:val>
+                                        </p:tav>
+                                      </p:tavLst>
+                                    </p:anim>
+                                  </p:childTnLst>
+                                </p:cTn>
+                              </p:par>
+                              <p:par>
+                                <p:cTn id="49" presetID="42" presetClass="entr" presetSubtype="0" fill="hold" nodeType="withEffect">
+                                  <p:stCondLst>
+                                    <p:cond delay="0"/>
+                                  </p:stCondLst>
+                                  <p:childTnLst>
+                                    <p:set>
+                                      <p:cBhvr>
+                                        <p:cTn id="50" dur="1" fill="hold">
+                                          <p:stCondLst>
+                                            <p:cond delay="0"/>
+                                          </p:stCondLst>
+                                        </p:cTn>
+                                        <p:tgtEl>
+                                          <p:spTgt spid="14"/>
+                                        </p:tgtEl>
+                                        <p:attrNameLst>
+                                          <p:attrName>style.visibility</p:attrName>
+                                        </p:attrNameLst>
+                                      </p:cBhvr>
+                                      <p:to>
+                                        <p:strVal val="visible"/>
+                                      </p:to>
+                                    </p:set>
+                                    <p:animEffect transition="in" filter="fade">
+                                      <p:cBhvr>
+                                        <p:cTn id="51" dur="1000"/>
+                                        <p:tgtEl>
+                                          <p:spTgt spid="14"/>
+                                        </p:tgtEl>
+                                      </p:cBhvr>
+                                    </p:animEffect>
+                                    <p:anim calcmode="lin" valueType="num">
+                                      <p:cBhvr>
+                                        <p:cTn id="52" dur="1000" fill="hold"/>
+                                        <p:tgtEl>
+                                          <p:spTgt spid="14"/>
+                                        </p:tgtEl>
+                                        <p:attrNameLst>
+                                          <p:attrName>ppt_x</p:attrName>
+                                        </p:attrNameLst>
+                                      </p:cBhvr>
+                                      <p:tavLst>
+                                        <p:tav tm="0">
+                                          <p:val>
+                                            <p:strVal val="#ppt_x"/>
+                                          </p:val>
+                                        </p:tav>
+                                        <p:tav tm="100000">
+                                          <p:val>
+                                            <p:strVal val="#ppt_x"/>
+                                          </p:val>
+                                        </p:tav>
+                                      </p:tavLst>
+                                    </p:anim>
+                                    <p:anim calcmode="lin" valueType="num">
+                                      <p:cBhvr>
+                                        <p:cTn id="53" dur="1000" fill="hold"/>
+                                        <p:tgtEl>
+                                          <p:spTgt spid="14"/>
+                                        </p:tgtEl>
+                                        <p:attrNameLst>
+                                          <p:attrName>ppt_y</p:attrName>
+                                        </p:attrNameLst>
+                                      </p:cBhvr>
+                                      <p:tavLst>
+                                        <p:tav tm="0">
+                                          <p:val>
+                                            <p:strVal val="#ppt_y+.1"/>
+                                          </p:val>
+                                        </p:tav>
+                                        <p:tav tm="100000">
+                                          <p:val>
+                                            <p:strVal val="#ppt_y"/>
+                                          </p:val>
+                                        </p:tav>
+                                      </p:tavLst>
+                                    </p:anim>
+                                  </p:childTnLst>
+                                </p:cTn>
+                              </p:par>
+                              <p:par>
+                                <p:cTn id="54" presetID="42" presetClass="entr" presetSubtype="0" fill="hold" grpId="0" nodeType="withEffect">
+                                  <p:stCondLst>
+                                    <p:cond delay="0"/>
+                                  </p:stCondLst>
+                                  <p:childTnLst>
+                                    <p:set>
+                                      <p:cBhvr>
+                                        <p:cTn id="55" dur="1" fill="hold">
+                                          <p:stCondLst>
+                                            <p:cond delay="0"/>
+                                          </p:stCondLst>
+                                        </p:cTn>
+                                        <p:tgtEl>
+                                          <p:spTgt spid="17"/>
+                                        </p:tgtEl>
+                                        <p:attrNameLst>
+                                          <p:attrName>style.visibility</p:attrName>
+                                        </p:attrNameLst>
+                                      </p:cBhvr>
+                                      <p:to>
+                                        <p:strVal val="visible"/>
+                                      </p:to>
+                                    </p:set>
+                                    <p:animEffect transition="in" filter="fade">
+                                      <p:cBhvr>
+                                        <p:cTn id="56" dur="1000"/>
+                                        <p:tgtEl>
+                                          <p:spTgt spid="17"/>
+                                        </p:tgtEl>
+                                      </p:cBhvr>
+                                    </p:animEffect>
+                                    <p:anim calcmode="lin" valueType="num">
+                                      <p:cBhvr>
+                                        <p:cTn id="57" dur="1000" fill="hold"/>
+                                        <p:tgtEl>
+                                          <p:spTgt spid="17"/>
+                                        </p:tgtEl>
+                                        <p:attrNameLst>
+                                          <p:attrName>ppt_x</p:attrName>
+                                        </p:attrNameLst>
+                                      </p:cBhvr>
+                                      <p:tavLst>
+                                        <p:tav tm="0">
+                                          <p:val>
+                                            <p:strVal val="#ppt_x"/>
+                                          </p:val>
+                                        </p:tav>
+                                        <p:tav tm="100000">
+                                          <p:val>
+                                            <p:strVal val="#ppt_x"/>
+                                          </p:val>
+                                        </p:tav>
+                                      </p:tavLst>
+                                    </p:anim>
+                                    <p:anim calcmode="lin" valueType="num">
+                                      <p:cBhvr>
+                                        <p:cTn id="58" dur="1000" fill="hold"/>
+                                        <p:tgtEl>
+                                          <p:spTgt spid="17"/>
+                                        </p:tgtEl>
+                                        <p:attrNameLst>
+                                          <p:attrName>ppt_y</p:attrName>
+                                        </p:attrNameLst>
+                                      </p:cBhvr>
+                                      <p:tavLst>
+                                        <p:tav tm="0">
+                                          <p:val>
+                                            <p:strVal val="#ppt_y+.1"/>
+                                          </p:val>
+                                        </p:tav>
+                                        <p:tav tm="100000">
+                                          <p:val>
+                                            <p:strVal val="#ppt_y"/>
+                                          </p:val>
+                                        </p:tav>
+                                      </p:tavLst>
+                                    </p:anim>
+                                  </p:childTnLst>
+                                </p:cTn>
+                              </p:par>
+                              <p:par>
+                                <p:cTn id="59" presetID="42" presetClass="entr" presetSubtype="0" fill="hold" nodeType="withEffect">
+                                  <p:stCondLst>
+                                    <p:cond delay="0"/>
+                                  </p:stCondLst>
+                                  <p:childTnLst>
+                                    <p:set>
+                                      <p:cBhvr>
+                                        <p:cTn id="60" dur="1" fill="hold">
+                                          <p:stCondLst>
+                                            <p:cond delay="0"/>
+                                          </p:stCondLst>
+                                        </p:cTn>
+                                        <p:tgtEl>
+                                          <p:spTgt spid="15"/>
+                                        </p:tgtEl>
+                                        <p:attrNameLst>
+                                          <p:attrName>style.visibility</p:attrName>
+                                        </p:attrNameLst>
+                                      </p:cBhvr>
+                                      <p:to>
+                                        <p:strVal val="visible"/>
+                                      </p:to>
+                                    </p:set>
+                                    <p:animEffect transition="in" filter="fade">
+                                      <p:cBhvr>
+                                        <p:cTn id="61" dur="1000"/>
+                                        <p:tgtEl>
+                                          <p:spTgt spid="15"/>
+                                        </p:tgtEl>
+                                      </p:cBhvr>
+                                    </p:animEffect>
+                                    <p:anim calcmode="lin" valueType="num">
+                                      <p:cBhvr>
+                                        <p:cTn id="62" dur="1000" fill="hold"/>
+                                        <p:tgtEl>
+                                          <p:spTgt spid="15"/>
+                                        </p:tgtEl>
+                                        <p:attrNameLst>
+                                          <p:attrName>ppt_x</p:attrName>
+                                        </p:attrNameLst>
+                                      </p:cBhvr>
+                                      <p:tavLst>
+                                        <p:tav tm="0">
+                                          <p:val>
+                                            <p:strVal val="#ppt_x"/>
+                                          </p:val>
+                                        </p:tav>
+                                        <p:tav tm="100000">
+                                          <p:val>
+                                            <p:strVal val="#ppt_x"/>
+                                          </p:val>
+                                        </p:tav>
+                                      </p:tavLst>
+                                    </p:anim>
+                                    <p:anim calcmode="lin" valueType="num">
+                                      <p:cBhvr>
+                                        <p:cTn id="63" dur="1000" fill="hold"/>
+                                        <p:tgtEl>
+                                          <p:spTgt spid="15"/>
+                                        </p:tgtEl>
+                                        <p:attrNameLst>
+                                          <p:attrName>ppt_y</p:attrName>
+                                        </p:attrNameLst>
+                                      </p:cBhvr>
+                                      <p:tavLst>
+                                        <p:tav tm="0">
+                                          <p:val>
+                                            <p:strVal val="#ppt_y+.1"/>
+                                          </p:val>
+                                        </p:tav>
+                                        <p:tav tm="100000">
+                                          <p:val>
+                                            <p:strVal val="#ppt_y"/>
+                                          </p:val>
+                                        </p:tav>
+                                      </p:tavLst>
+                                    </p:anim>
+                                  </p:childTnLst>
+                                </p:cTn>
+                              </p:par>
+                            </p:childTnLst>
+                          </p:cTn>
+                        </p:par>
+                      </p:childTnLst>
+                    </p:cTn>
+                  </p:par>
+                  <p:par>
+                    <p:cTn id="64" fill="hold">
+                      <p:stCondLst>
+                        <p:cond delay="indefinite"/>
+                      </p:stCondLst>
+                      <p:childTnLst>
+                        <p:par>
+                          <p:cTn id="65" fill="hold">
+                            <p:stCondLst>
+                              <p:cond delay="0"/>
+                            </p:stCondLst>
+                            <p:childTnLst>
+                              <p:par>
+                                <p:cTn id="66" presetID="42" presetClass="entr" presetSubtype="0" fill="hold" grpId="0" nodeType="clickEffect">
+                                  <p:stCondLst>
+                                    <p:cond delay="0"/>
+                                  </p:stCondLst>
+                                  <p:childTnLst>
+                                    <p:set>
+                                      <p:cBhvr>
+                                        <p:cTn id="67" dur="1" fill="hold">
+                                          <p:stCondLst>
+                                            <p:cond delay="0"/>
+                                          </p:stCondLst>
+                                        </p:cTn>
+                                        <p:tgtEl>
+                                          <p:spTgt spid="20"/>
+                                        </p:tgtEl>
+                                        <p:attrNameLst>
+                                          <p:attrName>style.visibility</p:attrName>
+                                        </p:attrNameLst>
+                                      </p:cBhvr>
+                                      <p:to>
+                                        <p:strVal val="visible"/>
+                                      </p:to>
+                                    </p:set>
+                                    <p:animEffect transition="in" filter="fade">
+                                      <p:cBhvr>
+                                        <p:cTn id="68" dur="1000"/>
+                                        <p:tgtEl>
+                                          <p:spTgt spid="20"/>
+                                        </p:tgtEl>
+                                      </p:cBhvr>
+                                    </p:animEffect>
+                                    <p:anim calcmode="lin" valueType="num">
+                                      <p:cBhvr>
+                                        <p:cTn id="69" dur="1000" fill="hold"/>
+                                        <p:tgtEl>
+                                          <p:spTgt spid="20"/>
+                                        </p:tgtEl>
+                                        <p:attrNameLst>
+                                          <p:attrName>ppt_x</p:attrName>
+                                        </p:attrNameLst>
+                                      </p:cBhvr>
+                                      <p:tavLst>
+                                        <p:tav tm="0">
+                                          <p:val>
+                                            <p:strVal val="#ppt_x"/>
+                                          </p:val>
+                                        </p:tav>
+                                        <p:tav tm="100000">
+                                          <p:val>
+                                            <p:strVal val="#ppt_x"/>
+                                          </p:val>
+                                        </p:tav>
+                                      </p:tavLst>
+                                    </p:anim>
+                                    <p:anim calcmode="lin" valueType="num">
+                                      <p:cBhvr>
+                                        <p:cTn id="70" dur="1000" fill="hold"/>
+                                        <p:tgtEl>
+                                          <p:spTgt spid="20"/>
+                                        </p:tgtEl>
+                                        <p:attrNameLst>
+                                          <p:attrName>ppt_y</p:attrName>
+                                        </p:attrNameLst>
+                                      </p:cBhvr>
+                                      <p:tavLst>
+                                        <p:tav tm="0">
+                                          <p:val>
+                                            <p:strVal val="#ppt_y+.1"/>
+                                          </p:val>
+                                        </p:tav>
+                                        <p:tav tm="100000">
+                                          <p:val>
+                                            <p:strVal val="#ppt_y"/>
+                                          </p:val>
+                                        </p:tav>
+                                      </p:tavLst>
+                                    </p:anim>
+                                  </p:childTnLst>
+                                </p:cTn>
+                              </p:par>
+                              <p:par>
+                                <p:cTn id="71" presetID="42" presetClass="entr" presetSubtype="0" fill="hold" nodeType="withEffect">
+                                  <p:stCondLst>
+                                    <p:cond delay="0"/>
+                                  </p:stCondLst>
+                                  <p:childTnLst>
+                                    <p:set>
+                                      <p:cBhvr>
+                                        <p:cTn id="72" dur="1" fill="hold">
+                                          <p:stCondLst>
+                                            <p:cond delay="0"/>
+                                          </p:stCondLst>
+                                        </p:cTn>
+                                        <p:tgtEl>
+                                          <p:spTgt spid="18"/>
+                                        </p:tgtEl>
+                                        <p:attrNameLst>
+                                          <p:attrName>style.visibility</p:attrName>
+                                        </p:attrNameLst>
+                                      </p:cBhvr>
+                                      <p:to>
+                                        <p:strVal val="visible"/>
+                                      </p:to>
+                                    </p:set>
+                                    <p:animEffect transition="in" filter="fade">
+                                      <p:cBhvr>
+                                        <p:cTn id="73" dur="1000"/>
+                                        <p:tgtEl>
+                                          <p:spTgt spid="18"/>
+                                        </p:tgtEl>
+                                      </p:cBhvr>
+                                    </p:animEffect>
+                                    <p:anim calcmode="lin" valueType="num">
+                                      <p:cBhvr>
+                                        <p:cTn id="74" dur="1000" fill="hold"/>
+                                        <p:tgtEl>
+                                          <p:spTgt spid="18"/>
+                                        </p:tgtEl>
+                                        <p:attrNameLst>
+                                          <p:attrName>ppt_x</p:attrName>
+                                        </p:attrNameLst>
+                                      </p:cBhvr>
+                                      <p:tavLst>
+                                        <p:tav tm="0">
+                                          <p:val>
+                                            <p:strVal val="#ppt_x"/>
+                                          </p:val>
+                                        </p:tav>
+                                        <p:tav tm="100000">
+                                          <p:val>
+                                            <p:strVal val="#ppt_x"/>
+                                          </p:val>
+                                        </p:tav>
+                                      </p:tavLst>
+                                    </p:anim>
+                                    <p:anim calcmode="lin" valueType="num">
+                                      <p:cBhvr>
+                                        <p:cTn id="75" dur="1000" fill="hold"/>
+                                        <p:tgtEl>
+                                          <p:spTgt spid="18"/>
+                                        </p:tgtEl>
+                                        <p:attrNameLst>
+                                          <p:attrName>ppt_y</p:attrName>
+                                        </p:attrNameLst>
+                                      </p:cBhvr>
+                                      <p:tavLst>
+                                        <p:tav tm="0">
+                                          <p:val>
+                                            <p:strVal val="#ppt_y+.1"/>
+                                          </p:val>
+                                        </p:tav>
+                                        <p:tav tm="100000">
+                                          <p:val>
+                                            <p:strVal val="#ppt_y"/>
+                                          </p:val>
+                                        </p:tav>
+                                      </p:tavLst>
+                                    </p:anim>
+                                  </p:childTnLst>
+                                </p:cTn>
+                              </p:par>
+                              <p:par>
+                                <p:cTn id="76" presetID="42" presetClass="entr" presetSubtype="0" fill="hold" grpId="0" nodeType="withEffect">
+                                  <p:stCondLst>
+                                    <p:cond delay="0"/>
+                                  </p:stCondLst>
+                                  <p:childTnLst>
+                                    <p:set>
+                                      <p:cBhvr>
+                                        <p:cTn id="77" dur="1" fill="hold">
+                                          <p:stCondLst>
+                                            <p:cond delay="0"/>
+                                          </p:stCondLst>
+                                        </p:cTn>
+                                        <p:tgtEl>
+                                          <p:spTgt spid="21"/>
+                                        </p:tgtEl>
+                                        <p:attrNameLst>
+                                          <p:attrName>style.visibility</p:attrName>
+                                        </p:attrNameLst>
+                                      </p:cBhvr>
+                                      <p:to>
+                                        <p:strVal val="visible"/>
+                                      </p:to>
+                                    </p:set>
+                                    <p:animEffect transition="in" filter="fade">
+                                      <p:cBhvr>
+                                        <p:cTn id="78" dur="1000"/>
+                                        <p:tgtEl>
+                                          <p:spTgt spid="21"/>
+                                        </p:tgtEl>
+                                      </p:cBhvr>
+                                    </p:animEffect>
+                                    <p:anim calcmode="lin" valueType="num">
+                                      <p:cBhvr>
+                                        <p:cTn id="79" dur="1000" fill="hold"/>
+                                        <p:tgtEl>
+                                          <p:spTgt spid="21"/>
+                                        </p:tgtEl>
+                                        <p:attrNameLst>
+                                          <p:attrName>ppt_x</p:attrName>
+                                        </p:attrNameLst>
+                                      </p:cBhvr>
+                                      <p:tavLst>
+                                        <p:tav tm="0">
+                                          <p:val>
+                                            <p:strVal val="#ppt_x"/>
+                                          </p:val>
+                                        </p:tav>
+                                        <p:tav tm="100000">
+                                          <p:val>
+                                            <p:strVal val="#ppt_x"/>
+                                          </p:val>
+                                        </p:tav>
+                                      </p:tavLst>
+                                    </p:anim>
+                                    <p:anim calcmode="lin" valueType="num">
+                                      <p:cBhvr>
+                                        <p:cTn id="80" dur="1000" fill="hold"/>
+                                        <p:tgtEl>
+                                          <p:spTgt spid="21"/>
+                                        </p:tgtEl>
+                                        <p:attrNameLst>
+                                          <p:attrName>ppt_y</p:attrName>
+                                        </p:attrNameLst>
+                                      </p:cBhvr>
+                                      <p:tavLst>
+                                        <p:tav tm="0">
+                                          <p:val>
+                                            <p:strVal val="#ppt_y+.1"/>
+                                          </p:val>
+                                        </p:tav>
+                                        <p:tav tm="100000">
+                                          <p:val>
+                                            <p:strVal val="#ppt_y"/>
+                                          </p:val>
+                                        </p:tav>
+                                      </p:tavLst>
+                                    </p:anim>
+                                  </p:childTnLst>
+                                </p:cTn>
+                              </p:par>
+                              <p:par>
+                                <p:cTn id="81" presetID="42" presetClass="entr" presetSubtype="0" fill="hold" nodeType="withEffect">
+                                  <p:stCondLst>
+                                    <p:cond delay="0"/>
+                                  </p:stCondLst>
+                                  <p:childTnLst>
+                                    <p:set>
+                                      <p:cBhvr>
+                                        <p:cTn id="82" dur="1" fill="hold">
+                                          <p:stCondLst>
+                                            <p:cond delay="0"/>
+                                          </p:stCondLst>
+                                        </p:cTn>
+                                        <p:tgtEl>
+                                          <p:spTgt spid="19"/>
+                                        </p:tgtEl>
+                                        <p:attrNameLst>
+                                          <p:attrName>style.visibility</p:attrName>
+                                        </p:attrNameLst>
+                                      </p:cBhvr>
+                                      <p:to>
+                                        <p:strVal val="visible"/>
+                                      </p:to>
+                                    </p:set>
+                                    <p:animEffect transition="in" filter="fade">
+                                      <p:cBhvr>
+                                        <p:cTn id="83" dur="1000"/>
+                                        <p:tgtEl>
+                                          <p:spTgt spid="19"/>
+                                        </p:tgtEl>
+                                      </p:cBhvr>
+                                    </p:animEffect>
+                                    <p:anim calcmode="lin" valueType="num">
+                                      <p:cBhvr>
+                                        <p:cTn id="84" dur="1000" fill="hold"/>
+                                        <p:tgtEl>
+                                          <p:spTgt spid="19"/>
+                                        </p:tgtEl>
+                                        <p:attrNameLst>
+                                          <p:attrName>ppt_x</p:attrName>
+                                        </p:attrNameLst>
+                                      </p:cBhvr>
+                                      <p:tavLst>
+                                        <p:tav tm="0">
+                                          <p:val>
+                                            <p:strVal val="#ppt_x"/>
+                                          </p:val>
+                                        </p:tav>
+                                        <p:tav tm="100000">
+                                          <p:val>
+                                            <p:strVal val="#ppt_x"/>
+                                          </p:val>
+                                        </p:tav>
+                                      </p:tavLst>
+                                    </p:anim>
+                                    <p:anim calcmode="lin" valueType="num">
+                                      <p:cBhvr>
+                                        <p:cTn id="85" dur="1000" fill="hold"/>
+                                        <p:tgtEl>
+                                          <p:spTgt spid="19"/>
+                                        </p:tgtEl>
+                                        <p:attrNameLst>
+                                          <p:attrName>ppt_y</p:attrName>
+                                        </p:attrNameLst>
+                                      </p:cBhvr>
+                                      <p:tavLst>
+                                        <p:tav tm="0">
+                                          <p:val>
+                                            <p:strVal val="#ppt_y+.1"/>
+                                          </p:val>
+                                        </p:tav>
+                                        <p:tav tm="100000">
+                                          <p:val>
+                                            <p:strVal val="#ppt_y"/>
+                                          </p:val>
+                                        </p:tav>
+                                      </p:tavLst>
+                                    </p:anim>
+                                  </p:childTnLst>
+                                </p:cTn>
+                              </p:par>
+                            </p:childTnLst>
+                          </p:cTn>
+                        </p:par>
+                      </p:childTnLst>
+                    </p:cTn>
+                  </p:par>
+                </p:childTnLst>
+              </p:cTn>
+              <p:prevCondLst>
+                <p:cond evt="onPrev" delay="0">
+                  <p:tgtEl>
+                    <p:sldTgt/>
+                  </p:tgtEl>
+                </p:cond>
+              </p:prevCondLst>
+              <p:nextCondLst>
+                <p:cond evt="onNext" delay="0">
+                  <p:tgtEl>
+                    <p:sldTgt/>
+                  </p:tgtEl>
+                </p:cond>
+              </p:nextCondLst>
+            </p:seq>
+          </p:childTnLst>
+        </p:cTn>
+      </p:par>
+    </p:tnLst>
+    <p:bldLst>
+      <p:bldP spid="8" grpId="0" animBg="1"/>
+      <p:bldP spid="9" grpId="0" animBg="1"/>
+      <p:bldP spid="13" grpId="0" animBg="1"/>
+      <p:bldP spid="16" grpId="0" animBg="1"/>
+      <p:bldP spid="17" grpId="0" animBg="1"/>
+      <p:bldP spid="20" grpId="0" animBg="1"/>
+      <p:bldP spid="21" grpId="0" animBg="1"/>
+    </p:bldLst>
+  </p:timing>
 </p:sld>
 </file>
 
@@ -12769,6 +16861,9 @@
   <p:clrMapOvr>
     <a:masterClrMapping/>
   </p:clrMapOvr>
+  <p:transition spd="slow">
+    <p:wipe dir="r"/>
+  </p:transition>
 </p:sld>
 </file>
 
@@ -12826,13 +16921,16 @@
                 <a:solidFill>
                   <a:srgbClr val="587078"/>
                 </a:solidFill>
-                <a:latin typeface="Arial" pitchFamily="34" charset="0"/>
-                <a:ea typeface="Arial" pitchFamily="34" charset="-122"/>
-                <a:cs typeface="Arial" pitchFamily="34" charset="-120"/>
+                <a:latin typeface="Dubai" panose="020B0503030403030204" pitchFamily="34" charset="-78"/>
+                <a:ea typeface="Arial" pitchFamily="34" charset="-122"/>
+                <a:cs typeface="Dubai" panose="020B0503030403030204" pitchFamily="34" charset="-78"/>
               </a:rPr>
               <a:t>نبض — نظام السجلات الطبية الرقمية</a:t>
             </a:r>
-            <a:endParaRPr lang="ar-SA" sz="900" dirty="0"/>
+            <a:endParaRPr lang="ar-SA" sz="900" dirty="0">
+              <a:latin typeface="Dubai" panose="020B0503030403030204" pitchFamily="34" charset="-78"/>
+              <a:cs typeface="Dubai" panose="020B0503030403030204" pitchFamily="34" charset="-78"/>
+            </a:endParaRPr>
           </a:p>
         </p:txBody>
       </p:sp>
@@ -12904,13 +17002,16 @@
                 <a:solidFill>
                   <a:srgbClr val="0A3540"/>
                 </a:solidFill>
-                <a:latin typeface="Arial" pitchFamily="34" charset="0"/>
-                <a:ea typeface="Arial" pitchFamily="34" charset="-122"/>
-                <a:cs typeface="Arial" pitchFamily="34" charset="-120"/>
+                <a:latin typeface="Dubai" panose="020B0503030403030204" pitchFamily="34" charset="-78"/>
+                <a:ea typeface="Arial" pitchFamily="34" charset="-122"/>
+                <a:cs typeface="Dubai" panose="020B0503030403030204" pitchFamily="34" charset="-78"/>
               </a:rPr>
               <a:t>الطبقة الأولى: لغةٌ موحّدة للبيانات الصحية</a:t>
             </a:r>
-            <a:endParaRPr lang="ar-SA" sz="2900" dirty="0"/>
+            <a:endParaRPr lang="ar-SA" sz="2900" dirty="0">
+              <a:latin typeface="Dubai" panose="020B0503030403030204" pitchFamily="34" charset="-78"/>
+              <a:cs typeface="Dubai" panose="020B0503030403030204" pitchFamily="34" charset="-78"/>
+            </a:endParaRPr>
           </a:p>
         </p:txBody>
       </p:sp>
@@ -12943,9 +17044,9 @@
                 <a:solidFill>
                   <a:srgbClr val="0E7C86"/>
                 </a:solidFill>
-                <a:latin typeface="Arial" pitchFamily="34" charset="0"/>
-                <a:ea typeface="Arial" pitchFamily="34" charset="-122"/>
-                <a:cs typeface="Arial" pitchFamily="34" charset="-120"/>
+                <a:latin typeface="Dubai" panose="020B0503030403030204" pitchFamily="34" charset="-78"/>
+                <a:ea typeface="Arial" pitchFamily="34" charset="-122"/>
+                <a:cs typeface="Dubai" panose="020B0503030403030204" pitchFamily="34" charset="-78"/>
               </a:rPr>
               <a:t>معيار ‏</a:t>
             </a:r>
@@ -12954,9 +17055,9 @@
                 <a:solidFill>
                   <a:srgbClr val="0E7C86"/>
                 </a:solidFill>
-                <a:latin typeface="Arial" pitchFamily="34" charset="0"/>
-                <a:ea typeface="Arial" pitchFamily="34" charset="-122"/>
-                <a:cs typeface="Arial" pitchFamily="34" charset="-120"/>
+                <a:latin typeface="Dubai" panose="020B0503030403030204" pitchFamily="34" charset="-78"/>
+                <a:ea typeface="Arial" pitchFamily="34" charset="-122"/>
+                <a:cs typeface="Dubai" panose="020B0503030403030204" pitchFamily="34" charset="-78"/>
               </a:rPr>
               <a:t>HL7 FHIR</a:t>
             </a:r>
@@ -12965,13 +17066,16 @@
                 <a:solidFill>
                   <a:srgbClr val="0E7C86"/>
                 </a:solidFill>
-                <a:latin typeface="Arial" pitchFamily="34" charset="0"/>
-                <a:ea typeface="Arial" pitchFamily="34" charset="-122"/>
-                <a:cs typeface="Arial" pitchFamily="34" charset="-120"/>
+                <a:latin typeface="Dubai" panose="020B0503030403030204" pitchFamily="34" charset="-78"/>
+                <a:ea typeface="Arial" pitchFamily="34" charset="-122"/>
+                <a:cs typeface="Dubai" panose="020B0503030403030204" pitchFamily="34" charset="-78"/>
               </a:rPr>
               <a:t>‏ العالمي — الإصدار الخامس</a:t>
             </a:r>
-            <a:endParaRPr lang="ar-SA" sz="1400" dirty="0"/>
+            <a:endParaRPr lang="ar-SA" sz="1400" dirty="0">
+              <a:latin typeface="Dubai" panose="020B0503030403030204" pitchFamily="34" charset="-78"/>
+              <a:cs typeface="Dubai" panose="020B0503030403030204" pitchFamily="34" charset="-78"/>
+            </a:endParaRPr>
           </a:p>
         </p:txBody>
       </p:sp>
@@ -13030,61 +17134,64 @@
               <a:buNone/>
             </a:pPr>
             <a:r>
-              <a:rPr lang="ar-SA" altLang="en-US" sz="1550" i="1" dirty="0">
+              <a:rPr lang="ar-SA" altLang="en-US" i="1" dirty="0">
                 <a:solidFill>
                   <a:srgbClr val="0A3540"/>
                 </a:solidFill>
-                <a:latin typeface="Arial" pitchFamily="34" charset="0"/>
-                <a:ea typeface="Arial" pitchFamily="34" charset="-122"/>
-                <a:cs typeface="Arial" pitchFamily="34" charset="-120"/>
+                <a:latin typeface="Dubai" panose="020B0503030403030204" pitchFamily="34" charset="-78"/>
+                <a:ea typeface="Arial" pitchFamily="34" charset="-122"/>
+                <a:cs typeface="Dubai" panose="020B0503030403030204" pitchFamily="34" charset="-78"/>
               </a:rPr>
               <a:t>تماماً كما وحّد منفذ ‏</a:t>
             </a:r>
             <a:r>
-              <a:rPr lang="en-US" altLang="en-US" sz="1550" i="1" dirty="0">
+              <a:rPr lang="en-US" altLang="en-US" i="1" dirty="0">
                 <a:solidFill>
                   <a:srgbClr val="0A3540"/>
                 </a:solidFill>
-                <a:latin typeface="Arial" pitchFamily="34" charset="0"/>
-                <a:ea typeface="Arial" pitchFamily="34" charset="-122"/>
-                <a:cs typeface="Arial" pitchFamily="34" charset="-120"/>
+                <a:latin typeface="Dubai" panose="020B0503030403030204" pitchFamily="34" charset="-78"/>
+                <a:ea typeface="Arial" pitchFamily="34" charset="-122"/>
+                <a:cs typeface="Dubai" panose="020B0503030403030204" pitchFamily="34" charset="-78"/>
               </a:rPr>
               <a:t>USB</a:t>
             </a:r>
             <a:r>
-              <a:rPr lang="ar-SA" altLang="en-US" sz="1550" i="1" dirty="0">
+              <a:rPr lang="ar-SA" altLang="en-US" i="1" dirty="0">
                 <a:solidFill>
                   <a:srgbClr val="0A3540"/>
                 </a:solidFill>
-                <a:latin typeface="Arial" pitchFamily="34" charset="0"/>
-                <a:ea typeface="Arial" pitchFamily="34" charset="-122"/>
-                <a:cs typeface="Arial" pitchFamily="34" charset="-120"/>
+                <a:latin typeface="Dubai" panose="020B0503030403030204" pitchFamily="34" charset="-78"/>
+                <a:ea typeface="Arial" pitchFamily="34" charset="-122"/>
+                <a:cs typeface="Dubai" panose="020B0503030403030204" pitchFamily="34" charset="-78"/>
               </a:rPr>
               <a:t>‏ طريقة توصيل الأجهزة على اختلافها، يوحّد معيار ‏</a:t>
             </a:r>
             <a:r>
-              <a:rPr lang="en-US" altLang="en-US" sz="1550" i="1" dirty="0">
+              <a:rPr lang="en-US" altLang="en-US" i="1" dirty="0">
                 <a:solidFill>
                   <a:srgbClr val="0A3540"/>
                 </a:solidFill>
-                <a:latin typeface="Arial" pitchFamily="34" charset="0"/>
-                <a:ea typeface="Arial" pitchFamily="34" charset="-122"/>
-                <a:cs typeface="Arial" pitchFamily="34" charset="-120"/>
+                <a:latin typeface="Dubai" panose="020B0503030403030204" pitchFamily="34" charset="-78"/>
+                <a:ea typeface="Arial" pitchFamily="34" charset="-122"/>
+                <a:cs typeface="Dubai" panose="020B0503030403030204" pitchFamily="34" charset="-78"/>
               </a:rPr>
               <a:t>FHIR</a:t>
             </a:r>
             <a:r>
-              <a:rPr lang="ar-SA" altLang="en-US" sz="1550" i="1" dirty="0">
+              <a:rPr lang="ar-SA" altLang="en-US" i="1" dirty="0">
                 <a:solidFill>
                   <a:srgbClr val="0A3540"/>
                 </a:solidFill>
-                <a:latin typeface="Arial" pitchFamily="34" charset="0"/>
-                <a:ea typeface="Arial" pitchFamily="34" charset="-122"/>
-                <a:cs typeface="Arial" pitchFamily="34" charset="-120"/>
+                <a:latin typeface="Dubai" panose="020B0503030403030204" pitchFamily="34" charset="-78"/>
+                <a:ea typeface="Arial" pitchFamily="34" charset="-122"/>
+                <a:cs typeface="Dubai" panose="020B0503030403030204" pitchFamily="34" charset="-78"/>
               </a:rPr>
               <a:t>‏ طريقة كتابة البيانات الصحية وتبادلها بين الأنظمة على اختلافها.</a:t>
             </a:r>
-            <a:endParaRPr lang="ar-SA" sz="1550" dirty="0"/>
+            <a:endParaRPr lang="ar-SA" dirty="0">
+              <a:latin typeface="Dubai" panose="020B0503030403030204" pitchFamily="34" charset="-78"/>
+              <a:cs typeface="Dubai" panose="020B0503030403030204" pitchFamily="34" charset="-78"/>
+            </a:endParaRPr>
           </a:p>
         </p:txBody>
       </p:sp>
@@ -13160,17 +17267,20 @@
               <a:buNone/>
             </a:pPr>
             <a:r>
-              <a:rPr lang="ar-SA" altLang="en-US" sz="1800" b="1" dirty="0">
+              <a:rPr lang="en-US" altLang="en-US" sz="1800" b="1" dirty="0">
                 <a:solidFill>
                   <a:srgbClr val="FFFFFF"/>
                 </a:solidFill>
-                <a:latin typeface="Arial" pitchFamily="34" charset="0"/>
-                <a:ea typeface="Arial" pitchFamily="34" charset="-122"/>
-                <a:cs typeface="Arial" pitchFamily="34" charset="-120"/>
-              </a:rPr>
-              <a:t>١</a:t>
-            </a:r>
-            <a:endParaRPr lang="ar-SA" sz="1800" dirty="0"/>
+                <a:latin typeface="Dubai" panose="020B0503030403030204" pitchFamily="34" charset="-78"/>
+                <a:ea typeface="Arial" pitchFamily="34" charset="-122"/>
+                <a:cs typeface="Dubai" panose="020B0503030403030204" pitchFamily="34" charset="-78"/>
+              </a:rPr>
+              <a:t>1</a:t>
+            </a:r>
+            <a:endParaRPr lang="ar-SA" sz="1800" dirty="0">
+              <a:latin typeface="Dubai" panose="020B0503030403030204" pitchFamily="34" charset="-78"/>
+              <a:cs typeface="Dubai" panose="020B0503030403030204" pitchFamily="34" charset="-78"/>
+            </a:endParaRPr>
           </a:p>
         </p:txBody>
       </p:sp>
@@ -13199,17 +17309,20 @@
               <a:buNone/>
             </a:pPr>
             <a:r>
-              <a:rPr lang="ar-SA" altLang="en-US" sz="1650" b="1" dirty="0">
+              <a:rPr lang="ar-SA" altLang="en-US" sz="2000" b="1" dirty="0">
                 <a:solidFill>
                   <a:srgbClr val="0A3540"/>
                 </a:solidFill>
-                <a:latin typeface="Arial" pitchFamily="34" charset="0"/>
-                <a:ea typeface="Arial" pitchFamily="34" charset="-122"/>
-                <a:cs typeface="Arial" pitchFamily="34" charset="-120"/>
+                <a:latin typeface="Dubai" panose="020B0503030403030204" pitchFamily="34" charset="-78"/>
+                <a:ea typeface="Arial" pitchFamily="34" charset="-122"/>
+                <a:cs typeface="Dubai" panose="020B0503030403030204" pitchFamily="34" charset="-78"/>
               </a:rPr>
               <a:t>لغة واحدة</a:t>
             </a:r>
-            <a:endParaRPr lang="ar-SA" sz="1650" dirty="0"/>
+            <a:endParaRPr lang="ar-SA" sz="2000" dirty="0">
+              <a:latin typeface="Dubai" panose="020B0503030403030204" pitchFamily="34" charset="-78"/>
+              <a:cs typeface="Dubai" panose="020B0503030403030204" pitchFamily="34" charset="-78"/>
+            </a:endParaRPr>
           </a:p>
         </p:txBody>
       </p:sp>
@@ -13241,17 +17354,20 @@
               <a:buNone/>
             </a:pPr>
             <a:r>
-              <a:rPr lang="ar-SA" altLang="en-US" sz="1250" dirty="0">
+              <a:rPr lang="ar-SA" altLang="en-US" sz="1600" dirty="0">
                 <a:solidFill>
                   <a:srgbClr val="587078"/>
                 </a:solidFill>
-                <a:latin typeface="Arial" pitchFamily="34" charset="0"/>
-                <a:ea typeface="Arial" pitchFamily="34" charset="-122"/>
-                <a:cs typeface="Arial" pitchFamily="34" charset="-120"/>
+                <a:latin typeface="Dubai" panose="020B0503030403030204" pitchFamily="34" charset="-78"/>
+                <a:ea typeface="Arial" pitchFamily="34" charset="-122"/>
+                <a:cs typeface="Dubai" panose="020B0503030403030204" pitchFamily="34" charset="-78"/>
               </a:rPr>
               <a:t>كلّ تشخيصٍ وتحليلٍ ودواءٍ يُكتب بصيغة قياسية واحدة يفهمها أيّ نظامٍ صحي حديث في العالم.</a:t>
             </a:r>
-            <a:endParaRPr lang="ar-SA" sz="1250" dirty="0"/>
+            <a:endParaRPr lang="ar-SA" sz="1600" dirty="0">
+              <a:latin typeface="Dubai" panose="020B0503030403030204" pitchFamily="34" charset="-78"/>
+              <a:cs typeface="Dubai" panose="020B0503030403030204" pitchFamily="34" charset="-78"/>
+            </a:endParaRPr>
           </a:p>
         </p:txBody>
       </p:sp>
@@ -13327,17 +17443,20 @@
               <a:buNone/>
             </a:pPr>
             <a:r>
-              <a:rPr lang="ar-SA" altLang="en-US" sz="1800" b="1" dirty="0">
+              <a:rPr lang="en-US" altLang="en-US" sz="1800" b="1" dirty="0">
                 <a:solidFill>
                   <a:srgbClr val="FFFFFF"/>
                 </a:solidFill>
-                <a:latin typeface="Arial" pitchFamily="34" charset="0"/>
-                <a:ea typeface="Arial" pitchFamily="34" charset="-122"/>
-                <a:cs typeface="Arial" pitchFamily="34" charset="-120"/>
-              </a:rPr>
-              <a:t>٢</a:t>
-            </a:r>
-            <a:endParaRPr lang="ar-SA" sz="1800" dirty="0"/>
+                <a:latin typeface="Dubai" panose="020B0503030403030204" pitchFamily="34" charset="-78"/>
+                <a:ea typeface="Arial" pitchFamily="34" charset="-122"/>
+                <a:cs typeface="Dubai" panose="020B0503030403030204" pitchFamily="34" charset="-78"/>
+              </a:rPr>
+              <a:t>2</a:t>
+            </a:r>
+            <a:endParaRPr lang="ar-SA" sz="1800" dirty="0">
+              <a:latin typeface="Dubai" panose="020B0503030403030204" pitchFamily="34" charset="-78"/>
+              <a:cs typeface="Dubai" panose="020B0503030403030204" pitchFamily="34" charset="-78"/>
+            </a:endParaRPr>
           </a:p>
         </p:txBody>
       </p:sp>
@@ -13366,17 +17485,20 @@
               <a:buNone/>
             </a:pPr>
             <a:r>
-              <a:rPr lang="ar-SA" altLang="en-US" sz="1650" b="1" dirty="0">
+              <a:rPr lang="ar-SA" altLang="en-US" sz="2000" b="1" dirty="0">
                 <a:solidFill>
                   <a:srgbClr val="0A3540"/>
                 </a:solidFill>
-                <a:latin typeface="Arial" pitchFamily="34" charset="0"/>
-                <a:ea typeface="Arial" pitchFamily="34" charset="-122"/>
-                <a:cs typeface="Arial" pitchFamily="34" charset="-120"/>
+                <a:latin typeface="Dubai" panose="020B0503030403030204" pitchFamily="34" charset="-78"/>
+                <a:ea typeface="Arial" pitchFamily="34" charset="-122"/>
+                <a:cs typeface="Dubai" panose="020B0503030403030204" pitchFamily="34" charset="-78"/>
               </a:rPr>
               <a:t>ذاكرة كاملة</a:t>
             </a:r>
-            <a:endParaRPr lang="ar-SA" sz="1650" dirty="0"/>
+            <a:endParaRPr lang="ar-SA" sz="2000" dirty="0">
+              <a:latin typeface="Dubai" panose="020B0503030403030204" pitchFamily="34" charset="-78"/>
+              <a:cs typeface="Dubai" panose="020B0503030403030204" pitchFamily="34" charset="-78"/>
+            </a:endParaRPr>
           </a:p>
         </p:txBody>
       </p:sp>
@@ -13408,17 +17530,20 @@
               <a:buNone/>
             </a:pPr>
             <a:r>
-              <a:rPr lang="ar-SA" altLang="en-US" sz="1250" dirty="0">
+              <a:rPr lang="ar-SA" altLang="en-US" sz="1600" dirty="0">
                 <a:solidFill>
                   <a:srgbClr val="587078"/>
                 </a:solidFill>
-                <a:latin typeface="Arial" pitchFamily="34" charset="0"/>
-                <a:ea typeface="Arial" pitchFamily="34" charset="-122"/>
-                <a:cs typeface="Arial" pitchFamily="34" charset="-120"/>
+                <a:latin typeface="Dubai" panose="020B0503030403030204" pitchFamily="34" charset="-78"/>
+                <a:ea typeface="Arial" pitchFamily="34" charset="-122"/>
+                <a:cs typeface="Dubai" panose="020B0503030403030204" pitchFamily="34" charset="-78"/>
               </a:rPr>
               <a:t>كلّ تعديلٍ على الملف محفوظ بنسخته وتاريخه وصاحبه — فلا يضيع شيء، ويمكن دائماً معرفة من غيّر وماذا.</a:t>
             </a:r>
-            <a:endParaRPr lang="ar-SA" sz="1250" dirty="0"/>
+            <a:endParaRPr lang="ar-SA" sz="1600" dirty="0">
+              <a:latin typeface="Dubai" panose="020B0503030403030204" pitchFamily="34" charset="-78"/>
+              <a:cs typeface="Dubai" panose="020B0503030403030204" pitchFamily="34" charset="-78"/>
+            </a:endParaRPr>
           </a:p>
         </p:txBody>
       </p:sp>
@@ -13468,6 +17593,13 @@
           </a:solidFill>
           <a:ln/>
         </p:spPr>
+        <p:txBody>
+          <a:bodyPr/>
+          <a:lstStyle/>
+          <a:p>
+            <a:endParaRPr lang="en-US" dirty="0"/>
+          </a:p>
+        </p:txBody>
       </p:sp>
       <p:sp>
         <p:nvSpPr>
@@ -13494,17 +17626,20 @@
               <a:buNone/>
             </a:pPr>
             <a:r>
-              <a:rPr lang="ar-SA" altLang="en-US" sz="1800" b="1" dirty="0">
+              <a:rPr lang="en-US" altLang="en-US" sz="1800" b="1" dirty="0">
                 <a:solidFill>
                   <a:srgbClr val="0A3540"/>
                 </a:solidFill>
-                <a:latin typeface="Arial" pitchFamily="34" charset="0"/>
-                <a:ea typeface="Arial" pitchFamily="34" charset="-122"/>
-                <a:cs typeface="Arial" pitchFamily="34" charset="-120"/>
-              </a:rPr>
-              <a:t>٣</a:t>
-            </a:r>
-            <a:endParaRPr lang="ar-SA" sz="1800" dirty="0"/>
+                <a:latin typeface="Dubai" panose="020B0503030403030204" pitchFamily="34" charset="-78"/>
+                <a:ea typeface="Arial" pitchFamily="34" charset="-122"/>
+                <a:cs typeface="Dubai" panose="020B0503030403030204" pitchFamily="34" charset="-78"/>
+              </a:rPr>
+              <a:t>3</a:t>
+            </a:r>
+            <a:endParaRPr lang="ar-SA" sz="1800" dirty="0">
+              <a:latin typeface="Dubai" panose="020B0503030403030204" pitchFamily="34" charset="-78"/>
+              <a:cs typeface="Dubai" panose="020B0503030403030204" pitchFamily="34" charset="-78"/>
+            </a:endParaRPr>
           </a:p>
         </p:txBody>
       </p:sp>
@@ -13533,17 +17668,20 @@
               <a:buNone/>
             </a:pPr>
             <a:r>
-              <a:rPr lang="ar-SA" altLang="en-US" sz="1650" b="1" dirty="0">
+              <a:rPr lang="ar-SA" altLang="en-US" sz="2000" b="1" dirty="0">
                 <a:solidFill>
                   <a:srgbClr val="0A3540"/>
                 </a:solidFill>
-                <a:latin typeface="Arial" pitchFamily="34" charset="0"/>
-                <a:ea typeface="Arial" pitchFamily="34" charset="-122"/>
-                <a:cs typeface="Arial" pitchFamily="34" charset="-120"/>
+                <a:latin typeface="Dubai" panose="020B0503030403030204" pitchFamily="34" charset="-78"/>
+                <a:ea typeface="Arial" pitchFamily="34" charset="-122"/>
+                <a:cs typeface="Dubai" panose="020B0503030403030204" pitchFamily="34" charset="-78"/>
               </a:rPr>
               <a:t>جاهز للربط</a:t>
             </a:r>
-            <a:endParaRPr lang="ar-SA" sz="1650" dirty="0"/>
+            <a:endParaRPr lang="ar-SA" sz="2000" dirty="0">
+              <a:latin typeface="Dubai" panose="020B0503030403030204" pitchFamily="34" charset="-78"/>
+              <a:cs typeface="Dubai" panose="020B0503030403030204" pitchFamily="34" charset="-78"/>
+            </a:endParaRPr>
           </a:p>
         </p:txBody>
       </p:sp>
@@ -13575,17 +17713,20 @@
               <a:buNone/>
             </a:pPr>
             <a:r>
-              <a:rPr lang="ar-SA" altLang="en-US" sz="1250" dirty="0">
+              <a:rPr lang="ar-SA" altLang="en-US" sz="1600" dirty="0">
                 <a:solidFill>
                   <a:srgbClr val="587078"/>
                 </a:solidFill>
-                <a:latin typeface="Arial" pitchFamily="34" charset="0"/>
-                <a:ea typeface="Arial" pitchFamily="34" charset="-122"/>
-                <a:cs typeface="Arial" pitchFamily="34" charset="-120"/>
+                <a:latin typeface="Dubai" panose="020B0503030403030204" pitchFamily="34" charset="-78"/>
+                <a:ea typeface="Arial" pitchFamily="34" charset="-122"/>
+                <a:cs typeface="Dubai" panose="020B0503030403030204" pitchFamily="34" charset="-78"/>
               </a:rPr>
               <a:t>لأنّ نظامنا يتكلّم اللغة نفسها، يستطيع غداً تبادل الملفات مع أيّ مشفى أو نظامٍ يعتمد المعيار ذاته.</a:t>
             </a:r>
-            <a:endParaRPr lang="ar-SA" sz="1250" dirty="0"/>
+            <a:endParaRPr lang="ar-SA" sz="1600" dirty="0">
+              <a:latin typeface="Dubai" panose="020B0503030403030204" pitchFamily="34" charset="-78"/>
+              <a:cs typeface="Dubai" panose="020B0503030403030204" pitchFamily="34" charset="-78"/>
+            </a:endParaRPr>
           </a:p>
         </p:txBody>
       </p:sp>
@@ -13594,6 +17735,9 @@
   <p:clrMapOvr>
     <a:masterClrMapping/>
   </p:clrMapOvr>
+  <p:transition spd="slow">
+    <p:wipe dir="r"/>
+  </p:transition>
 </p:sld>
 </file>
 
@@ -14365,6 +18509,9 @@
   <p:clrMapOvr>
     <a:masterClrMapping/>
   </p:clrMapOvr>
+  <p:transition spd="slow">
+    <p:wipe dir="r"/>
+  </p:transition>
 </p:sld>
 </file>
 
@@ -15221,6 +19368,9 @@
   <p:clrMapOvr>
     <a:masterClrMapping/>
   </p:clrMapOvr>
+  <p:transition spd="slow">
+    <p:wipe dir="r"/>
+  </p:transition>
 </p:sld>
 </file>
 

</xml_diff>